<commit_message>
docs: update presentation slides
Co-Authored-By: Claude Opus 4.6 <noreply@anthropic.com>
</commit_message>
<xml_diff>
--- a/docs/05-soutenance/MSPR_NordTransit_Presentation.pptx
+++ b/docs/05-soutenance/MSPR_NordTransit_Presentation.pptx
@@ -5,7 +5,7 @@
     <p:sldMasterId id="2147483648" r:id="rId1"/>
   </p:sldMasterIdLst>
   <p:notesMasterIdLst>
-    <p:notesMasterId r:id="rId13"/>
+    <p:notesMasterId r:id="rId14"/>
   </p:notesMasterIdLst>
   <p:sldIdLst>
     <p:sldId id="256" r:id="rId2"/>
@@ -19,6 +19,7 @@
     <p:sldId id="264" r:id="rId10"/>
     <p:sldId id="265" r:id="rId11"/>
     <p:sldId id="266" r:id="rId12"/>
+    <p:sldId id="267" r:id="rId13"/>
   </p:sldIdLst>
   <p:sldSz cx="9144000" cy="5143500" type="screen16x9"/>
   <p:notesSz cx="5143500" cy="9144000"/>
@@ -161,15 +162,9 @@
             <c:idx val="0"/>
             <c:invertIfNegative val="0"/>
             <c:bubble3D val="0"/>
-            <c:spPr>
-              <a:solidFill>
-                <a:srgbClr val="0F1B2D"/>
-              </a:solidFill>
-              <a:effectLst/>
-            </c:spPr>
             <c:extLst>
               <c:ext xmlns:c16="http://schemas.microsoft.com/office/drawing/2014/chart" uri="{C3380CC4-5D6E-409C-BE32-E72D297353CC}">
-                <c16:uniqueId val="{00000001-E679-4DFB-8D67-6DCE4507CC6D}"/>
+                <c16:uniqueId val="{00000001-1CF2-41DD-B408-19671E8AB0D4}"/>
               </c:ext>
             </c:extLst>
           </c:dPt>
@@ -185,7 +180,7 @@
             </c:spPr>
             <c:extLst>
               <c:ext xmlns:c16="http://schemas.microsoft.com/office/drawing/2014/chart" uri="{C3380CC4-5D6E-409C-BE32-E72D297353CC}">
-                <c16:uniqueId val="{00000003-E679-4DFB-8D67-6DCE4507CC6D}"/>
+                <c16:uniqueId val="{00000003-1CF2-41DD-B408-19671E8AB0D4}"/>
               </c:ext>
             </c:extLst>
           </c:dPt>
@@ -201,7 +196,7 @@
             </c:spPr>
             <c:extLst>
               <c:ext xmlns:c16="http://schemas.microsoft.com/office/drawing/2014/chart" uri="{C3380CC4-5D6E-409C-BE32-E72D297353CC}">
-                <c16:uniqueId val="{00000005-E679-4DFB-8D67-6DCE4507CC6D}"/>
+                <c16:uniqueId val="{00000005-1CF2-41DD-B408-19671E8AB0D4}"/>
               </c:ext>
             </c:extLst>
           </c:dPt>
@@ -217,7 +212,7 @@
             </c:spPr>
             <c:extLst>
               <c:ext xmlns:c16="http://schemas.microsoft.com/office/drawing/2014/chart" uri="{C3380CC4-5D6E-409C-BE32-E72D297353CC}">
-                <c16:uniqueId val="{00000007-E679-4DFB-8D67-6DCE4507CC6D}"/>
+                <c16:uniqueId val="{00000007-1CF2-41DD-B408-19671E8AB0D4}"/>
               </c:ext>
             </c:extLst>
           </c:dPt>
@@ -233,7 +228,7 @@
             </c:spPr>
             <c:extLst>
               <c:ext xmlns:c16="http://schemas.microsoft.com/office/drawing/2014/chart" uri="{C3380CC4-5D6E-409C-BE32-E72D297353CC}">
-                <c16:uniqueId val="{00000009-E679-4DFB-8D67-6DCE4507CC6D}"/>
+                <c16:uniqueId val="{00000009-1CF2-41DD-B408-19671E8AB0D4}"/>
               </c:ext>
             </c:extLst>
           </c:dPt>
@@ -249,7 +244,7 @@
             </c:spPr>
             <c:extLst>
               <c:ext xmlns:c16="http://schemas.microsoft.com/office/drawing/2014/chart" uri="{C3380CC4-5D6E-409C-BE32-E72D297353CC}">
-                <c16:uniqueId val="{0000000B-E679-4DFB-8D67-6DCE4507CC6D}"/>
+                <c16:uniqueId val="{0000000B-1CF2-41DD-B408-19671E8AB0D4}"/>
               </c:ext>
             </c:extLst>
           </c:dPt>
@@ -265,7 +260,7 @@
             </c:spPr>
             <c:extLst>
               <c:ext xmlns:c16="http://schemas.microsoft.com/office/drawing/2014/chart" uri="{C3380CC4-5D6E-409C-BE32-E72D297353CC}">
-                <c16:uniqueId val="{0000000D-E679-4DFB-8D67-6DCE4507CC6D}"/>
+                <c16:uniqueId val="{0000000D-1CF2-41DD-B408-19671E8AB0D4}"/>
               </c:ext>
             </c:extLst>
           </c:dPt>
@@ -281,7 +276,7 @@
             </c:spPr>
             <c:extLst>
               <c:ext xmlns:c16="http://schemas.microsoft.com/office/drawing/2014/chart" uri="{C3380CC4-5D6E-409C-BE32-E72D297353CC}">
-                <c16:uniqueId val="{0000000F-E679-4DFB-8D67-6DCE4507CC6D}"/>
+                <c16:uniqueId val="{0000000F-1CF2-41DD-B408-19671E8AB0D4}"/>
               </c:ext>
             </c:extLst>
           </c:dPt>
@@ -389,7 +384,7 @@
           </c:val>
           <c:extLst>
             <c:ext xmlns:c16="http://schemas.microsoft.com/office/drawing/2014/chart" uri="{C3380CC4-5D6E-409C-BE32-E72D297353CC}">
-              <c16:uniqueId val="{00000010-E679-4DFB-8D67-6DCE4507CC6D}"/>
+              <c16:uniqueId val="{00000010-1CF2-41DD-B408-19671E8AB0D4}"/>
             </c:ext>
           </c:extLst>
         </c:ser>
@@ -549,7 +544,7 @@
     </p:spTree>
     <p:extLst>
       <p:ext uri="{BB962C8B-B14F-4D97-AF65-F5344CB8AC3E}">
-        <p14:creationId xmlns:p14="http://schemas.microsoft.com/office/powerpoint/2010/main" val="1418425403"/>
+        <p14:creationId xmlns:p14="http://schemas.microsoft.com/office/powerpoint/2010/main" val="3019041510"/>
       </p:ext>
     </p:extLst>
   </p:cSld>
@@ -883,6 +878,90 @@
             <a:fld id="{F7021451-1387-4CA6-816F-3879F97B5CBC}" type="slidenum">
               <a:rPr lang="en-US"/>
               <a:t>11</a:t>
+            </a:fld>
+            <a:endParaRPr lang="en-US"/>
+          </a:p>
+        </p:txBody>
+      </p:sp>
+    </p:spTree>
+    <p:extLst>
+      <p:ext uri="{BB962C8B-B14F-4D97-AF65-F5344CB8AC3E}">
+        <p14:creationId xmlns:p14="http://schemas.microsoft.com/office/powerpoint/2010/main" val="1024086991"/>
+      </p:ext>
+    </p:extLst>
+  </p:cSld>
+  <p:clrMapOvr>
+    <a:masterClrMapping/>
+  </p:clrMapOvr>
+</p:notes>
+</file>
+
+<file path=ppt/notesSlides/notesSlide12.xml><?xml version="1.0" encoding="utf-8"?>
+<p:notes xmlns:a="http://schemas.openxmlformats.org/drawingml/2006/main" xmlns:r="http://schemas.openxmlformats.org/officeDocument/2006/relationships" xmlns:p="http://schemas.openxmlformats.org/presentationml/2006/main">
+  <p:cSld>
+    <p:spTree>
+      <p:nvGrpSpPr>
+        <p:cNvPr id="1" name=""/>
+        <p:cNvGrpSpPr/>
+        <p:nvPr/>
+      </p:nvGrpSpPr>
+      <p:grpSpPr>
+        <a:xfrm>
+          <a:off x="0" y="0"/>
+          <a:ext cx="0" cy="0"/>
+          <a:chOff x="0" y="0"/>
+          <a:chExt cx="0" cy="0"/>
+        </a:xfrm>
+      </p:grpSpPr>
+      <p:sp>
+        <p:nvSpPr>
+          <p:cNvPr id="2" name="Slide Image Placeholder 1"/>
+          <p:cNvSpPr>
+            <a:spLocks noGrp="1" noRot="1" noChangeAspect="1"/>
+          </p:cNvSpPr>
+          <p:nvPr>
+            <p:ph type="sldImg"/>
+          </p:nvPr>
+        </p:nvSpPr>
+        <p:spPr/>
+      </p:sp>
+      <p:sp>
+        <p:nvSpPr>
+          <p:cNvPr id="3" name="Notes Placeholder 2"/>
+          <p:cNvSpPr>
+            <a:spLocks noGrp="1"/>
+          </p:cNvSpPr>
+          <p:nvPr>
+            <p:ph type="body" idx="1"/>
+          </p:nvPr>
+        </p:nvSpPr>
+        <p:spPr/>
+        <p:txBody>
+          <a:bodyPr/>
+          <a:lstStyle/>
+          <a:p>
+            <a:endParaRPr lang="en-US" dirty="0"/>
+          </a:p>
+        </p:txBody>
+      </p:sp>
+      <p:sp>
+        <p:nvSpPr>
+          <p:cNvPr id="4" name="Slide Number Placeholder 3"/>
+          <p:cNvSpPr>
+            <a:spLocks noGrp="1"/>
+          </p:cNvSpPr>
+          <p:nvPr>
+            <p:ph type="sldNum" sz="quarter" idx="10"/>
+          </p:nvPr>
+        </p:nvSpPr>
+        <p:spPr/>
+        <p:txBody>
+          <a:bodyPr/>
+          <a:lstStyle/>
+          <a:p>
+            <a:fld id="{F7021451-1387-4CA6-816F-3879F97B5CBC}" type="slidenum">
+              <a:rPr lang="en-US"/>
+              <a:t>12</a:t>
             </a:fld>
             <a:endParaRPr lang="en-US"/>
           </a:p>
@@ -2121,8 +2200,8 @@
         </p:nvSpPr>
         <p:spPr>
           <a:xfrm>
-            <a:off x="731520" y="3611879"/>
-            <a:ext cx="7680960" cy="929343"/>
+            <a:off x="731520" y="3557517"/>
+            <a:ext cx="7680960" cy="1059966"/>
           </a:xfrm>
           <a:prstGeom prst="rect">
             <a:avLst/>
@@ -2137,19 +2216,17 @@
             <a:r>
               <a:rPr lang="fr-FR" sz="1200" b="1" dirty="0">
                 <a:solidFill>
-                  <a:schemeClr val="accent3">
-                    <a:lumMod val="20000"/>
-                    <a:lumOff val="80000"/>
+                  <a:schemeClr val="bg1">
+                    <a:lumMod val="75000"/>
                   </a:schemeClr>
                 </a:solidFill>
               </a:rPr>
-              <a:t>B3 ASRBD Groupe 2 : </a:t>
+              <a:t>B3 ASRBD Groupe 2 :</a:t>
             </a:r>
             <a:endParaRPr lang="fr-FR" sz="1200" dirty="0">
               <a:solidFill>
-                <a:schemeClr val="accent3">
-                  <a:lumMod val="20000"/>
-                  <a:lumOff val="80000"/>
+                <a:schemeClr val="bg1">
+                  <a:lumMod val="75000"/>
                 </a:schemeClr>
               </a:solidFill>
             </a:endParaRPr>
@@ -2158,9 +2235,8 @@
             <a:r>
               <a:rPr lang="fr-FR" sz="1200" b="1" dirty="0">
                 <a:solidFill>
-                  <a:schemeClr val="accent3">
-                    <a:lumMod val="20000"/>
-                    <a:lumOff val="80000"/>
+                  <a:schemeClr val="bg1">
+                    <a:lumMod val="75000"/>
                   </a:schemeClr>
                 </a:solidFill>
               </a:rPr>
@@ -2168,9 +2244,8 @@
             </a:r>
             <a:endParaRPr lang="fr-FR" sz="1200" dirty="0">
               <a:solidFill>
-                <a:schemeClr val="accent3">
-                  <a:lumMod val="20000"/>
-                  <a:lumOff val="80000"/>
+                <a:schemeClr val="bg1">
+                  <a:lumMod val="75000"/>
                 </a:schemeClr>
               </a:solidFill>
             </a:endParaRPr>
@@ -2179,9 +2254,8 @@
             <a:r>
               <a:rPr lang="fr-FR" sz="1200" b="1" dirty="0">
                 <a:solidFill>
-                  <a:schemeClr val="accent3">
-                    <a:lumMod val="20000"/>
-                    <a:lumOff val="80000"/>
+                  <a:schemeClr val="bg1">
+                    <a:lumMod val="75000"/>
                   </a:schemeClr>
                 </a:solidFill>
               </a:rPr>
@@ -2190,9 +2264,8 @@
             <a:r>
               <a:rPr lang="fr-FR" sz="1200" b="1" dirty="0" err="1">
                 <a:solidFill>
-                  <a:schemeClr val="accent3">
-                    <a:lumMod val="20000"/>
-                    <a:lumOff val="80000"/>
+                  <a:schemeClr val="bg1">
+                    <a:lumMod val="75000"/>
                   </a:schemeClr>
                 </a:solidFill>
               </a:rPr>
@@ -2200,9 +2273,8 @@
             </a:r>
             <a:endParaRPr lang="fr-FR" sz="1200" dirty="0">
               <a:solidFill>
-                <a:schemeClr val="accent3">
-                  <a:lumMod val="20000"/>
-                  <a:lumOff val="80000"/>
+                <a:schemeClr val="bg1">
+                  <a:lumMod val="75000"/>
                 </a:schemeClr>
               </a:solidFill>
             </a:endParaRPr>
@@ -2211,9 +2283,8 @@
             <a:r>
               <a:rPr lang="fr-FR" sz="1200" b="1" dirty="0">
                 <a:solidFill>
-                  <a:schemeClr val="accent3">
-                    <a:lumMod val="20000"/>
-                    <a:lumOff val="80000"/>
+                  <a:schemeClr val="bg1">
+                    <a:lumMod val="75000"/>
                   </a:schemeClr>
                 </a:solidFill>
               </a:rPr>
@@ -2222,9 +2293,8 @@
             <a:r>
               <a:rPr lang="fr-FR" sz="1200" b="1" dirty="0" err="1">
                 <a:solidFill>
-                  <a:schemeClr val="accent3">
-                    <a:lumMod val="20000"/>
-                    <a:lumOff val="80000"/>
+                  <a:schemeClr val="bg1">
+                    <a:lumMod val="75000"/>
                   </a:schemeClr>
                 </a:solidFill>
               </a:rPr>
@@ -2232,9 +2302,8 @@
             </a:r>
             <a:endParaRPr lang="fr-FR" sz="1200" dirty="0">
               <a:solidFill>
-                <a:schemeClr val="accent3">
-                  <a:lumMod val="20000"/>
-                  <a:lumOff val="80000"/>
+                <a:schemeClr val="bg1">
+                  <a:lumMod val="75000"/>
                 </a:schemeClr>
               </a:solidFill>
             </a:endParaRPr>
@@ -2243,9 +2312,8 @@
             <a:r>
               <a:rPr lang="fr-FR" sz="1200" b="1" dirty="0">
                 <a:solidFill>
-                  <a:schemeClr val="accent3">
-                    <a:lumMod val="20000"/>
-                    <a:lumOff val="80000"/>
+                  <a:schemeClr val="bg1">
+                    <a:lumMod val="75000"/>
                   </a:schemeClr>
                 </a:solidFill>
               </a:rPr>
@@ -2253,9 +2321,8 @@
             </a:r>
             <a:endParaRPr lang="fr-FR" sz="1200" dirty="0">
               <a:solidFill>
-                <a:schemeClr val="accent3">
-                  <a:lumMod val="20000"/>
-                  <a:lumOff val="80000"/>
+                <a:schemeClr val="bg1">
+                  <a:lumMod val="75000"/>
                 </a:schemeClr>
               </a:solidFill>
             </a:endParaRPr>
@@ -2264,9 +2331,8 @@
             <a:r>
               <a:rPr lang="fr-FR" sz="1200" b="1" dirty="0">
                 <a:solidFill>
-                  <a:schemeClr val="accent3">
-                    <a:lumMod val="20000"/>
-                    <a:lumOff val="80000"/>
+                  <a:schemeClr val="bg1">
+                    <a:lumMod val="75000"/>
                   </a:schemeClr>
                 </a:solidFill>
               </a:rPr>
@@ -2274,12 +2340,50 @@
             </a:r>
             <a:endParaRPr lang="en-US" sz="1200" dirty="0">
               <a:solidFill>
-                <a:schemeClr val="accent3">
-                  <a:lumMod val="20000"/>
-                  <a:lumOff val="80000"/>
+                <a:schemeClr val="bg1">
+                  <a:lumMod val="75000"/>
                 </a:schemeClr>
               </a:solidFill>
             </a:endParaRPr>
+          </a:p>
+        </p:txBody>
+      </p:sp>
+      <p:sp>
+        <p:nvSpPr>
+          <p:cNvPr id="9" name="Text 7"/>
+          <p:cNvSpPr/>
+          <p:nvPr/>
+        </p:nvSpPr>
+        <p:spPr>
+          <a:xfrm>
+            <a:off x="731520" y="4682774"/>
+            <a:ext cx="7680960" cy="365760"/>
+          </a:xfrm>
+          <a:prstGeom prst="rect">
+            <a:avLst/>
+          </a:prstGeom>
+          <a:noFill/>
+          <a:ln/>
+        </p:spPr>
+        <p:txBody>
+          <a:bodyPr wrap="square" lIns="0" tIns="0" rIns="0" bIns="0" rtlCol="0" anchor="ctr"/>
+          <a:lstStyle/>
+          <a:p>
+            <a:pPr marL="0" indent="0">
+              <a:buNone/>
+            </a:pPr>
+            <a:r>
+              <a:rPr lang="en-US" sz="1300" dirty="0">
+                <a:solidFill>
+                  <a:srgbClr val="94A3B8"/>
+                </a:solidFill>
+                <a:latin typeface="Calibri" pitchFamily="34" charset="0"/>
+                <a:ea typeface="Calibri" pitchFamily="34" charset="-122"/>
+                <a:cs typeface="Calibri" pitchFamily="34" charset="-120"/>
+              </a:rPr>
+              <a:t>Février 2026</a:t>
+            </a:r>
+            <a:endParaRPr lang="en-US" sz="1300" dirty="0"/>
           </a:p>
         </p:txBody>
       </p:sp>
@@ -2351,6 +2455,2892 @@
         </p:nvSpPr>
         <p:spPr>
           <a:xfrm>
+            <a:off x="640080" y="228600"/>
+            <a:ext cx="7863840" cy="502920"/>
+          </a:xfrm>
+          <a:prstGeom prst="rect">
+            <a:avLst/>
+          </a:prstGeom>
+          <a:noFill/>
+          <a:ln/>
+        </p:spPr>
+        <p:txBody>
+          <a:bodyPr wrap="square" lIns="0" tIns="0" rIns="0" bIns="0" rtlCol="0" anchor="ctr"/>
+          <a:lstStyle/>
+          <a:p>
+            <a:pPr marL="0" indent="0">
+              <a:buNone/>
+            </a:pPr>
+            <a:r>
+              <a:rPr lang="en-US" sz="3000" b="1" dirty="0">
+                <a:solidFill>
+                  <a:srgbClr val="0F1B2D"/>
+                </a:solidFill>
+                <a:latin typeface="Trebuchet MS" pitchFamily="34" charset="0"/>
+                <a:ea typeface="Trebuchet MS" pitchFamily="34" charset="-122"/>
+                <a:cs typeface="Trebuchet MS" pitchFamily="34" charset="-120"/>
+              </a:rPr>
+              <a:t>Stratégie de migration</a:t>
+            </a:r>
+            <a:endParaRPr lang="en-US" sz="3000" dirty="0"/>
+          </a:p>
+        </p:txBody>
+      </p:sp>
+      <p:sp>
+        <p:nvSpPr>
+          <p:cNvPr id="4" name="Text 2"/>
+          <p:cNvSpPr/>
+          <p:nvPr/>
+        </p:nvSpPr>
+        <p:spPr>
+          <a:xfrm>
+            <a:off x="640080" y="685800"/>
+            <a:ext cx="7863840" cy="274320"/>
+          </a:xfrm>
+          <a:prstGeom prst="rect">
+            <a:avLst/>
+          </a:prstGeom>
+          <a:noFill/>
+          <a:ln/>
+        </p:spPr>
+        <p:txBody>
+          <a:bodyPr wrap="square" lIns="0" tIns="0" rIns="0" bIns="0" rtlCol="0" anchor="ctr"/>
+          <a:lstStyle/>
+          <a:p>
+            <a:pPr marL="0" indent="0">
+              <a:buNone/>
+            </a:pPr>
+            <a:r>
+              <a:rPr lang="en-US" sz="1200" i="1" dirty="0">
+                <a:solidFill>
+                  <a:srgbClr val="334155"/>
+                </a:solidFill>
+                <a:latin typeface="Calibri" pitchFamily="34" charset="0"/>
+                <a:ea typeface="Calibri" pitchFamily="34" charset="-122"/>
+                <a:cs typeface="Calibri" pitchFamily="34" charset="-120"/>
+              </a:rPr>
+              <a:t>6 phases sur 6 semaines — migrations nocturnes — rollback à chaque étape</a:t>
+            </a:r>
+            <a:endParaRPr lang="en-US" sz="1200" dirty="0"/>
+          </a:p>
+        </p:txBody>
+      </p:sp>
+      <p:sp>
+        <p:nvSpPr>
+          <p:cNvPr id="5" name="Shape 3"/>
+          <p:cNvSpPr/>
+          <p:nvPr/>
+        </p:nvSpPr>
+        <p:spPr>
+          <a:xfrm>
+            <a:off x="365760" y="1097280"/>
+            <a:ext cx="4160520" cy="914400"/>
+          </a:xfrm>
+          <a:prstGeom prst="rect">
+            <a:avLst/>
+          </a:prstGeom>
+          <a:solidFill>
+            <a:srgbClr val="FFFFFF"/>
+          </a:solidFill>
+          <a:ln/>
+          <a:effectLst>
+            <a:outerShdw blurRad="50800" dist="25400" dir="8100000" algn="bl" rotWithShape="0">
+              <a:srgbClr val="000000">
+                <a:alpha val="12000"/>
+              </a:srgbClr>
+            </a:outerShdw>
+          </a:effectLst>
+        </p:spPr>
+        <p:txBody>
+          <a:bodyPr/>
+          <a:lstStyle/>
+          <a:p>
+            <a:endParaRPr lang="fr-FR"/>
+          </a:p>
+        </p:txBody>
+      </p:sp>
+      <p:sp>
+        <p:nvSpPr>
+          <p:cNvPr id="6" name="Shape 4"/>
+          <p:cNvSpPr/>
+          <p:nvPr/>
+        </p:nvSpPr>
+        <p:spPr>
+          <a:xfrm>
+            <a:off x="365760" y="1097280"/>
+            <a:ext cx="45720" cy="914400"/>
+          </a:xfrm>
+          <a:prstGeom prst="rect">
+            <a:avLst/>
+          </a:prstGeom>
+          <a:solidFill>
+            <a:srgbClr val="F97316"/>
+          </a:solidFill>
+          <a:ln/>
+        </p:spPr>
+        <p:txBody>
+          <a:bodyPr/>
+          <a:lstStyle/>
+          <a:p>
+            <a:endParaRPr lang="fr-FR"/>
+          </a:p>
+        </p:txBody>
+      </p:sp>
+      <p:sp>
+        <p:nvSpPr>
+          <p:cNvPr id="7" name="Shape 5"/>
+          <p:cNvSpPr/>
+          <p:nvPr/>
+        </p:nvSpPr>
+        <p:spPr>
+          <a:xfrm>
+            <a:off x="530352" y="1207008"/>
+            <a:ext cx="502920" cy="320040"/>
+          </a:xfrm>
+          <a:prstGeom prst="rect">
+            <a:avLst/>
+          </a:prstGeom>
+          <a:solidFill>
+            <a:srgbClr val="1A2744"/>
+          </a:solidFill>
+          <a:ln/>
+        </p:spPr>
+        <p:txBody>
+          <a:bodyPr/>
+          <a:lstStyle/>
+          <a:p>
+            <a:endParaRPr lang="fr-FR"/>
+          </a:p>
+        </p:txBody>
+      </p:sp>
+      <p:sp>
+        <p:nvSpPr>
+          <p:cNvPr id="8" name="Text 6"/>
+          <p:cNvSpPr/>
+          <p:nvPr/>
+        </p:nvSpPr>
+        <p:spPr>
+          <a:xfrm>
+            <a:off x="530352" y="1207008"/>
+            <a:ext cx="502920" cy="320040"/>
+          </a:xfrm>
+          <a:prstGeom prst="rect">
+            <a:avLst/>
+          </a:prstGeom>
+          <a:noFill/>
+          <a:ln/>
+        </p:spPr>
+        <p:txBody>
+          <a:bodyPr wrap="square" rtlCol="0" anchor="ctr"/>
+          <a:lstStyle/>
+          <a:p>
+            <a:pPr marL="0" indent="0" algn="ctr">
+              <a:buNone/>
+            </a:pPr>
+            <a:r>
+              <a:rPr lang="en-US" sz="1200" b="1" dirty="0">
+                <a:solidFill>
+                  <a:srgbClr val="FFFFFF"/>
+                </a:solidFill>
+                <a:latin typeface="Calibri" pitchFamily="34" charset="0"/>
+                <a:ea typeface="Calibri" pitchFamily="34" charset="-122"/>
+                <a:cs typeface="Calibri" pitchFamily="34" charset="-120"/>
+              </a:rPr>
+              <a:t>M1</a:t>
+            </a:r>
+            <a:endParaRPr lang="en-US" sz="1200" dirty="0"/>
+          </a:p>
+        </p:txBody>
+      </p:sp>
+      <p:sp>
+        <p:nvSpPr>
+          <p:cNvPr id="9" name="Text 7"/>
+          <p:cNvSpPr/>
+          <p:nvPr/>
+        </p:nvSpPr>
+        <p:spPr>
+          <a:xfrm>
+            <a:off x="1143000" y="1152144"/>
+            <a:ext cx="2011680" cy="228600"/>
+          </a:xfrm>
+          <a:prstGeom prst="rect">
+            <a:avLst/>
+          </a:prstGeom>
+          <a:noFill/>
+          <a:ln/>
+        </p:spPr>
+        <p:txBody>
+          <a:bodyPr wrap="square" lIns="0" tIns="0" rIns="0" bIns="0" rtlCol="0" anchor="ctr"/>
+          <a:lstStyle/>
+          <a:p>
+            <a:pPr marL="0" indent="0">
+              <a:buNone/>
+            </a:pPr>
+            <a:r>
+              <a:rPr lang="en-US" sz="1300" b="1" dirty="0">
+                <a:solidFill>
+                  <a:srgbClr val="0F1B2D"/>
+                </a:solidFill>
+                <a:latin typeface="Trebuchet MS" pitchFamily="34" charset="0"/>
+                <a:ea typeface="Trebuchet MS" pitchFamily="34" charset="-122"/>
+                <a:cs typeface="Trebuchet MS" pitchFamily="34" charset="-120"/>
+              </a:rPr>
+              <a:t>Pare-feu</a:t>
+            </a:r>
+            <a:endParaRPr lang="en-US" sz="1300" dirty="0"/>
+          </a:p>
+        </p:txBody>
+      </p:sp>
+      <p:sp>
+        <p:nvSpPr>
+          <p:cNvPr id="10" name="Text 8"/>
+          <p:cNvSpPr/>
+          <p:nvPr/>
+        </p:nvSpPr>
+        <p:spPr>
+          <a:xfrm>
+            <a:off x="1143000" y="1371600"/>
+            <a:ext cx="2743200" cy="201168"/>
+          </a:xfrm>
+          <a:prstGeom prst="rect">
+            <a:avLst/>
+          </a:prstGeom>
+          <a:noFill/>
+          <a:ln/>
+        </p:spPr>
+        <p:txBody>
+          <a:bodyPr wrap="square" lIns="0" tIns="0" rIns="0" bIns="0" rtlCol="0" anchor="ctr"/>
+          <a:lstStyle/>
+          <a:p>
+            <a:pPr marL="0" indent="0">
+              <a:buNone/>
+            </a:pPr>
+            <a:r>
+              <a:rPr lang="en-US" sz="900" dirty="0">
+                <a:solidFill>
+                  <a:srgbClr val="334155"/>
+                </a:solidFill>
+                <a:latin typeface="Calibri" pitchFamily="34" charset="0"/>
+                <a:ea typeface="Calibri" pitchFamily="34" charset="-122"/>
+                <a:cs typeface="Calibri" pitchFamily="34" charset="-120"/>
+              </a:rPr>
+              <a:t>Remplacement DrayTek/80D → FortiGate</a:t>
+            </a:r>
+            <a:endParaRPr lang="en-US" sz="900" dirty="0"/>
+          </a:p>
+        </p:txBody>
+      </p:sp>
+      <p:sp>
+        <p:nvSpPr>
+          <p:cNvPr id="11" name="Shape 9"/>
+          <p:cNvSpPr/>
+          <p:nvPr/>
+        </p:nvSpPr>
+        <p:spPr>
+          <a:xfrm>
+            <a:off x="3383280" y="1170432"/>
+            <a:ext cx="1005840" cy="274320"/>
+          </a:xfrm>
+          <a:prstGeom prst="rect">
+            <a:avLst/>
+          </a:prstGeom>
+          <a:solidFill>
+            <a:srgbClr val="F0F4F8"/>
+          </a:solidFill>
+          <a:ln/>
+        </p:spPr>
+        <p:txBody>
+          <a:bodyPr/>
+          <a:lstStyle/>
+          <a:p>
+            <a:endParaRPr lang="fr-FR"/>
+          </a:p>
+        </p:txBody>
+      </p:sp>
+      <p:sp>
+        <p:nvSpPr>
+          <p:cNvPr id="12" name="Text 10"/>
+          <p:cNvSpPr/>
+          <p:nvPr/>
+        </p:nvSpPr>
+        <p:spPr>
+          <a:xfrm>
+            <a:off x="3383280" y="1170432"/>
+            <a:ext cx="1005840" cy="274320"/>
+          </a:xfrm>
+          <a:prstGeom prst="rect">
+            <a:avLst/>
+          </a:prstGeom>
+          <a:noFill/>
+          <a:ln/>
+        </p:spPr>
+        <p:txBody>
+          <a:bodyPr wrap="square" rtlCol="0" anchor="ctr"/>
+          <a:lstStyle/>
+          <a:p>
+            <a:pPr marL="0" indent="0" algn="ctr">
+              <a:buNone/>
+            </a:pPr>
+            <a:r>
+              <a:rPr lang="en-US" sz="750" dirty="0">
+                <a:solidFill>
+                  <a:srgbClr val="0F1B2D"/>
+                </a:solidFill>
+                <a:latin typeface="Calibri" pitchFamily="34" charset="0"/>
+                <a:ea typeface="Calibri" pitchFamily="34" charset="-122"/>
+                <a:cs typeface="Calibri" pitchFamily="34" charset="-120"/>
+              </a:rPr>
+              <a:t>5 nuits (S1-S2)</a:t>
+            </a:r>
+            <a:endParaRPr lang="en-US" sz="750" dirty="0"/>
+          </a:p>
+        </p:txBody>
+      </p:sp>
+      <p:sp>
+        <p:nvSpPr>
+          <p:cNvPr id="13" name="Text 11"/>
+          <p:cNvSpPr/>
+          <p:nvPr/>
+        </p:nvSpPr>
+        <p:spPr>
+          <a:xfrm>
+            <a:off x="1143000" y="1627632"/>
+            <a:ext cx="3200400" cy="292608"/>
+          </a:xfrm>
+          <a:prstGeom prst="rect">
+            <a:avLst/>
+          </a:prstGeom>
+          <a:noFill/>
+          <a:ln/>
+        </p:spPr>
+        <p:txBody>
+          <a:bodyPr wrap="square" lIns="0" tIns="0" rIns="0" bIns="0" rtlCol="0" anchor="ctr"/>
+          <a:lstStyle/>
+          <a:p>
+            <a:pPr marL="0" indent="0">
+              <a:buNone/>
+            </a:pPr>
+            <a:r>
+              <a:rPr lang="en-US" sz="800" i="1" dirty="0">
+                <a:solidFill>
+                  <a:srgbClr val="94A3B8"/>
+                </a:solidFill>
+                <a:latin typeface="Calibri" pitchFamily="34" charset="0"/>
+                <a:ea typeface="Calibri" pitchFamily="34" charset="-122"/>
+                <a:cs typeface="Calibri" pitchFamily="34" charset="-120"/>
+              </a:rPr>
+              <a:t>↩ Rebrancher ancien équipement (~15 min)</a:t>
+            </a:r>
+            <a:endParaRPr lang="en-US" sz="800" dirty="0"/>
+          </a:p>
+        </p:txBody>
+      </p:sp>
+      <p:sp>
+        <p:nvSpPr>
+          <p:cNvPr id="14" name="Shape 12"/>
+          <p:cNvSpPr/>
+          <p:nvPr/>
+        </p:nvSpPr>
+        <p:spPr>
+          <a:xfrm>
+            <a:off x="4754880" y="1097280"/>
+            <a:ext cx="4160520" cy="914400"/>
+          </a:xfrm>
+          <a:prstGeom prst="rect">
+            <a:avLst/>
+          </a:prstGeom>
+          <a:solidFill>
+            <a:srgbClr val="FFFFFF"/>
+          </a:solidFill>
+          <a:ln/>
+          <a:effectLst>
+            <a:outerShdw blurRad="50800" dist="25400" dir="8100000" algn="bl" rotWithShape="0">
+              <a:srgbClr val="000000">
+                <a:alpha val="12000"/>
+              </a:srgbClr>
+            </a:outerShdw>
+          </a:effectLst>
+        </p:spPr>
+        <p:txBody>
+          <a:bodyPr/>
+          <a:lstStyle/>
+          <a:p>
+            <a:endParaRPr lang="fr-FR"/>
+          </a:p>
+        </p:txBody>
+      </p:sp>
+      <p:sp>
+        <p:nvSpPr>
+          <p:cNvPr id="15" name="Shape 13"/>
+          <p:cNvSpPr/>
+          <p:nvPr/>
+        </p:nvSpPr>
+        <p:spPr>
+          <a:xfrm>
+            <a:off x="4754880" y="1097280"/>
+            <a:ext cx="45720" cy="914400"/>
+          </a:xfrm>
+          <a:prstGeom prst="rect">
+            <a:avLst/>
+          </a:prstGeom>
+          <a:solidFill>
+            <a:srgbClr val="10B981"/>
+          </a:solidFill>
+          <a:ln/>
+        </p:spPr>
+        <p:txBody>
+          <a:bodyPr/>
+          <a:lstStyle/>
+          <a:p>
+            <a:endParaRPr lang="fr-FR"/>
+          </a:p>
+        </p:txBody>
+      </p:sp>
+      <p:sp>
+        <p:nvSpPr>
+          <p:cNvPr id="16" name="Shape 14"/>
+          <p:cNvSpPr/>
+          <p:nvPr/>
+        </p:nvSpPr>
+        <p:spPr>
+          <a:xfrm>
+            <a:off x="4919472" y="1207008"/>
+            <a:ext cx="502920" cy="320040"/>
+          </a:xfrm>
+          <a:prstGeom prst="rect">
+            <a:avLst/>
+          </a:prstGeom>
+          <a:solidFill>
+            <a:srgbClr val="1A2744"/>
+          </a:solidFill>
+          <a:ln/>
+        </p:spPr>
+        <p:txBody>
+          <a:bodyPr/>
+          <a:lstStyle/>
+          <a:p>
+            <a:endParaRPr lang="fr-FR"/>
+          </a:p>
+        </p:txBody>
+      </p:sp>
+      <p:sp>
+        <p:nvSpPr>
+          <p:cNvPr id="17" name="Text 15"/>
+          <p:cNvSpPr/>
+          <p:nvPr/>
+        </p:nvSpPr>
+        <p:spPr>
+          <a:xfrm>
+            <a:off x="4919472" y="1207008"/>
+            <a:ext cx="502920" cy="320040"/>
+          </a:xfrm>
+          <a:prstGeom prst="rect">
+            <a:avLst/>
+          </a:prstGeom>
+          <a:noFill/>
+          <a:ln/>
+        </p:spPr>
+        <p:txBody>
+          <a:bodyPr wrap="square" rtlCol="0" anchor="ctr"/>
+          <a:lstStyle/>
+          <a:p>
+            <a:pPr marL="0" indent="0" algn="ctr">
+              <a:buNone/>
+            </a:pPr>
+            <a:r>
+              <a:rPr lang="en-US" sz="1200" b="1" dirty="0">
+                <a:solidFill>
+                  <a:srgbClr val="FFFFFF"/>
+                </a:solidFill>
+                <a:latin typeface="Calibri" pitchFamily="34" charset="0"/>
+                <a:ea typeface="Calibri" pitchFamily="34" charset="-122"/>
+                <a:cs typeface="Calibri" pitchFamily="34" charset="-120"/>
+              </a:rPr>
+              <a:t>M2</a:t>
+            </a:r>
+            <a:endParaRPr lang="en-US" sz="1200" dirty="0"/>
+          </a:p>
+        </p:txBody>
+      </p:sp>
+      <p:sp>
+        <p:nvSpPr>
+          <p:cNvPr id="18" name="Text 16"/>
+          <p:cNvSpPr/>
+          <p:nvPr/>
+        </p:nvSpPr>
+        <p:spPr>
+          <a:xfrm>
+            <a:off x="5532120" y="1152144"/>
+            <a:ext cx="2011680" cy="228600"/>
+          </a:xfrm>
+          <a:prstGeom prst="rect">
+            <a:avLst/>
+          </a:prstGeom>
+          <a:noFill/>
+          <a:ln/>
+        </p:spPr>
+        <p:txBody>
+          <a:bodyPr wrap="square" lIns="0" tIns="0" rIns="0" bIns="0" rtlCol="0" anchor="ctr"/>
+          <a:lstStyle/>
+          <a:p>
+            <a:pPr marL="0" indent="0">
+              <a:buNone/>
+            </a:pPr>
+            <a:r>
+              <a:rPr lang="en-US" sz="1300" b="1" dirty="0">
+                <a:solidFill>
+                  <a:srgbClr val="0F1B2D"/>
+                </a:solidFill>
+                <a:latin typeface="Trebuchet MS" pitchFamily="34" charset="0"/>
+                <a:ea typeface="Trebuchet MS" pitchFamily="34" charset="-122"/>
+                <a:cs typeface="Trebuchet MS" pitchFamily="34" charset="-120"/>
+              </a:rPr>
+              <a:t>Cluster</a:t>
+            </a:r>
+            <a:endParaRPr lang="en-US" sz="1300" dirty="0"/>
+          </a:p>
+        </p:txBody>
+      </p:sp>
+      <p:sp>
+        <p:nvSpPr>
+          <p:cNvPr id="19" name="Text 17"/>
+          <p:cNvSpPr/>
+          <p:nvPr/>
+        </p:nvSpPr>
+        <p:spPr>
+          <a:xfrm>
+            <a:off x="5532120" y="1371600"/>
+            <a:ext cx="2743200" cy="201168"/>
+          </a:xfrm>
+          <a:prstGeom prst="rect">
+            <a:avLst/>
+          </a:prstGeom>
+          <a:noFill/>
+          <a:ln/>
+        </p:spPr>
+        <p:txBody>
+          <a:bodyPr wrap="square" lIns="0" tIns="0" rIns="0" bIns="0" rtlCol="0" anchor="ctr"/>
+          <a:lstStyle/>
+          <a:p>
+            <a:pPr marL="0" indent="0">
+              <a:buNone/>
+            </a:pPr>
+            <a:r>
+              <a:rPr lang="en-US" sz="900" dirty="0">
+                <a:solidFill>
+                  <a:srgbClr val="334155"/>
+                </a:solidFill>
+                <a:latin typeface="Calibri" pitchFamily="34" charset="0"/>
+                <a:ea typeface="Calibri" pitchFamily="34" charset="-122"/>
+                <a:cs typeface="Calibri" pitchFamily="34" charset="-120"/>
+              </a:rPr>
+              <a:t>Installation 2x R650xs + SAN ME5012</a:t>
+            </a:r>
+            <a:endParaRPr lang="en-US" sz="900" dirty="0"/>
+          </a:p>
+        </p:txBody>
+      </p:sp>
+      <p:sp>
+        <p:nvSpPr>
+          <p:cNvPr id="20" name="Shape 18"/>
+          <p:cNvSpPr/>
+          <p:nvPr/>
+        </p:nvSpPr>
+        <p:spPr>
+          <a:xfrm>
+            <a:off x="7772400" y="1170432"/>
+            <a:ext cx="1005840" cy="274320"/>
+          </a:xfrm>
+          <a:prstGeom prst="rect">
+            <a:avLst/>
+          </a:prstGeom>
+          <a:solidFill>
+            <a:srgbClr val="F0F4F8"/>
+          </a:solidFill>
+          <a:ln/>
+        </p:spPr>
+        <p:txBody>
+          <a:bodyPr/>
+          <a:lstStyle/>
+          <a:p>
+            <a:endParaRPr lang="fr-FR"/>
+          </a:p>
+        </p:txBody>
+      </p:sp>
+      <p:sp>
+        <p:nvSpPr>
+          <p:cNvPr id="21" name="Text 19"/>
+          <p:cNvSpPr/>
+          <p:nvPr/>
+        </p:nvSpPr>
+        <p:spPr>
+          <a:xfrm>
+            <a:off x="7772400" y="1170432"/>
+            <a:ext cx="1005840" cy="274320"/>
+          </a:xfrm>
+          <a:prstGeom prst="rect">
+            <a:avLst/>
+          </a:prstGeom>
+          <a:noFill/>
+          <a:ln/>
+        </p:spPr>
+        <p:txBody>
+          <a:bodyPr wrap="square" rtlCol="0" anchor="ctr"/>
+          <a:lstStyle/>
+          <a:p>
+            <a:pPr marL="0" indent="0" algn="ctr">
+              <a:buNone/>
+            </a:pPr>
+            <a:r>
+              <a:rPr lang="en-US" sz="750" dirty="0">
+                <a:solidFill>
+                  <a:srgbClr val="0F1B2D"/>
+                </a:solidFill>
+                <a:latin typeface="Calibri" pitchFamily="34" charset="0"/>
+                <a:ea typeface="Calibri" pitchFamily="34" charset="-122"/>
+                <a:cs typeface="Calibri" pitchFamily="34" charset="-120"/>
+              </a:rPr>
+              <a:t>1 WE + 2j (S2-S3)</a:t>
+            </a:r>
+            <a:endParaRPr lang="en-US" sz="750" dirty="0"/>
+          </a:p>
+        </p:txBody>
+      </p:sp>
+      <p:sp>
+        <p:nvSpPr>
+          <p:cNvPr id="22" name="Text 20"/>
+          <p:cNvSpPr/>
+          <p:nvPr/>
+        </p:nvSpPr>
+        <p:spPr>
+          <a:xfrm>
+            <a:off x="5532120" y="1627632"/>
+            <a:ext cx="3200400" cy="292608"/>
+          </a:xfrm>
+          <a:prstGeom prst="rect">
+            <a:avLst/>
+          </a:prstGeom>
+          <a:noFill/>
+          <a:ln/>
+        </p:spPr>
+        <p:txBody>
+          <a:bodyPr wrap="square" lIns="0" tIns="0" rIns="0" bIns="0" rtlCol="0" anchor="ctr"/>
+          <a:lstStyle/>
+          <a:p>
+            <a:pPr marL="0" indent="0">
+              <a:buNone/>
+            </a:pPr>
+            <a:r>
+              <a:rPr lang="en-US" sz="800" i="1" dirty="0">
+                <a:solidFill>
+                  <a:srgbClr val="94A3B8"/>
+                </a:solidFill>
+                <a:latin typeface="Calibri" pitchFamily="34" charset="0"/>
+                <a:ea typeface="Calibri" pitchFamily="34" charset="-122"/>
+                <a:cs typeface="Calibri" pitchFamily="34" charset="-120"/>
+              </a:rPr>
+              <a:t>↩ R630 reste actif en parallèle</a:t>
+            </a:r>
+            <a:endParaRPr lang="en-US" sz="800" dirty="0"/>
+          </a:p>
+        </p:txBody>
+      </p:sp>
+      <p:sp>
+        <p:nvSpPr>
+          <p:cNvPr id="23" name="Shape 21"/>
+          <p:cNvSpPr/>
+          <p:nvPr/>
+        </p:nvSpPr>
+        <p:spPr>
+          <a:xfrm>
+            <a:off x="365760" y="2121408"/>
+            <a:ext cx="4160520" cy="914400"/>
+          </a:xfrm>
+          <a:prstGeom prst="rect">
+            <a:avLst/>
+          </a:prstGeom>
+          <a:solidFill>
+            <a:srgbClr val="FFFFFF"/>
+          </a:solidFill>
+          <a:ln/>
+          <a:effectLst>
+            <a:outerShdw blurRad="50800" dist="25400" dir="8100000" algn="bl" rotWithShape="0">
+              <a:srgbClr val="000000">
+                <a:alpha val="12000"/>
+              </a:srgbClr>
+            </a:outerShdw>
+          </a:effectLst>
+        </p:spPr>
+        <p:txBody>
+          <a:bodyPr/>
+          <a:lstStyle/>
+          <a:p>
+            <a:endParaRPr lang="fr-FR"/>
+          </a:p>
+        </p:txBody>
+      </p:sp>
+      <p:sp>
+        <p:nvSpPr>
+          <p:cNvPr id="24" name="Shape 22"/>
+          <p:cNvSpPr/>
+          <p:nvPr/>
+        </p:nvSpPr>
+        <p:spPr>
+          <a:xfrm>
+            <a:off x="365760" y="2121408"/>
+            <a:ext cx="45720" cy="914400"/>
+          </a:xfrm>
+          <a:prstGeom prst="rect">
+            <a:avLst/>
+          </a:prstGeom>
+          <a:solidFill>
+            <a:srgbClr val="EF4444"/>
+          </a:solidFill>
+          <a:ln/>
+        </p:spPr>
+        <p:txBody>
+          <a:bodyPr/>
+          <a:lstStyle/>
+          <a:p>
+            <a:endParaRPr lang="fr-FR"/>
+          </a:p>
+        </p:txBody>
+      </p:sp>
+      <p:sp>
+        <p:nvSpPr>
+          <p:cNvPr id="25" name="Shape 23"/>
+          <p:cNvSpPr/>
+          <p:nvPr/>
+        </p:nvSpPr>
+        <p:spPr>
+          <a:xfrm>
+            <a:off x="530352" y="2231136"/>
+            <a:ext cx="502920" cy="320040"/>
+          </a:xfrm>
+          <a:prstGeom prst="rect">
+            <a:avLst/>
+          </a:prstGeom>
+          <a:solidFill>
+            <a:srgbClr val="1A2744"/>
+          </a:solidFill>
+          <a:ln/>
+        </p:spPr>
+        <p:txBody>
+          <a:bodyPr/>
+          <a:lstStyle/>
+          <a:p>
+            <a:endParaRPr lang="fr-FR"/>
+          </a:p>
+        </p:txBody>
+      </p:sp>
+      <p:sp>
+        <p:nvSpPr>
+          <p:cNvPr id="26" name="Text 24"/>
+          <p:cNvSpPr/>
+          <p:nvPr/>
+        </p:nvSpPr>
+        <p:spPr>
+          <a:xfrm>
+            <a:off x="530352" y="2231136"/>
+            <a:ext cx="502920" cy="320040"/>
+          </a:xfrm>
+          <a:prstGeom prst="rect">
+            <a:avLst/>
+          </a:prstGeom>
+          <a:noFill/>
+          <a:ln/>
+        </p:spPr>
+        <p:txBody>
+          <a:bodyPr wrap="square" rtlCol="0" anchor="ctr"/>
+          <a:lstStyle/>
+          <a:p>
+            <a:pPr marL="0" indent="0" algn="ctr">
+              <a:buNone/>
+            </a:pPr>
+            <a:r>
+              <a:rPr lang="en-US" sz="1200" b="1" dirty="0">
+                <a:solidFill>
+                  <a:srgbClr val="FFFFFF"/>
+                </a:solidFill>
+                <a:latin typeface="Calibri" pitchFamily="34" charset="0"/>
+                <a:ea typeface="Calibri" pitchFamily="34" charset="-122"/>
+                <a:cs typeface="Calibri" pitchFamily="34" charset="-120"/>
+              </a:rPr>
+              <a:t>M3</a:t>
+            </a:r>
+            <a:endParaRPr lang="en-US" sz="1200" dirty="0"/>
+          </a:p>
+        </p:txBody>
+      </p:sp>
+      <p:sp>
+        <p:nvSpPr>
+          <p:cNvPr id="27" name="Text 25"/>
+          <p:cNvSpPr/>
+          <p:nvPr/>
+        </p:nvSpPr>
+        <p:spPr>
+          <a:xfrm>
+            <a:off x="1143000" y="2176272"/>
+            <a:ext cx="2011680" cy="228600"/>
+          </a:xfrm>
+          <a:prstGeom prst="rect">
+            <a:avLst/>
+          </a:prstGeom>
+          <a:noFill/>
+          <a:ln/>
+        </p:spPr>
+        <p:txBody>
+          <a:bodyPr wrap="square" lIns="0" tIns="0" rIns="0" bIns="0" rtlCol="0" anchor="ctr"/>
+          <a:lstStyle/>
+          <a:p>
+            <a:pPr marL="0" indent="0">
+              <a:buNone/>
+            </a:pPr>
+            <a:r>
+              <a:rPr lang="en-US" sz="1300" b="1" dirty="0">
+                <a:solidFill>
+                  <a:srgbClr val="0F1B2D"/>
+                </a:solidFill>
+                <a:latin typeface="Trebuchet MS" pitchFamily="34" charset="0"/>
+                <a:ea typeface="Trebuchet MS" pitchFamily="34" charset="-122"/>
+                <a:cs typeface="Trebuchet MS" pitchFamily="34" charset="-120"/>
+              </a:rPr>
+              <a:t>VMs</a:t>
+            </a:r>
+            <a:endParaRPr lang="en-US" sz="1300" dirty="0"/>
+          </a:p>
+        </p:txBody>
+      </p:sp>
+      <p:sp>
+        <p:nvSpPr>
+          <p:cNvPr id="28" name="Text 26"/>
+          <p:cNvSpPr/>
+          <p:nvPr/>
+        </p:nvSpPr>
+        <p:spPr>
+          <a:xfrm>
+            <a:off x="1143000" y="2395728"/>
+            <a:ext cx="2743200" cy="201168"/>
+          </a:xfrm>
+          <a:prstGeom prst="rect">
+            <a:avLst/>
+          </a:prstGeom>
+          <a:noFill/>
+          <a:ln/>
+        </p:spPr>
+        <p:txBody>
+          <a:bodyPr wrap="square" lIns="0" tIns="0" rIns="0" bIns="0" rtlCol="0" anchor="ctr"/>
+          <a:lstStyle/>
+          <a:p>
+            <a:pPr marL="0" indent="0">
+              <a:buNone/>
+            </a:pPr>
+            <a:r>
+              <a:rPr lang="en-US" sz="900" dirty="0">
+                <a:solidFill>
+                  <a:srgbClr val="334155"/>
+                </a:solidFill>
+                <a:latin typeface="Calibri" pitchFamily="34" charset="0"/>
+                <a:ea typeface="Calibri" pitchFamily="34" charset="-122"/>
+                <a:cs typeface="Calibri" pitchFamily="34" charset="-120"/>
+              </a:rPr>
+              <a:t>Migration ~20 VMs du R630 → cluster</a:t>
+            </a:r>
+            <a:endParaRPr lang="en-US" sz="900" dirty="0"/>
+          </a:p>
+        </p:txBody>
+      </p:sp>
+      <p:sp>
+        <p:nvSpPr>
+          <p:cNvPr id="29" name="Shape 27"/>
+          <p:cNvSpPr/>
+          <p:nvPr/>
+        </p:nvSpPr>
+        <p:spPr>
+          <a:xfrm>
+            <a:off x="3383280" y="2194560"/>
+            <a:ext cx="1005840" cy="274320"/>
+          </a:xfrm>
+          <a:prstGeom prst="rect">
+            <a:avLst/>
+          </a:prstGeom>
+          <a:solidFill>
+            <a:srgbClr val="F0F4F8"/>
+          </a:solidFill>
+          <a:ln/>
+        </p:spPr>
+        <p:txBody>
+          <a:bodyPr/>
+          <a:lstStyle/>
+          <a:p>
+            <a:endParaRPr lang="fr-FR"/>
+          </a:p>
+        </p:txBody>
+      </p:sp>
+      <p:sp>
+        <p:nvSpPr>
+          <p:cNvPr id="30" name="Text 28"/>
+          <p:cNvSpPr/>
+          <p:nvPr/>
+        </p:nvSpPr>
+        <p:spPr>
+          <a:xfrm>
+            <a:off x="3383280" y="2194560"/>
+            <a:ext cx="1005840" cy="274320"/>
+          </a:xfrm>
+          <a:prstGeom prst="rect">
+            <a:avLst/>
+          </a:prstGeom>
+          <a:noFill/>
+          <a:ln/>
+        </p:spPr>
+        <p:txBody>
+          <a:bodyPr wrap="square" rtlCol="0" anchor="ctr"/>
+          <a:lstStyle/>
+          <a:p>
+            <a:pPr marL="0" indent="0" algn="ctr">
+              <a:buNone/>
+            </a:pPr>
+            <a:r>
+              <a:rPr lang="en-US" sz="750" dirty="0">
+                <a:solidFill>
+                  <a:srgbClr val="0F1B2D"/>
+                </a:solidFill>
+                <a:latin typeface="Calibri" pitchFamily="34" charset="0"/>
+                <a:ea typeface="Calibri" pitchFamily="34" charset="-122"/>
+                <a:cs typeface="Calibri" pitchFamily="34" charset="-120"/>
+              </a:rPr>
+              <a:t>2 nuits WE (S3)</a:t>
+            </a:r>
+            <a:endParaRPr lang="en-US" sz="750" dirty="0"/>
+          </a:p>
+        </p:txBody>
+      </p:sp>
+      <p:sp>
+        <p:nvSpPr>
+          <p:cNvPr id="31" name="Text 29"/>
+          <p:cNvSpPr/>
+          <p:nvPr/>
+        </p:nvSpPr>
+        <p:spPr>
+          <a:xfrm>
+            <a:off x="1143000" y="2651760"/>
+            <a:ext cx="3200400" cy="292608"/>
+          </a:xfrm>
+          <a:prstGeom prst="rect">
+            <a:avLst/>
+          </a:prstGeom>
+          <a:noFill/>
+          <a:ln/>
+        </p:spPr>
+        <p:txBody>
+          <a:bodyPr wrap="square" lIns="0" tIns="0" rIns="0" bIns="0" rtlCol="0" anchor="ctr"/>
+          <a:lstStyle/>
+          <a:p>
+            <a:pPr marL="0" indent="0">
+              <a:buNone/>
+            </a:pPr>
+            <a:r>
+              <a:rPr lang="en-US" sz="800" i="1" dirty="0">
+                <a:solidFill>
+                  <a:srgbClr val="94A3B8"/>
+                </a:solidFill>
+                <a:latin typeface="Calibri" pitchFamily="34" charset="0"/>
+                <a:ea typeface="Calibri" pitchFamily="34" charset="-122"/>
+                <a:cs typeface="Calibri" pitchFamily="34" charset="-120"/>
+              </a:rPr>
+              <a:t>↩ Restaurer snapshots sur R630 (~30 min)</a:t>
+            </a:r>
+            <a:endParaRPr lang="en-US" sz="800" dirty="0"/>
+          </a:p>
+        </p:txBody>
+      </p:sp>
+      <p:sp>
+        <p:nvSpPr>
+          <p:cNvPr id="32" name="Shape 30"/>
+          <p:cNvSpPr/>
+          <p:nvPr/>
+        </p:nvSpPr>
+        <p:spPr>
+          <a:xfrm>
+            <a:off x="4754880" y="2121408"/>
+            <a:ext cx="4160520" cy="914400"/>
+          </a:xfrm>
+          <a:prstGeom prst="rect">
+            <a:avLst/>
+          </a:prstGeom>
+          <a:solidFill>
+            <a:srgbClr val="FFFFFF"/>
+          </a:solidFill>
+          <a:ln/>
+          <a:effectLst>
+            <a:outerShdw blurRad="50800" dist="25400" dir="8100000" algn="bl" rotWithShape="0">
+              <a:srgbClr val="000000">
+                <a:alpha val="12000"/>
+              </a:srgbClr>
+            </a:outerShdw>
+          </a:effectLst>
+        </p:spPr>
+        <p:txBody>
+          <a:bodyPr/>
+          <a:lstStyle/>
+          <a:p>
+            <a:endParaRPr lang="fr-FR"/>
+          </a:p>
+        </p:txBody>
+      </p:sp>
+      <p:sp>
+        <p:nvSpPr>
+          <p:cNvPr id="33" name="Shape 31"/>
+          <p:cNvSpPr/>
+          <p:nvPr/>
+        </p:nvSpPr>
+        <p:spPr>
+          <a:xfrm>
+            <a:off x="4754880" y="2121408"/>
+            <a:ext cx="45720" cy="914400"/>
+          </a:xfrm>
+          <a:prstGeom prst="rect">
+            <a:avLst/>
+          </a:prstGeom>
+          <a:solidFill>
+            <a:srgbClr val="F97316"/>
+          </a:solidFill>
+          <a:ln/>
+        </p:spPr>
+        <p:txBody>
+          <a:bodyPr/>
+          <a:lstStyle/>
+          <a:p>
+            <a:endParaRPr lang="fr-FR"/>
+          </a:p>
+        </p:txBody>
+      </p:sp>
+      <p:sp>
+        <p:nvSpPr>
+          <p:cNvPr id="34" name="Shape 32"/>
+          <p:cNvSpPr/>
+          <p:nvPr/>
+        </p:nvSpPr>
+        <p:spPr>
+          <a:xfrm>
+            <a:off x="4919472" y="2231136"/>
+            <a:ext cx="502920" cy="320040"/>
+          </a:xfrm>
+          <a:prstGeom prst="rect">
+            <a:avLst/>
+          </a:prstGeom>
+          <a:solidFill>
+            <a:srgbClr val="1A2744"/>
+          </a:solidFill>
+          <a:ln/>
+        </p:spPr>
+        <p:txBody>
+          <a:bodyPr/>
+          <a:lstStyle/>
+          <a:p>
+            <a:endParaRPr lang="fr-FR"/>
+          </a:p>
+        </p:txBody>
+      </p:sp>
+      <p:sp>
+        <p:nvSpPr>
+          <p:cNvPr id="35" name="Text 33"/>
+          <p:cNvSpPr/>
+          <p:nvPr/>
+        </p:nvSpPr>
+        <p:spPr>
+          <a:xfrm>
+            <a:off x="4919472" y="2231136"/>
+            <a:ext cx="502920" cy="320040"/>
+          </a:xfrm>
+          <a:prstGeom prst="rect">
+            <a:avLst/>
+          </a:prstGeom>
+          <a:noFill/>
+          <a:ln/>
+        </p:spPr>
+        <p:txBody>
+          <a:bodyPr wrap="square" rtlCol="0" anchor="ctr"/>
+          <a:lstStyle/>
+          <a:p>
+            <a:pPr marL="0" indent="0" algn="ctr">
+              <a:buNone/>
+            </a:pPr>
+            <a:r>
+              <a:rPr lang="en-US" sz="1200" b="1" dirty="0">
+                <a:solidFill>
+                  <a:srgbClr val="FFFFFF"/>
+                </a:solidFill>
+                <a:latin typeface="Calibri" pitchFamily="34" charset="0"/>
+                <a:ea typeface="Calibri" pitchFamily="34" charset="-122"/>
+                <a:cs typeface="Calibri" pitchFamily="34" charset="-120"/>
+              </a:rPr>
+              <a:t>M4</a:t>
+            </a:r>
+            <a:endParaRPr lang="en-US" sz="1200" dirty="0"/>
+          </a:p>
+        </p:txBody>
+      </p:sp>
+      <p:sp>
+        <p:nvSpPr>
+          <p:cNvPr id="36" name="Text 34"/>
+          <p:cNvSpPr/>
+          <p:nvPr/>
+        </p:nvSpPr>
+        <p:spPr>
+          <a:xfrm>
+            <a:off x="5532120" y="2176272"/>
+            <a:ext cx="2011680" cy="228600"/>
+          </a:xfrm>
+          <a:prstGeom prst="rect">
+            <a:avLst/>
+          </a:prstGeom>
+          <a:noFill/>
+          <a:ln/>
+        </p:spPr>
+        <p:txBody>
+          <a:bodyPr wrap="square" lIns="0" tIns="0" rIns="0" bIns="0" rtlCol="0" anchor="ctr"/>
+          <a:lstStyle/>
+          <a:p>
+            <a:pPr marL="0" indent="0">
+              <a:buNone/>
+            </a:pPr>
+            <a:r>
+              <a:rPr lang="en-US" sz="1300" b="1" dirty="0">
+                <a:solidFill>
+                  <a:srgbClr val="0F1B2D"/>
+                </a:solidFill>
+                <a:latin typeface="Trebuchet MS" pitchFamily="34" charset="0"/>
+                <a:ea typeface="Trebuchet MS" pitchFamily="34" charset="-122"/>
+                <a:cs typeface="Trebuchet MS" pitchFamily="34" charset="-120"/>
+              </a:rPr>
+              <a:t>Azure</a:t>
+            </a:r>
+            <a:endParaRPr lang="en-US" sz="1300" dirty="0"/>
+          </a:p>
+        </p:txBody>
+      </p:sp>
+      <p:sp>
+        <p:nvSpPr>
+          <p:cNvPr id="37" name="Text 35"/>
+          <p:cNvSpPr/>
+          <p:nvPr/>
+        </p:nvSpPr>
+        <p:spPr>
+          <a:xfrm>
+            <a:off x="5532120" y="2395728"/>
+            <a:ext cx="2743200" cy="201168"/>
+          </a:xfrm>
+          <a:prstGeom prst="rect">
+            <a:avLst/>
+          </a:prstGeom>
+          <a:noFill/>
+          <a:ln/>
+        </p:spPr>
+        <p:txBody>
+          <a:bodyPr wrap="square" lIns="0" tIns="0" rIns="0" bIns="0" rtlCol="0" anchor="ctr"/>
+          <a:lstStyle/>
+          <a:p>
+            <a:pPr marL="0" indent="0">
+              <a:buNone/>
+            </a:pPr>
+            <a:r>
+              <a:rPr lang="en-US" sz="900" dirty="0">
+                <a:solidFill>
+                  <a:srgbClr val="334155"/>
+                </a:solidFill>
+                <a:latin typeface="Calibri" pitchFamily="34" charset="0"/>
+                <a:ea typeface="Calibri" pitchFamily="34" charset="-122"/>
+                <a:cs typeface="Calibri" pitchFamily="34" charset="-120"/>
+              </a:rPr>
+              <a:t>VPN site-à-site + DC répliqué + ASR</a:t>
+            </a:r>
+            <a:endParaRPr lang="en-US" sz="900" dirty="0"/>
+          </a:p>
+        </p:txBody>
+      </p:sp>
+      <p:sp>
+        <p:nvSpPr>
+          <p:cNvPr id="38" name="Shape 36"/>
+          <p:cNvSpPr/>
+          <p:nvPr/>
+        </p:nvSpPr>
+        <p:spPr>
+          <a:xfrm>
+            <a:off x="7772400" y="2194560"/>
+            <a:ext cx="1005840" cy="274320"/>
+          </a:xfrm>
+          <a:prstGeom prst="rect">
+            <a:avLst/>
+          </a:prstGeom>
+          <a:solidFill>
+            <a:srgbClr val="F0F4F8"/>
+          </a:solidFill>
+          <a:ln/>
+        </p:spPr>
+        <p:txBody>
+          <a:bodyPr/>
+          <a:lstStyle/>
+          <a:p>
+            <a:endParaRPr lang="fr-FR"/>
+          </a:p>
+        </p:txBody>
+      </p:sp>
+      <p:sp>
+        <p:nvSpPr>
+          <p:cNvPr id="39" name="Text 37"/>
+          <p:cNvSpPr/>
+          <p:nvPr/>
+        </p:nvSpPr>
+        <p:spPr>
+          <a:xfrm>
+            <a:off x="7772400" y="2194560"/>
+            <a:ext cx="1005840" cy="274320"/>
+          </a:xfrm>
+          <a:prstGeom prst="rect">
+            <a:avLst/>
+          </a:prstGeom>
+          <a:noFill/>
+          <a:ln/>
+        </p:spPr>
+        <p:txBody>
+          <a:bodyPr wrap="square" rtlCol="0" anchor="ctr"/>
+          <a:lstStyle/>
+          <a:p>
+            <a:pPr marL="0" indent="0" algn="ctr">
+              <a:buNone/>
+            </a:pPr>
+            <a:r>
+              <a:rPr lang="en-US" sz="750" dirty="0">
+                <a:solidFill>
+                  <a:srgbClr val="0F1B2D"/>
+                </a:solidFill>
+                <a:latin typeface="Calibri" pitchFamily="34" charset="0"/>
+                <a:ea typeface="Calibri" pitchFamily="34" charset="-122"/>
+                <a:cs typeface="Calibri" pitchFamily="34" charset="-120"/>
+              </a:rPr>
+              <a:t>3 jours (S4)</a:t>
+            </a:r>
+            <a:endParaRPr lang="en-US" sz="750" dirty="0"/>
+          </a:p>
+        </p:txBody>
+      </p:sp>
+      <p:sp>
+        <p:nvSpPr>
+          <p:cNvPr id="40" name="Text 38"/>
+          <p:cNvSpPr/>
+          <p:nvPr/>
+        </p:nvSpPr>
+        <p:spPr>
+          <a:xfrm>
+            <a:off x="5532120" y="2651760"/>
+            <a:ext cx="3200400" cy="292608"/>
+          </a:xfrm>
+          <a:prstGeom prst="rect">
+            <a:avLst/>
+          </a:prstGeom>
+          <a:noFill/>
+          <a:ln/>
+        </p:spPr>
+        <p:txBody>
+          <a:bodyPr wrap="square" lIns="0" tIns="0" rIns="0" bIns="0" rtlCol="0" anchor="ctr"/>
+          <a:lstStyle/>
+          <a:p>
+            <a:pPr marL="0" indent="0">
+              <a:buNone/>
+            </a:pPr>
+            <a:r>
+              <a:rPr lang="en-US" sz="800" i="1" dirty="0">
+                <a:solidFill>
+                  <a:srgbClr val="94A3B8"/>
+                </a:solidFill>
+                <a:latin typeface="Calibri" pitchFamily="34" charset="0"/>
+                <a:ea typeface="Calibri" pitchFamily="34" charset="-122"/>
+                <a:cs typeface="Calibri" pitchFamily="34" charset="-120"/>
+              </a:rPr>
+              <a:t>↩ Couper tunnel, supprimer ressources (~5 min)</a:t>
+            </a:r>
+            <a:endParaRPr lang="en-US" sz="800" dirty="0"/>
+          </a:p>
+        </p:txBody>
+      </p:sp>
+      <p:sp>
+        <p:nvSpPr>
+          <p:cNvPr id="41" name="Shape 39"/>
+          <p:cNvSpPr/>
+          <p:nvPr/>
+        </p:nvSpPr>
+        <p:spPr>
+          <a:xfrm>
+            <a:off x="365760" y="3145536"/>
+            <a:ext cx="4160520" cy="914400"/>
+          </a:xfrm>
+          <a:prstGeom prst="rect">
+            <a:avLst/>
+          </a:prstGeom>
+          <a:solidFill>
+            <a:srgbClr val="FFFFFF"/>
+          </a:solidFill>
+          <a:ln/>
+          <a:effectLst>
+            <a:outerShdw blurRad="50800" dist="25400" dir="8100000" algn="bl" rotWithShape="0">
+              <a:srgbClr val="000000">
+                <a:alpha val="12000"/>
+              </a:srgbClr>
+            </a:outerShdw>
+          </a:effectLst>
+        </p:spPr>
+        <p:txBody>
+          <a:bodyPr/>
+          <a:lstStyle/>
+          <a:p>
+            <a:endParaRPr lang="fr-FR"/>
+          </a:p>
+        </p:txBody>
+      </p:sp>
+      <p:sp>
+        <p:nvSpPr>
+          <p:cNvPr id="42" name="Shape 40"/>
+          <p:cNvSpPr/>
+          <p:nvPr/>
+        </p:nvSpPr>
+        <p:spPr>
+          <a:xfrm>
+            <a:off x="365760" y="3145536"/>
+            <a:ext cx="45720" cy="914400"/>
+          </a:xfrm>
+          <a:prstGeom prst="rect">
+            <a:avLst/>
+          </a:prstGeom>
+          <a:solidFill>
+            <a:srgbClr val="F97316"/>
+          </a:solidFill>
+          <a:ln/>
+        </p:spPr>
+        <p:txBody>
+          <a:bodyPr/>
+          <a:lstStyle/>
+          <a:p>
+            <a:endParaRPr lang="fr-FR"/>
+          </a:p>
+        </p:txBody>
+      </p:sp>
+      <p:sp>
+        <p:nvSpPr>
+          <p:cNvPr id="43" name="Shape 41"/>
+          <p:cNvSpPr/>
+          <p:nvPr/>
+        </p:nvSpPr>
+        <p:spPr>
+          <a:xfrm>
+            <a:off x="530352" y="3255264"/>
+            <a:ext cx="502920" cy="320040"/>
+          </a:xfrm>
+          <a:prstGeom prst="rect">
+            <a:avLst/>
+          </a:prstGeom>
+          <a:solidFill>
+            <a:srgbClr val="1A2744"/>
+          </a:solidFill>
+          <a:ln/>
+        </p:spPr>
+        <p:txBody>
+          <a:bodyPr/>
+          <a:lstStyle/>
+          <a:p>
+            <a:endParaRPr lang="fr-FR"/>
+          </a:p>
+        </p:txBody>
+      </p:sp>
+      <p:sp>
+        <p:nvSpPr>
+          <p:cNvPr id="44" name="Text 42"/>
+          <p:cNvSpPr/>
+          <p:nvPr/>
+        </p:nvSpPr>
+        <p:spPr>
+          <a:xfrm>
+            <a:off x="530352" y="3255264"/>
+            <a:ext cx="502920" cy="320040"/>
+          </a:xfrm>
+          <a:prstGeom prst="rect">
+            <a:avLst/>
+          </a:prstGeom>
+          <a:noFill/>
+          <a:ln/>
+        </p:spPr>
+        <p:txBody>
+          <a:bodyPr wrap="square" rtlCol="0" anchor="ctr"/>
+          <a:lstStyle/>
+          <a:p>
+            <a:pPr marL="0" indent="0" algn="ctr">
+              <a:buNone/>
+            </a:pPr>
+            <a:r>
+              <a:rPr lang="en-US" sz="1200" b="1" dirty="0">
+                <a:solidFill>
+                  <a:srgbClr val="FFFFFF"/>
+                </a:solidFill>
+                <a:latin typeface="Calibri" pitchFamily="34" charset="0"/>
+                <a:ea typeface="Calibri" pitchFamily="34" charset="-122"/>
+                <a:cs typeface="Calibri" pitchFamily="34" charset="-120"/>
+              </a:rPr>
+              <a:t>M5</a:t>
+            </a:r>
+            <a:endParaRPr lang="en-US" sz="1200" dirty="0"/>
+          </a:p>
+        </p:txBody>
+      </p:sp>
+      <p:sp>
+        <p:nvSpPr>
+          <p:cNvPr id="45" name="Text 43"/>
+          <p:cNvSpPr/>
+          <p:nvPr/>
+        </p:nvSpPr>
+        <p:spPr>
+          <a:xfrm>
+            <a:off x="1143000" y="3200400"/>
+            <a:ext cx="2011680" cy="228600"/>
+          </a:xfrm>
+          <a:prstGeom prst="rect">
+            <a:avLst/>
+          </a:prstGeom>
+          <a:noFill/>
+          <a:ln/>
+        </p:spPr>
+        <p:txBody>
+          <a:bodyPr wrap="square" lIns="0" tIns="0" rIns="0" bIns="0" rtlCol="0" anchor="ctr"/>
+          <a:lstStyle/>
+          <a:p>
+            <a:pPr marL="0" indent="0">
+              <a:buNone/>
+            </a:pPr>
+            <a:r>
+              <a:rPr lang="en-US" sz="1300" b="1" dirty="0">
+                <a:solidFill>
+                  <a:srgbClr val="0F1B2D"/>
+                </a:solidFill>
+                <a:latin typeface="Trebuchet MS" pitchFamily="34" charset="0"/>
+                <a:ea typeface="Trebuchet MS" pitchFamily="34" charset="-122"/>
+                <a:cs typeface="Trebuchet MS" pitchFamily="34" charset="-120"/>
+              </a:rPr>
+              <a:t>QoS/VLAN</a:t>
+            </a:r>
+            <a:endParaRPr lang="en-US" sz="1300" dirty="0"/>
+          </a:p>
+        </p:txBody>
+      </p:sp>
+      <p:sp>
+        <p:nvSpPr>
+          <p:cNvPr id="46" name="Text 44"/>
+          <p:cNvSpPr/>
+          <p:nvPr/>
+        </p:nvSpPr>
+        <p:spPr>
+          <a:xfrm>
+            <a:off x="1143000" y="3419856"/>
+            <a:ext cx="2743200" cy="201168"/>
+          </a:xfrm>
+          <a:prstGeom prst="rect">
+            <a:avLst/>
+          </a:prstGeom>
+          <a:noFill/>
+          <a:ln/>
+        </p:spPr>
+        <p:txBody>
+          <a:bodyPr wrap="square" lIns="0" tIns="0" rIns="0" bIns="0" rtlCol="0" anchor="ctr"/>
+          <a:lstStyle/>
+          <a:p>
+            <a:pPr marL="0" indent="0">
+              <a:buNone/>
+            </a:pPr>
+            <a:r>
+              <a:rPr lang="en-US" sz="900" dirty="0">
+                <a:solidFill>
+                  <a:srgbClr val="334155"/>
+                </a:solidFill>
+                <a:latin typeface="Calibri" pitchFamily="34" charset="0"/>
+                <a:ea typeface="Calibri" pitchFamily="34" charset="-122"/>
+                <a:cs typeface="Calibri" pitchFamily="34" charset="-120"/>
+              </a:rPr>
+              <a:t>Segmentation 4 VLAN + DSCP + QoS VoIP</a:t>
+            </a:r>
+            <a:endParaRPr lang="en-US" sz="900" dirty="0"/>
+          </a:p>
+        </p:txBody>
+      </p:sp>
+      <p:sp>
+        <p:nvSpPr>
+          <p:cNvPr id="47" name="Shape 45"/>
+          <p:cNvSpPr/>
+          <p:nvPr/>
+        </p:nvSpPr>
+        <p:spPr>
+          <a:xfrm>
+            <a:off x="3383280" y="3218688"/>
+            <a:ext cx="1005840" cy="274320"/>
+          </a:xfrm>
+          <a:prstGeom prst="rect">
+            <a:avLst/>
+          </a:prstGeom>
+          <a:solidFill>
+            <a:srgbClr val="F0F4F8"/>
+          </a:solidFill>
+          <a:ln/>
+        </p:spPr>
+        <p:txBody>
+          <a:bodyPr/>
+          <a:lstStyle/>
+          <a:p>
+            <a:endParaRPr lang="fr-FR"/>
+          </a:p>
+        </p:txBody>
+      </p:sp>
+      <p:sp>
+        <p:nvSpPr>
+          <p:cNvPr id="48" name="Text 46"/>
+          <p:cNvSpPr/>
+          <p:nvPr/>
+        </p:nvSpPr>
+        <p:spPr>
+          <a:xfrm>
+            <a:off x="3383280" y="3218688"/>
+            <a:ext cx="1005840" cy="274320"/>
+          </a:xfrm>
+          <a:prstGeom prst="rect">
+            <a:avLst/>
+          </a:prstGeom>
+          <a:noFill/>
+          <a:ln/>
+        </p:spPr>
+        <p:txBody>
+          <a:bodyPr wrap="square" rtlCol="0" anchor="ctr"/>
+          <a:lstStyle/>
+          <a:p>
+            <a:pPr marL="0" indent="0" algn="ctr">
+              <a:buNone/>
+            </a:pPr>
+            <a:r>
+              <a:rPr lang="en-US" sz="750" dirty="0">
+                <a:solidFill>
+                  <a:srgbClr val="0F1B2D"/>
+                </a:solidFill>
+                <a:latin typeface="Calibri" pitchFamily="34" charset="0"/>
+                <a:ea typeface="Calibri" pitchFamily="34" charset="-122"/>
+                <a:cs typeface="Calibri" pitchFamily="34" charset="-120"/>
+              </a:rPr>
+              <a:t>3 nuits (S5)</a:t>
+            </a:r>
+            <a:endParaRPr lang="en-US" sz="750" dirty="0"/>
+          </a:p>
+        </p:txBody>
+      </p:sp>
+      <p:sp>
+        <p:nvSpPr>
+          <p:cNvPr id="49" name="Text 47"/>
+          <p:cNvSpPr/>
+          <p:nvPr/>
+        </p:nvSpPr>
+        <p:spPr>
+          <a:xfrm>
+            <a:off x="1143000" y="3675888"/>
+            <a:ext cx="3200400" cy="292608"/>
+          </a:xfrm>
+          <a:prstGeom prst="rect">
+            <a:avLst/>
+          </a:prstGeom>
+          <a:noFill/>
+          <a:ln/>
+        </p:spPr>
+        <p:txBody>
+          <a:bodyPr wrap="square" lIns="0" tIns="0" rIns="0" bIns="0" rtlCol="0" anchor="ctr"/>
+          <a:lstStyle/>
+          <a:p>
+            <a:pPr marL="0" indent="0">
+              <a:buNone/>
+            </a:pPr>
+            <a:r>
+              <a:rPr lang="en-US" sz="800" i="1" dirty="0">
+                <a:solidFill>
+                  <a:srgbClr val="94A3B8"/>
+                </a:solidFill>
+                <a:latin typeface="Calibri" pitchFamily="34" charset="0"/>
+                <a:ea typeface="Calibri" pitchFamily="34" charset="-122"/>
+                <a:cs typeface="Calibri" pitchFamily="34" charset="-120"/>
+              </a:rPr>
+              <a:t>↩ Désactiver VLAN, retour flat (~20 min)</a:t>
+            </a:r>
+            <a:endParaRPr lang="en-US" sz="800" dirty="0"/>
+          </a:p>
+        </p:txBody>
+      </p:sp>
+      <p:sp>
+        <p:nvSpPr>
+          <p:cNvPr id="50" name="Shape 48"/>
+          <p:cNvSpPr/>
+          <p:nvPr/>
+        </p:nvSpPr>
+        <p:spPr>
+          <a:xfrm>
+            <a:off x="4754880" y="3145536"/>
+            <a:ext cx="4160520" cy="914400"/>
+          </a:xfrm>
+          <a:prstGeom prst="rect">
+            <a:avLst/>
+          </a:prstGeom>
+          <a:solidFill>
+            <a:srgbClr val="FFFFFF"/>
+          </a:solidFill>
+          <a:ln/>
+          <a:effectLst>
+            <a:outerShdw blurRad="50800" dist="25400" dir="8100000" algn="bl" rotWithShape="0">
+              <a:srgbClr val="000000">
+                <a:alpha val="12000"/>
+              </a:srgbClr>
+            </a:outerShdw>
+          </a:effectLst>
+        </p:spPr>
+        <p:txBody>
+          <a:bodyPr/>
+          <a:lstStyle/>
+          <a:p>
+            <a:endParaRPr lang="fr-FR"/>
+          </a:p>
+        </p:txBody>
+      </p:sp>
+      <p:sp>
+        <p:nvSpPr>
+          <p:cNvPr id="51" name="Shape 49"/>
+          <p:cNvSpPr/>
+          <p:nvPr/>
+        </p:nvSpPr>
+        <p:spPr>
+          <a:xfrm>
+            <a:off x="4754880" y="3145536"/>
+            <a:ext cx="45720" cy="914400"/>
+          </a:xfrm>
+          <a:prstGeom prst="rect">
+            <a:avLst/>
+          </a:prstGeom>
+          <a:solidFill>
+            <a:srgbClr val="10B981"/>
+          </a:solidFill>
+          <a:ln/>
+        </p:spPr>
+        <p:txBody>
+          <a:bodyPr/>
+          <a:lstStyle/>
+          <a:p>
+            <a:endParaRPr lang="fr-FR"/>
+          </a:p>
+        </p:txBody>
+      </p:sp>
+      <p:sp>
+        <p:nvSpPr>
+          <p:cNvPr id="52" name="Shape 50"/>
+          <p:cNvSpPr/>
+          <p:nvPr/>
+        </p:nvSpPr>
+        <p:spPr>
+          <a:xfrm>
+            <a:off x="4919472" y="3255264"/>
+            <a:ext cx="502920" cy="320040"/>
+          </a:xfrm>
+          <a:prstGeom prst="rect">
+            <a:avLst/>
+          </a:prstGeom>
+          <a:solidFill>
+            <a:srgbClr val="1A2744"/>
+          </a:solidFill>
+          <a:ln/>
+        </p:spPr>
+        <p:txBody>
+          <a:bodyPr/>
+          <a:lstStyle/>
+          <a:p>
+            <a:endParaRPr lang="fr-FR"/>
+          </a:p>
+        </p:txBody>
+      </p:sp>
+      <p:sp>
+        <p:nvSpPr>
+          <p:cNvPr id="53" name="Text 51"/>
+          <p:cNvSpPr/>
+          <p:nvPr/>
+        </p:nvSpPr>
+        <p:spPr>
+          <a:xfrm>
+            <a:off x="4919472" y="3255264"/>
+            <a:ext cx="502920" cy="320040"/>
+          </a:xfrm>
+          <a:prstGeom prst="rect">
+            <a:avLst/>
+          </a:prstGeom>
+          <a:noFill/>
+          <a:ln/>
+        </p:spPr>
+        <p:txBody>
+          <a:bodyPr wrap="square" rtlCol="0" anchor="ctr"/>
+          <a:lstStyle/>
+          <a:p>
+            <a:pPr marL="0" indent="0" algn="ctr">
+              <a:buNone/>
+            </a:pPr>
+            <a:r>
+              <a:rPr lang="en-US" sz="1200" b="1" dirty="0">
+                <a:solidFill>
+                  <a:srgbClr val="FFFFFF"/>
+                </a:solidFill>
+                <a:latin typeface="Calibri" pitchFamily="34" charset="0"/>
+                <a:ea typeface="Calibri" pitchFamily="34" charset="-122"/>
+                <a:cs typeface="Calibri" pitchFamily="34" charset="-120"/>
+              </a:rPr>
+              <a:t>M6</a:t>
+            </a:r>
+            <a:endParaRPr lang="en-US" sz="1200" dirty="0"/>
+          </a:p>
+        </p:txBody>
+      </p:sp>
+      <p:sp>
+        <p:nvSpPr>
+          <p:cNvPr id="54" name="Text 52"/>
+          <p:cNvSpPr/>
+          <p:nvPr/>
+        </p:nvSpPr>
+        <p:spPr>
+          <a:xfrm>
+            <a:off x="5532120" y="3200400"/>
+            <a:ext cx="2011680" cy="228600"/>
+          </a:xfrm>
+          <a:prstGeom prst="rect">
+            <a:avLst/>
+          </a:prstGeom>
+          <a:noFill/>
+          <a:ln/>
+        </p:spPr>
+        <p:txBody>
+          <a:bodyPr wrap="square" lIns="0" tIns="0" rIns="0" bIns="0" rtlCol="0" anchor="ctr"/>
+          <a:lstStyle/>
+          <a:p>
+            <a:pPr marL="0" indent="0">
+              <a:buNone/>
+            </a:pPr>
+            <a:r>
+              <a:rPr lang="en-US" sz="1300" b="1" dirty="0">
+                <a:solidFill>
+                  <a:srgbClr val="0F1B2D"/>
+                </a:solidFill>
+                <a:latin typeface="Trebuchet MS" pitchFamily="34" charset="0"/>
+                <a:ea typeface="Trebuchet MS" pitchFamily="34" charset="-122"/>
+                <a:cs typeface="Trebuchet MS" pitchFamily="34" charset="-120"/>
+              </a:rPr>
+              <a:t>Validation</a:t>
+            </a:r>
+            <a:endParaRPr lang="en-US" sz="1300" dirty="0"/>
+          </a:p>
+        </p:txBody>
+      </p:sp>
+      <p:sp>
+        <p:nvSpPr>
+          <p:cNvPr id="55" name="Text 53"/>
+          <p:cNvSpPr/>
+          <p:nvPr/>
+        </p:nvSpPr>
+        <p:spPr>
+          <a:xfrm>
+            <a:off x="5532120" y="3419856"/>
+            <a:ext cx="2743200" cy="201168"/>
+          </a:xfrm>
+          <a:prstGeom prst="rect">
+            <a:avLst/>
+          </a:prstGeom>
+          <a:noFill/>
+          <a:ln/>
+        </p:spPr>
+        <p:txBody>
+          <a:bodyPr wrap="square" lIns="0" tIns="0" rIns="0" bIns="0" rtlCol="0" anchor="ctr"/>
+          <a:lstStyle/>
+          <a:p>
+            <a:pPr marL="0" indent="0">
+              <a:buNone/>
+            </a:pPr>
+            <a:r>
+              <a:rPr lang="en-US" sz="900" dirty="0">
+                <a:solidFill>
+                  <a:srgbClr val="334155"/>
+                </a:solidFill>
+                <a:latin typeface="Calibri" pitchFamily="34" charset="0"/>
+                <a:ea typeface="Calibri" pitchFamily="34" charset="-122"/>
+                <a:cs typeface="Calibri" pitchFamily="34" charset="-120"/>
+              </a:rPr>
+              <a:t>Tests bout en bout + test PRA complet</a:t>
+            </a:r>
+            <a:endParaRPr lang="en-US" sz="900" dirty="0"/>
+          </a:p>
+        </p:txBody>
+      </p:sp>
+      <p:sp>
+        <p:nvSpPr>
+          <p:cNvPr id="56" name="Shape 54"/>
+          <p:cNvSpPr/>
+          <p:nvPr/>
+        </p:nvSpPr>
+        <p:spPr>
+          <a:xfrm>
+            <a:off x="7772400" y="3218688"/>
+            <a:ext cx="1005840" cy="274320"/>
+          </a:xfrm>
+          <a:prstGeom prst="rect">
+            <a:avLst/>
+          </a:prstGeom>
+          <a:solidFill>
+            <a:srgbClr val="F0F4F8"/>
+          </a:solidFill>
+          <a:ln/>
+        </p:spPr>
+        <p:txBody>
+          <a:bodyPr/>
+          <a:lstStyle/>
+          <a:p>
+            <a:endParaRPr lang="fr-FR"/>
+          </a:p>
+        </p:txBody>
+      </p:sp>
+      <p:sp>
+        <p:nvSpPr>
+          <p:cNvPr id="57" name="Text 55"/>
+          <p:cNvSpPr/>
+          <p:nvPr/>
+        </p:nvSpPr>
+        <p:spPr>
+          <a:xfrm>
+            <a:off x="7772400" y="3218688"/>
+            <a:ext cx="1005840" cy="274320"/>
+          </a:xfrm>
+          <a:prstGeom prst="rect">
+            <a:avLst/>
+          </a:prstGeom>
+          <a:noFill/>
+          <a:ln/>
+        </p:spPr>
+        <p:txBody>
+          <a:bodyPr wrap="square" rtlCol="0" anchor="ctr"/>
+          <a:lstStyle/>
+          <a:p>
+            <a:pPr marL="0" indent="0" algn="ctr">
+              <a:buNone/>
+            </a:pPr>
+            <a:r>
+              <a:rPr lang="en-US" sz="750" dirty="0">
+                <a:solidFill>
+                  <a:srgbClr val="0F1B2D"/>
+                </a:solidFill>
+                <a:latin typeface="Calibri" pitchFamily="34" charset="0"/>
+                <a:ea typeface="Calibri" pitchFamily="34" charset="-122"/>
+                <a:cs typeface="Calibri" pitchFamily="34" charset="-120"/>
+              </a:rPr>
+              <a:t>1 WE (S6)</a:t>
+            </a:r>
+            <a:endParaRPr lang="en-US" sz="750" dirty="0"/>
+          </a:p>
+        </p:txBody>
+      </p:sp>
+      <p:sp>
+        <p:nvSpPr>
+          <p:cNvPr id="58" name="Text 56"/>
+          <p:cNvSpPr/>
+          <p:nvPr/>
+        </p:nvSpPr>
+        <p:spPr>
+          <a:xfrm>
+            <a:off x="5532120" y="3675888"/>
+            <a:ext cx="3200400" cy="292608"/>
+          </a:xfrm>
+          <a:prstGeom prst="rect">
+            <a:avLst/>
+          </a:prstGeom>
+          <a:noFill/>
+          <a:ln/>
+        </p:spPr>
+        <p:txBody>
+          <a:bodyPr wrap="square" lIns="0" tIns="0" rIns="0" bIns="0" rtlCol="0" anchor="ctr"/>
+          <a:lstStyle/>
+          <a:p>
+            <a:pPr marL="0" indent="0">
+              <a:buNone/>
+            </a:pPr>
+            <a:r>
+              <a:rPr lang="en-US" sz="800" i="1" dirty="0">
+                <a:solidFill>
+                  <a:srgbClr val="94A3B8"/>
+                </a:solidFill>
+                <a:latin typeface="Calibri" pitchFamily="34" charset="0"/>
+                <a:ea typeface="Calibri" pitchFamily="34" charset="-122"/>
+                <a:cs typeface="Calibri" pitchFamily="34" charset="-120"/>
+              </a:rPr>
+              <a:t>↩ Non applicable (tests uniquement)</a:t>
+            </a:r>
+            <a:endParaRPr lang="en-US" sz="800" dirty="0"/>
+          </a:p>
+        </p:txBody>
+      </p:sp>
+      <p:sp>
+        <p:nvSpPr>
+          <p:cNvPr id="59" name="Shape 57"/>
+          <p:cNvSpPr/>
+          <p:nvPr/>
+        </p:nvSpPr>
+        <p:spPr>
+          <a:xfrm>
+            <a:off x="365760" y="3931920"/>
+            <a:ext cx="8412480" cy="274320"/>
+          </a:xfrm>
+          <a:prstGeom prst="rect">
+            <a:avLst/>
+          </a:prstGeom>
+          <a:solidFill>
+            <a:srgbClr val="1A2744"/>
+          </a:solidFill>
+          <a:ln/>
+        </p:spPr>
+        <p:txBody>
+          <a:bodyPr/>
+          <a:lstStyle/>
+          <a:p>
+            <a:endParaRPr lang="fr-FR"/>
+          </a:p>
+        </p:txBody>
+      </p:sp>
+      <p:sp>
+        <p:nvSpPr>
+          <p:cNvPr id="60" name="Text 58"/>
+          <p:cNvSpPr/>
+          <p:nvPr/>
+        </p:nvSpPr>
+        <p:spPr>
+          <a:xfrm>
+            <a:off x="365760" y="3931920"/>
+            <a:ext cx="8412480" cy="274320"/>
+          </a:xfrm>
+          <a:prstGeom prst="rect">
+            <a:avLst/>
+          </a:prstGeom>
+          <a:noFill/>
+          <a:ln/>
+        </p:spPr>
+        <p:txBody>
+          <a:bodyPr wrap="square" rtlCol="0" anchor="ctr"/>
+          <a:lstStyle/>
+          <a:p>
+            <a:pPr marL="0" indent="0" algn="ctr">
+              <a:buNone/>
+            </a:pPr>
+            <a:r>
+              <a:rPr lang="en-US" sz="1000" b="1" dirty="0">
+                <a:solidFill>
+                  <a:srgbClr val="FFFFFF"/>
+                </a:solidFill>
+                <a:latin typeface="Calibri" pitchFamily="34" charset="0"/>
+                <a:ea typeface="Calibri" pitchFamily="34" charset="-122"/>
+                <a:cs typeface="Calibri" pitchFamily="34" charset="-120"/>
+              </a:rPr>
+              <a:t>Planning : 6 semaines — interventions nocturnes et week-ends uniquement</a:t>
+            </a:r>
+            <a:endParaRPr lang="en-US" sz="1000" dirty="0"/>
+          </a:p>
+        </p:txBody>
+      </p:sp>
+      <p:sp>
+        <p:nvSpPr>
+          <p:cNvPr id="61" name="Shape 59"/>
+          <p:cNvSpPr/>
+          <p:nvPr/>
+        </p:nvSpPr>
+        <p:spPr>
+          <a:xfrm>
+            <a:off x="914400" y="4206240"/>
+            <a:ext cx="1280160" cy="201168"/>
+          </a:xfrm>
+          <a:prstGeom prst="rect">
+            <a:avLst/>
+          </a:prstGeom>
+          <a:solidFill>
+            <a:srgbClr val="F0F4F8"/>
+          </a:solidFill>
+          <a:ln w="6350">
+            <a:solidFill>
+              <a:srgbClr val="E2E8F0"/>
+            </a:solidFill>
+            <a:prstDash val="solid"/>
+          </a:ln>
+        </p:spPr>
+        <p:txBody>
+          <a:bodyPr/>
+          <a:lstStyle/>
+          <a:p>
+            <a:endParaRPr lang="fr-FR"/>
+          </a:p>
+        </p:txBody>
+      </p:sp>
+      <p:sp>
+        <p:nvSpPr>
+          <p:cNvPr id="62" name="Text 60"/>
+          <p:cNvSpPr/>
+          <p:nvPr/>
+        </p:nvSpPr>
+        <p:spPr>
+          <a:xfrm>
+            <a:off x="914400" y="4206240"/>
+            <a:ext cx="1280160" cy="201168"/>
+          </a:xfrm>
+          <a:prstGeom prst="rect">
+            <a:avLst/>
+          </a:prstGeom>
+          <a:noFill/>
+          <a:ln/>
+        </p:spPr>
+        <p:txBody>
+          <a:bodyPr wrap="square" rtlCol="0" anchor="ctr"/>
+          <a:lstStyle/>
+          <a:p>
+            <a:pPr marL="0" indent="0" algn="ctr">
+              <a:buNone/>
+            </a:pPr>
+            <a:r>
+              <a:rPr lang="en-US" sz="800" b="1" dirty="0">
+                <a:solidFill>
+                  <a:srgbClr val="0F1B2D"/>
+                </a:solidFill>
+                <a:latin typeface="Calibri" pitchFamily="34" charset="0"/>
+                <a:ea typeface="Calibri" pitchFamily="34" charset="-122"/>
+                <a:cs typeface="Calibri" pitchFamily="34" charset="-120"/>
+              </a:rPr>
+              <a:t>S1</a:t>
+            </a:r>
+            <a:endParaRPr lang="en-US" sz="800" dirty="0"/>
+          </a:p>
+        </p:txBody>
+      </p:sp>
+      <p:sp>
+        <p:nvSpPr>
+          <p:cNvPr id="63" name="Shape 61"/>
+          <p:cNvSpPr/>
+          <p:nvPr/>
+        </p:nvSpPr>
+        <p:spPr>
+          <a:xfrm>
+            <a:off x="2194560" y="4206240"/>
+            <a:ext cx="1280160" cy="201168"/>
+          </a:xfrm>
+          <a:prstGeom prst="rect">
+            <a:avLst/>
+          </a:prstGeom>
+          <a:solidFill>
+            <a:srgbClr val="F0F4F8"/>
+          </a:solidFill>
+          <a:ln w="6350">
+            <a:solidFill>
+              <a:srgbClr val="E2E8F0"/>
+            </a:solidFill>
+            <a:prstDash val="solid"/>
+          </a:ln>
+        </p:spPr>
+        <p:txBody>
+          <a:bodyPr/>
+          <a:lstStyle/>
+          <a:p>
+            <a:endParaRPr lang="fr-FR"/>
+          </a:p>
+        </p:txBody>
+      </p:sp>
+      <p:sp>
+        <p:nvSpPr>
+          <p:cNvPr id="64" name="Text 62"/>
+          <p:cNvSpPr/>
+          <p:nvPr/>
+        </p:nvSpPr>
+        <p:spPr>
+          <a:xfrm>
+            <a:off x="2194560" y="4206240"/>
+            <a:ext cx="1280160" cy="201168"/>
+          </a:xfrm>
+          <a:prstGeom prst="rect">
+            <a:avLst/>
+          </a:prstGeom>
+          <a:noFill/>
+          <a:ln/>
+        </p:spPr>
+        <p:txBody>
+          <a:bodyPr wrap="square" rtlCol="0" anchor="ctr"/>
+          <a:lstStyle/>
+          <a:p>
+            <a:pPr marL="0" indent="0" algn="ctr">
+              <a:buNone/>
+            </a:pPr>
+            <a:r>
+              <a:rPr lang="en-US" sz="800" b="1" dirty="0">
+                <a:solidFill>
+                  <a:srgbClr val="0F1B2D"/>
+                </a:solidFill>
+                <a:latin typeface="Calibri" pitchFamily="34" charset="0"/>
+                <a:ea typeface="Calibri" pitchFamily="34" charset="-122"/>
+                <a:cs typeface="Calibri" pitchFamily="34" charset="-120"/>
+              </a:rPr>
+              <a:t>S2</a:t>
+            </a:r>
+            <a:endParaRPr lang="en-US" sz="800" dirty="0"/>
+          </a:p>
+        </p:txBody>
+      </p:sp>
+      <p:sp>
+        <p:nvSpPr>
+          <p:cNvPr id="65" name="Shape 63"/>
+          <p:cNvSpPr/>
+          <p:nvPr/>
+        </p:nvSpPr>
+        <p:spPr>
+          <a:xfrm>
+            <a:off x="3474720" y="4206240"/>
+            <a:ext cx="1280160" cy="201168"/>
+          </a:xfrm>
+          <a:prstGeom prst="rect">
+            <a:avLst/>
+          </a:prstGeom>
+          <a:solidFill>
+            <a:srgbClr val="F0F4F8"/>
+          </a:solidFill>
+          <a:ln w="6350">
+            <a:solidFill>
+              <a:srgbClr val="E2E8F0"/>
+            </a:solidFill>
+            <a:prstDash val="solid"/>
+          </a:ln>
+        </p:spPr>
+        <p:txBody>
+          <a:bodyPr/>
+          <a:lstStyle/>
+          <a:p>
+            <a:endParaRPr lang="fr-FR"/>
+          </a:p>
+        </p:txBody>
+      </p:sp>
+      <p:sp>
+        <p:nvSpPr>
+          <p:cNvPr id="66" name="Text 64"/>
+          <p:cNvSpPr/>
+          <p:nvPr/>
+        </p:nvSpPr>
+        <p:spPr>
+          <a:xfrm>
+            <a:off x="3474720" y="4206240"/>
+            <a:ext cx="1280160" cy="201168"/>
+          </a:xfrm>
+          <a:prstGeom prst="rect">
+            <a:avLst/>
+          </a:prstGeom>
+          <a:noFill/>
+          <a:ln/>
+        </p:spPr>
+        <p:txBody>
+          <a:bodyPr wrap="square" rtlCol="0" anchor="ctr"/>
+          <a:lstStyle/>
+          <a:p>
+            <a:pPr marL="0" indent="0" algn="ctr">
+              <a:buNone/>
+            </a:pPr>
+            <a:r>
+              <a:rPr lang="en-US" sz="800" b="1" dirty="0">
+                <a:solidFill>
+                  <a:srgbClr val="0F1B2D"/>
+                </a:solidFill>
+                <a:latin typeface="Calibri" pitchFamily="34" charset="0"/>
+                <a:ea typeface="Calibri" pitchFamily="34" charset="-122"/>
+                <a:cs typeface="Calibri" pitchFamily="34" charset="-120"/>
+              </a:rPr>
+              <a:t>S3</a:t>
+            </a:r>
+            <a:endParaRPr lang="en-US" sz="800" dirty="0"/>
+          </a:p>
+        </p:txBody>
+      </p:sp>
+      <p:sp>
+        <p:nvSpPr>
+          <p:cNvPr id="67" name="Shape 65"/>
+          <p:cNvSpPr/>
+          <p:nvPr/>
+        </p:nvSpPr>
+        <p:spPr>
+          <a:xfrm>
+            <a:off x="4754880" y="4206240"/>
+            <a:ext cx="1280160" cy="201168"/>
+          </a:xfrm>
+          <a:prstGeom prst="rect">
+            <a:avLst/>
+          </a:prstGeom>
+          <a:solidFill>
+            <a:srgbClr val="F0F4F8"/>
+          </a:solidFill>
+          <a:ln w="6350">
+            <a:solidFill>
+              <a:srgbClr val="E2E8F0"/>
+            </a:solidFill>
+            <a:prstDash val="solid"/>
+          </a:ln>
+        </p:spPr>
+        <p:txBody>
+          <a:bodyPr/>
+          <a:lstStyle/>
+          <a:p>
+            <a:endParaRPr lang="fr-FR"/>
+          </a:p>
+        </p:txBody>
+      </p:sp>
+      <p:sp>
+        <p:nvSpPr>
+          <p:cNvPr id="68" name="Text 66"/>
+          <p:cNvSpPr/>
+          <p:nvPr/>
+        </p:nvSpPr>
+        <p:spPr>
+          <a:xfrm>
+            <a:off x="4754880" y="4206240"/>
+            <a:ext cx="1280160" cy="201168"/>
+          </a:xfrm>
+          <a:prstGeom prst="rect">
+            <a:avLst/>
+          </a:prstGeom>
+          <a:noFill/>
+          <a:ln/>
+        </p:spPr>
+        <p:txBody>
+          <a:bodyPr wrap="square" rtlCol="0" anchor="ctr"/>
+          <a:lstStyle/>
+          <a:p>
+            <a:pPr marL="0" indent="0" algn="ctr">
+              <a:buNone/>
+            </a:pPr>
+            <a:r>
+              <a:rPr lang="en-US" sz="800" b="1" dirty="0">
+                <a:solidFill>
+                  <a:srgbClr val="0F1B2D"/>
+                </a:solidFill>
+                <a:latin typeface="Calibri" pitchFamily="34" charset="0"/>
+                <a:ea typeface="Calibri" pitchFamily="34" charset="-122"/>
+                <a:cs typeface="Calibri" pitchFamily="34" charset="-120"/>
+              </a:rPr>
+              <a:t>S4</a:t>
+            </a:r>
+            <a:endParaRPr lang="en-US" sz="800" dirty="0"/>
+          </a:p>
+        </p:txBody>
+      </p:sp>
+      <p:sp>
+        <p:nvSpPr>
+          <p:cNvPr id="69" name="Shape 67"/>
+          <p:cNvSpPr/>
+          <p:nvPr/>
+        </p:nvSpPr>
+        <p:spPr>
+          <a:xfrm>
+            <a:off x="6035040" y="4206240"/>
+            <a:ext cx="1280160" cy="201168"/>
+          </a:xfrm>
+          <a:prstGeom prst="rect">
+            <a:avLst/>
+          </a:prstGeom>
+          <a:solidFill>
+            <a:srgbClr val="F0F4F8"/>
+          </a:solidFill>
+          <a:ln w="6350">
+            <a:solidFill>
+              <a:srgbClr val="E2E8F0"/>
+            </a:solidFill>
+            <a:prstDash val="solid"/>
+          </a:ln>
+        </p:spPr>
+        <p:txBody>
+          <a:bodyPr/>
+          <a:lstStyle/>
+          <a:p>
+            <a:endParaRPr lang="fr-FR"/>
+          </a:p>
+        </p:txBody>
+      </p:sp>
+      <p:sp>
+        <p:nvSpPr>
+          <p:cNvPr id="70" name="Text 68"/>
+          <p:cNvSpPr/>
+          <p:nvPr/>
+        </p:nvSpPr>
+        <p:spPr>
+          <a:xfrm>
+            <a:off x="6035040" y="4206240"/>
+            <a:ext cx="1280160" cy="201168"/>
+          </a:xfrm>
+          <a:prstGeom prst="rect">
+            <a:avLst/>
+          </a:prstGeom>
+          <a:noFill/>
+          <a:ln/>
+        </p:spPr>
+        <p:txBody>
+          <a:bodyPr wrap="square" rtlCol="0" anchor="ctr"/>
+          <a:lstStyle/>
+          <a:p>
+            <a:pPr marL="0" indent="0" algn="ctr">
+              <a:buNone/>
+            </a:pPr>
+            <a:r>
+              <a:rPr lang="en-US" sz="800" b="1" dirty="0">
+                <a:solidFill>
+                  <a:srgbClr val="0F1B2D"/>
+                </a:solidFill>
+                <a:latin typeface="Calibri" pitchFamily="34" charset="0"/>
+                <a:ea typeface="Calibri" pitchFamily="34" charset="-122"/>
+                <a:cs typeface="Calibri" pitchFamily="34" charset="-120"/>
+              </a:rPr>
+              <a:t>S5</a:t>
+            </a:r>
+            <a:endParaRPr lang="en-US" sz="800" dirty="0"/>
+          </a:p>
+        </p:txBody>
+      </p:sp>
+      <p:sp>
+        <p:nvSpPr>
+          <p:cNvPr id="71" name="Shape 69"/>
+          <p:cNvSpPr/>
+          <p:nvPr/>
+        </p:nvSpPr>
+        <p:spPr>
+          <a:xfrm>
+            <a:off x="7315200" y="4206240"/>
+            <a:ext cx="1280160" cy="201168"/>
+          </a:xfrm>
+          <a:prstGeom prst="rect">
+            <a:avLst/>
+          </a:prstGeom>
+          <a:solidFill>
+            <a:srgbClr val="F0F4F8"/>
+          </a:solidFill>
+          <a:ln w="6350">
+            <a:solidFill>
+              <a:srgbClr val="E2E8F0"/>
+            </a:solidFill>
+            <a:prstDash val="solid"/>
+          </a:ln>
+        </p:spPr>
+        <p:txBody>
+          <a:bodyPr/>
+          <a:lstStyle/>
+          <a:p>
+            <a:endParaRPr lang="fr-FR"/>
+          </a:p>
+        </p:txBody>
+      </p:sp>
+      <p:sp>
+        <p:nvSpPr>
+          <p:cNvPr id="72" name="Text 70"/>
+          <p:cNvSpPr/>
+          <p:nvPr/>
+        </p:nvSpPr>
+        <p:spPr>
+          <a:xfrm>
+            <a:off x="7315200" y="4206240"/>
+            <a:ext cx="1280160" cy="201168"/>
+          </a:xfrm>
+          <a:prstGeom prst="rect">
+            <a:avLst/>
+          </a:prstGeom>
+          <a:noFill/>
+          <a:ln/>
+        </p:spPr>
+        <p:txBody>
+          <a:bodyPr wrap="square" rtlCol="0" anchor="ctr"/>
+          <a:lstStyle/>
+          <a:p>
+            <a:pPr marL="0" indent="0" algn="ctr">
+              <a:buNone/>
+            </a:pPr>
+            <a:r>
+              <a:rPr lang="en-US" sz="800" b="1" dirty="0">
+                <a:solidFill>
+                  <a:srgbClr val="0F1B2D"/>
+                </a:solidFill>
+                <a:latin typeface="Calibri" pitchFamily="34" charset="0"/>
+                <a:ea typeface="Calibri" pitchFamily="34" charset="-122"/>
+                <a:cs typeface="Calibri" pitchFamily="34" charset="-120"/>
+              </a:rPr>
+              <a:t>S6</a:t>
+            </a:r>
+            <a:endParaRPr lang="en-US" sz="800" dirty="0"/>
+          </a:p>
+        </p:txBody>
+      </p:sp>
+      <p:sp>
+        <p:nvSpPr>
+          <p:cNvPr id="73" name="Shape 71"/>
+          <p:cNvSpPr/>
+          <p:nvPr/>
+        </p:nvSpPr>
+        <p:spPr>
+          <a:xfrm>
+            <a:off x="914400" y="4443984"/>
+            <a:ext cx="2560320" cy="100584"/>
+          </a:xfrm>
+          <a:prstGeom prst="rect">
+            <a:avLst/>
+          </a:prstGeom>
+          <a:solidFill>
+            <a:srgbClr val="F97316"/>
+          </a:solidFill>
+          <a:ln/>
+        </p:spPr>
+        <p:txBody>
+          <a:bodyPr/>
+          <a:lstStyle/>
+          <a:p>
+            <a:endParaRPr lang="fr-FR"/>
+          </a:p>
+        </p:txBody>
+      </p:sp>
+      <p:sp>
+        <p:nvSpPr>
+          <p:cNvPr id="74" name="Text 72"/>
+          <p:cNvSpPr/>
+          <p:nvPr/>
+        </p:nvSpPr>
+        <p:spPr>
+          <a:xfrm>
+            <a:off x="914400" y="4443984"/>
+            <a:ext cx="2560320" cy="100584"/>
+          </a:xfrm>
+          <a:prstGeom prst="rect">
+            <a:avLst/>
+          </a:prstGeom>
+          <a:noFill/>
+          <a:ln/>
+        </p:spPr>
+        <p:txBody>
+          <a:bodyPr wrap="square" rtlCol="0" anchor="ctr"/>
+          <a:lstStyle/>
+          <a:p>
+            <a:pPr marL="0" indent="0" algn="ctr">
+              <a:buNone/>
+            </a:pPr>
+            <a:r>
+              <a:rPr lang="en-US" sz="600" b="1" dirty="0">
+                <a:solidFill>
+                  <a:srgbClr val="FFFFFF"/>
+                </a:solidFill>
+                <a:latin typeface="Calibri" pitchFamily="34" charset="0"/>
+                <a:ea typeface="Calibri" pitchFamily="34" charset="-122"/>
+                <a:cs typeface="Calibri" pitchFamily="34" charset="-120"/>
+              </a:rPr>
+              <a:t>M1</a:t>
+            </a:r>
+            <a:endParaRPr lang="en-US" sz="600" dirty="0"/>
+          </a:p>
+        </p:txBody>
+      </p:sp>
+      <p:sp>
+        <p:nvSpPr>
+          <p:cNvPr id="75" name="Shape 73"/>
+          <p:cNvSpPr/>
+          <p:nvPr/>
+        </p:nvSpPr>
+        <p:spPr>
+          <a:xfrm>
+            <a:off x="2834640" y="4572000"/>
+            <a:ext cx="1920240" cy="100584"/>
+          </a:xfrm>
+          <a:prstGeom prst="rect">
+            <a:avLst/>
+          </a:prstGeom>
+          <a:solidFill>
+            <a:srgbClr val="10B981"/>
+          </a:solidFill>
+          <a:ln/>
+        </p:spPr>
+        <p:txBody>
+          <a:bodyPr/>
+          <a:lstStyle/>
+          <a:p>
+            <a:endParaRPr lang="fr-FR"/>
+          </a:p>
+        </p:txBody>
+      </p:sp>
+      <p:sp>
+        <p:nvSpPr>
+          <p:cNvPr id="76" name="Text 74"/>
+          <p:cNvSpPr/>
+          <p:nvPr/>
+        </p:nvSpPr>
+        <p:spPr>
+          <a:xfrm>
+            <a:off x="2834640" y="4572000"/>
+            <a:ext cx="1920240" cy="100584"/>
+          </a:xfrm>
+          <a:prstGeom prst="rect">
+            <a:avLst/>
+          </a:prstGeom>
+          <a:noFill/>
+          <a:ln/>
+        </p:spPr>
+        <p:txBody>
+          <a:bodyPr wrap="square" rtlCol="0" anchor="ctr"/>
+          <a:lstStyle/>
+          <a:p>
+            <a:pPr marL="0" indent="0" algn="ctr">
+              <a:buNone/>
+            </a:pPr>
+            <a:r>
+              <a:rPr lang="en-US" sz="600" b="1" dirty="0">
+                <a:solidFill>
+                  <a:srgbClr val="FFFFFF"/>
+                </a:solidFill>
+                <a:latin typeface="Calibri" pitchFamily="34" charset="0"/>
+                <a:ea typeface="Calibri" pitchFamily="34" charset="-122"/>
+                <a:cs typeface="Calibri" pitchFamily="34" charset="-120"/>
+              </a:rPr>
+              <a:t>M2</a:t>
+            </a:r>
+            <a:endParaRPr lang="en-US" sz="600" dirty="0"/>
+          </a:p>
+        </p:txBody>
+      </p:sp>
+      <p:sp>
+        <p:nvSpPr>
+          <p:cNvPr id="77" name="Shape 75"/>
+          <p:cNvSpPr/>
+          <p:nvPr/>
+        </p:nvSpPr>
+        <p:spPr>
+          <a:xfrm>
+            <a:off x="4114800" y="4700016"/>
+            <a:ext cx="640080" cy="100584"/>
+          </a:xfrm>
+          <a:prstGeom prst="rect">
+            <a:avLst/>
+          </a:prstGeom>
+          <a:solidFill>
+            <a:srgbClr val="EF4444"/>
+          </a:solidFill>
+          <a:ln/>
+        </p:spPr>
+        <p:txBody>
+          <a:bodyPr/>
+          <a:lstStyle/>
+          <a:p>
+            <a:endParaRPr lang="fr-FR"/>
+          </a:p>
+        </p:txBody>
+      </p:sp>
+      <p:sp>
+        <p:nvSpPr>
+          <p:cNvPr id="78" name="Text 76"/>
+          <p:cNvSpPr/>
+          <p:nvPr/>
+        </p:nvSpPr>
+        <p:spPr>
+          <a:xfrm>
+            <a:off x="4114800" y="4700016"/>
+            <a:ext cx="640080" cy="100584"/>
+          </a:xfrm>
+          <a:prstGeom prst="rect">
+            <a:avLst/>
+          </a:prstGeom>
+          <a:noFill/>
+          <a:ln/>
+        </p:spPr>
+        <p:txBody>
+          <a:bodyPr wrap="square" rtlCol="0" anchor="ctr"/>
+          <a:lstStyle/>
+          <a:p>
+            <a:pPr marL="0" indent="0" algn="ctr">
+              <a:buNone/>
+            </a:pPr>
+            <a:r>
+              <a:rPr lang="en-US" sz="600" b="1" dirty="0">
+                <a:solidFill>
+                  <a:srgbClr val="FFFFFF"/>
+                </a:solidFill>
+                <a:latin typeface="Calibri" pitchFamily="34" charset="0"/>
+                <a:ea typeface="Calibri" pitchFamily="34" charset="-122"/>
+                <a:cs typeface="Calibri" pitchFamily="34" charset="-120"/>
+              </a:rPr>
+              <a:t>M3</a:t>
+            </a:r>
+            <a:endParaRPr lang="en-US" sz="600" dirty="0"/>
+          </a:p>
+        </p:txBody>
+      </p:sp>
+      <p:sp>
+        <p:nvSpPr>
+          <p:cNvPr id="79" name="Shape 77"/>
+          <p:cNvSpPr/>
+          <p:nvPr/>
+        </p:nvSpPr>
+        <p:spPr>
+          <a:xfrm>
+            <a:off x="4754880" y="4828032"/>
+            <a:ext cx="1280160" cy="100584"/>
+          </a:xfrm>
+          <a:prstGeom prst="rect">
+            <a:avLst/>
+          </a:prstGeom>
+          <a:solidFill>
+            <a:srgbClr val="F97316"/>
+          </a:solidFill>
+          <a:ln/>
+        </p:spPr>
+        <p:txBody>
+          <a:bodyPr/>
+          <a:lstStyle/>
+          <a:p>
+            <a:endParaRPr lang="fr-FR"/>
+          </a:p>
+        </p:txBody>
+      </p:sp>
+      <p:sp>
+        <p:nvSpPr>
+          <p:cNvPr id="80" name="Text 78"/>
+          <p:cNvSpPr/>
+          <p:nvPr/>
+        </p:nvSpPr>
+        <p:spPr>
+          <a:xfrm>
+            <a:off x="4754880" y="4828032"/>
+            <a:ext cx="1280160" cy="100584"/>
+          </a:xfrm>
+          <a:prstGeom prst="rect">
+            <a:avLst/>
+          </a:prstGeom>
+          <a:noFill/>
+          <a:ln/>
+        </p:spPr>
+        <p:txBody>
+          <a:bodyPr wrap="square" rtlCol="0" anchor="ctr"/>
+          <a:lstStyle/>
+          <a:p>
+            <a:pPr marL="0" indent="0" algn="ctr">
+              <a:buNone/>
+            </a:pPr>
+            <a:r>
+              <a:rPr lang="en-US" sz="600" b="1" dirty="0">
+                <a:solidFill>
+                  <a:srgbClr val="FFFFFF"/>
+                </a:solidFill>
+                <a:latin typeface="Calibri" pitchFamily="34" charset="0"/>
+                <a:ea typeface="Calibri" pitchFamily="34" charset="-122"/>
+                <a:cs typeface="Calibri" pitchFamily="34" charset="-120"/>
+              </a:rPr>
+              <a:t>M4</a:t>
+            </a:r>
+            <a:endParaRPr lang="en-US" sz="600" dirty="0"/>
+          </a:p>
+        </p:txBody>
+      </p:sp>
+      <p:sp>
+        <p:nvSpPr>
+          <p:cNvPr id="81" name="Shape 79"/>
+          <p:cNvSpPr/>
+          <p:nvPr/>
+        </p:nvSpPr>
+        <p:spPr>
+          <a:xfrm>
+            <a:off x="6035040" y="4956048"/>
+            <a:ext cx="1280160" cy="100584"/>
+          </a:xfrm>
+          <a:prstGeom prst="rect">
+            <a:avLst/>
+          </a:prstGeom>
+          <a:solidFill>
+            <a:srgbClr val="F97316"/>
+          </a:solidFill>
+          <a:ln/>
+        </p:spPr>
+        <p:txBody>
+          <a:bodyPr/>
+          <a:lstStyle/>
+          <a:p>
+            <a:endParaRPr lang="fr-FR"/>
+          </a:p>
+        </p:txBody>
+      </p:sp>
+      <p:sp>
+        <p:nvSpPr>
+          <p:cNvPr id="82" name="Text 80"/>
+          <p:cNvSpPr/>
+          <p:nvPr/>
+        </p:nvSpPr>
+        <p:spPr>
+          <a:xfrm>
+            <a:off x="6035040" y="4956048"/>
+            <a:ext cx="1280160" cy="100584"/>
+          </a:xfrm>
+          <a:prstGeom prst="rect">
+            <a:avLst/>
+          </a:prstGeom>
+          <a:noFill/>
+          <a:ln/>
+        </p:spPr>
+        <p:txBody>
+          <a:bodyPr wrap="square" rtlCol="0" anchor="ctr"/>
+          <a:lstStyle/>
+          <a:p>
+            <a:pPr marL="0" indent="0" algn="ctr">
+              <a:buNone/>
+            </a:pPr>
+            <a:r>
+              <a:rPr lang="en-US" sz="600" b="1" dirty="0">
+                <a:solidFill>
+                  <a:srgbClr val="FFFFFF"/>
+                </a:solidFill>
+                <a:latin typeface="Calibri" pitchFamily="34" charset="0"/>
+                <a:ea typeface="Calibri" pitchFamily="34" charset="-122"/>
+                <a:cs typeface="Calibri" pitchFamily="34" charset="-120"/>
+              </a:rPr>
+              <a:t>M5</a:t>
+            </a:r>
+            <a:endParaRPr lang="en-US" sz="600" dirty="0"/>
+          </a:p>
+        </p:txBody>
+      </p:sp>
+      <p:sp>
+        <p:nvSpPr>
+          <p:cNvPr id="83" name="Shape 81"/>
+          <p:cNvSpPr/>
+          <p:nvPr/>
+        </p:nvSpPr>
+        <p:spPr>
+          <a:xfrm>
+            <a:off x="7315200" y="5084064"/>
+            <a:ext cx="1280160" cy="100584"/>
+          </a:xfrm>
+          <a:prstGeom prst="rect">
+            <a:avLst/>
+          </a:prstGeom>
+          <a:solidFill>
+            <a:srgbClr val="10B981"/>
+          </a:solidFill>
+          <a:ln/>
+        </p:spPr>
+        <p:txBody>
+          <a:bodyPr/>
+          <a:lstStyle/>
+          <a:p>
+            <a:endParaRPr lang="fr-FR"/>
+          </a:p>
+        </p:txBody>
+      </p:sp>
+      <p:sp>
+        <p:nvSpPr>
+          <p:cNvPr id="84" name="Text 82"/>
+          <p:cNvSpPr/>
+          <p:nvPr/>
+        </p:nvSpPr>
+        <p:spPr>
+          <a:xfrm>
+            <a:off x="7315200" y="5084064"/>
+            <a:ext cx="1280160" cy="100584"/>
+          </a:xfrm>
+          <a:prstGeom prst="rect">
+            <a:avLst/>
+          </a:prstGeom>
+          <a:noFill/>
+          <a:ln/>
+        </p:spPr>
+        <p:txBody>
+          <a:bodyPr wrap="square" rtlCol="0" anchor="ctr"/>
+          <a:lstStyle/>
+          <a:p>
+            <a:pPr marL="0" indent="0" algn="ctr">
+              <a:buNone/>
+            </a:pPr>
+            <a:r>
+              <a:rPr lang="en-US" sz="600" b="1" dirty="0">
+                <a:solidFill>
+                  <a:srgbClr val="FFFFFF"/>
+                </a:solidFill>
+                <a:latin typeface="Calibri" pitchFamily="34" charset="0"/>
+                <a:ea typeface="Calibri" pitchFamily="34" charset="-122"/>
+                <a:cs typeface="Calibri" pitchFamily="34" charset="-120"/>
+              </a:rPr>
+              <a:t>M6</a:t>
+            </a:r>
+            <a:endParaRPr lang="en-US" sz="600" dirty="0"/>
+          </a:p>
+        </p:txBody>
+      </p:sp>
+    </p:spTree>
+  </p:cSld>
+  <p:clrMapOvr>
+    <a:masterClrMapping/>
+  </p:clrMapOvr>
+</p:sld>
+</file>
+
+<file path=ppt/slides/slide11.xml><?xml version="1.0" encoding="utf-8"?>
+<p:sld xmlns:a="http://schemas.openxmlformats.org/drawingml/2006/main" xmlns:r="http://schemas.openxmlformats.org/officeDocument/2006/relationships" xmlns:p="http://schemas.openxmlformats.org/presentationml/2006/main">
+  <p:cSld name="Slide 11">
+    <p:bg>
+      <p:bgPr>
+        <a:solidFill>
+          <a:srgbClr val="F0F4F8"/>
+        </a:solidFill>
+        <a:effectLst/>
+      </p:bgPr>
+    </p:bg>
+    <p:spTree>
+      <p:nvGrpSpPr>
+        <p:cNvPr id="1" name=""/>
+        <p:cNvGrpSpPr/>
+        <p:nvPr/>
+      </p:nvGrpSpPr>
+      <p:grpSpPr>
+        <a:xfrm>
+          <a:off x="0" y="0"/>
+          <a:ext cx="0" cy="0"/>
+          <a:chOff x="0" y="0"/>
+          <a:chExt cx="0" cy="0"/>
+        </a:xfrm>
+      </p:grpSpPr>
+      <p:sp>
+        <p:nvSpPr>
+          <p:cNvPr id="2" name="Shape 0"/>
+          <p:cNvSpPr/>
+          <p:nvPr/>
+        </p:nvSpPr>
+        <p:spPr>
+          <a:xfrm>
+            <a:off x="0" y="0"/>
+            <a:ext cx="9144000" cy="36576"/>
+          </a:xfrm>
+          <a:prstGeom prst="rect">
+            <a:avLst/>
+          </a:prstGeom>
+          <a:solidFill>
+            <a:srgbClr val="0891B2"/>
+          </a:solidFill>
+          <a:ln/>
+        </p:spPr>
+        <p:txBody>
+          <a:bodyPr/>
+          <a:lstStyle/>
+          <a:p>
+            <a:endParaRPr lang="fr-FR"/>
+          </a:p>
+        </p:txBody>
+      </p:sp>
+      <p:sp>
+        <p:nvSpPr>
+          <p:cNvPr id="3" name="Text 1"/>
+          <p:cNvSpPr/>
+          <p:nvPr/>
+        </p:nvSpPr>
+        <p:spPr>
+          <a:xfrm>
             <a:off x="640080" y="274320"/>
             <a:ext cx="3657600" cy="548640"/>
           </a:xfrm>
@@ -2885,9 +5875,9 @@
 </p:sld>
 </file>
 
-<file path=ppt/slides/slide11.xml><?xml version="1.0" encoding="utf-8"?>
+<file path=ppt/slides/slide12.xml><?xml version="1.0" encoding="utf-8"?>
 <p:sld xmlns:a="http://schemas.openxmlformats.org/drawingml/2006/main" xmlns:r="http://schemas.openxmlformats.org/officeDocument/2006/relationships" xmlns:p="http://schemas.openxmlformats.org/presentationml/2006/main">
-  <p:cSld name="Slide 11">
+  <p:cSld name="Slide 12">
     <p:bg>
       <p:bgPr>
         <a:solidFill>
@@ -3912,8 +6902,8 @@
         </p:nvSpPr>
         <p:spPr>
           <a:xfrm>
-            <a:off x="640080" y="1143000"/>
-            <a:ext cx="384048" cy="384048"/>
+            <a:off x="640080" y="1005840"/>
+            <a:ext cx="347472" cy="347472"/>
           </a:xfrm>
           <a:prstGeom prst="ellipse">
             <a:avLst/>
@@ -3939,8 +6929,8 @@
         </p:nvSpPr>
         <p:spPr>
           <a:xfrm>
-            <a:off x="640080" y="1143000"/>
-            <a:ext cx="384048" cy="384048"/>
+            <a:off x="640080" y="1005840"/>
+            <a:ext cx="347472" cy="347472"/>
           </a:xfrm>
           <a:prstGeom prst="rect">
             <a:avLst/>
@@ -3956,7 +6946,7 @@
               <a:buNone/>
             </a:pPr>
             <a:r>
-              <a:rPr lang="en-US" sz="1400" b="1" dirty="0">
+              <a:rPr lang="en-US" sz="1200" b="1" dirty="0">
                 <a:solidFill>
                   <a:srgbClr val="FFFFFF"/>
                 </a:solidFill>
@@ -3966,7 +6956,7 @@
               </a:rPr>
               <a:t>1</a:t>
             </a:r>
-            <a:endParaRPr lang="en-US" sz="1400" dirty="0"/>
+            <a:endParaRPr lang="en-US" sz="1200" dirty="0"/>
           </a:p>
         </p:txBody>
       </p:sp>
@@ -3978,8 +6968,8 @@
         </p:nvSpPr>
         <p:spPr>
           <a:xfrm>
-            <a:off x="1188720" y="1124712"/>
-            <a:ext cx="3200400" cy="237744"/>
+            <a:off x="1143000" y="987552"/>
+            <a:ext cx="3200400" cy="219456"/>
           </a:xfrm>
           <a:prstGeom prst="rect">
             <a:avLst/>
@@ -3995,7 +6985,7 @@
               <a:buNone/>
             </a:pPr>
             <a:r>
-              <a:rPr lang="en-US" sz="1500" b="1" dirty="0">
+              <a:rPr lang="en-US" sz="1400" b="1" dirty="0">
                 <a:solidFill>
                   <a:srgbClr val="0F1B2D"/>
                 </a:solidFill>
@@ -4005,7 +6995,7 @@
               </a:rPr>
               <a:t>Contexte client</a:t>
             </a:r>
-            <a:endParaRPr lang="en-US" sz="1500" dirty="0"/>
+            <a:endParaRPr lang="en-US" sz="1400" dirty="0"/>
           </a:p>
         </p:txBody>
       </p:sp>
@@ -4017,8 +7007,8 @@
         </p:nvSpPr>
         <p:spPr>
           <a:xfrm>
-            <a:off x="1188720" y="1344168"/>
-            <a:ext cx="4572000" cy="219456"/>
+            <a:off x="1143000" y="1188720"/>
+            <a:ext cx="4572000" cy="201168"/>
           </a:xfrm>
           <a:prstGeom prst="rect">
             <a:avLst/>
@@ -4034,7 +7024,7 @@
               <a:buNone/>
             </a:pPr>
             <a:r>
-              <a:rPr lang="en-US" sz="1100" dirty="0">
+              <a:rPr lang="en-US" sz="1000" dirty="0">
                 <a:solidFill>
                   <a:srgbClr val="334155"/>
                 </a:solidFill>
@@ -4044,7 +7034,7 @@
               </a:rPr>
               <a:t>NordTransit Logistics en bref</a:t>
             </a:r>
-            <a:endParaRPr lang="en-US" sz="1100" dirty="0"/>
+            <a:endParaRPr lang="en-US" sz="1000" dirty="0"/>
           </a:p>
         </p:txBody>
       </p:sp>
@@ -4056,8 +7046,8 @@
         </p:nvSpPr>
         <p:spPr>
           <a:xfrm>
-            <a:off x="640080" y="1673352"/>
-            <a:ext cx="384048" cy="384048"/>
+            <a:off x="640080" y="1463040"/>
+            <a:ext cx="347472" cy="347472"/>
           </a:xfrm>
           <a:prstGeom prst="ellipse">
             <a:avLst/>
@@ -4083,8 +7073,8 @@
         </p:nvSpPr>
         <p:spPr>
           <a:xfrm>
-            <a:off x="640080" y="1673352"/>
-            <a:ext cx="384048" cy="384048"/>
+            <a:off x="640080" y="1463040"/>
+            <a:ext cx="347472" cy="347472"/>
           </a:xfrm>
           <a:prstGeom prst="rect">
             <a:avLst/>
@@ -4100,7 +7090,7 @@
               <a:buNone/>
             </a:pPr>
             <a:r>
-              <a:rPr lang="en-US" sz="1400" b="1" dirty="0">
+              <a:rPr lang="en-US" sz="1200" b="1" dirty="0">
                 <a:solidFill>
                   <a:srgbClr val="FFFFFF"/>
                 </a:solidFill>
@@ -4110,7 +7100,7 @@
               </a:rPr>
               <a:t>2</a:t>
             </a:r>
-            <a:endParaRPr lang="en-US" sz="1400" dirty="0"/>
+            <a:endParaRPr lang="en-US" sz="1200" dirty="0"/>
           </a:p>
         </p:txBody>
       </p:sp>
@@ -4122,8 +7112,8 @@
         </p:nvSpPr>
         <p:spPr>
           <a:xfrm>
-            <a:off x="1188720" y="1655064"/>
-            <a:ext cx="3200400" cy="237744"/>
+            <a:off x="1143000" y="1444752"/>
+            <a:ext cx="3200400" cy="219456"/>
           </a:xfrm>
           <a:prstGeom prst="rect">
             <a:avLst/>
@@ -4139,7 +7129,7 @@
               <a:buNone/>
             </a:pPr>
             <a:r>
-              <a:rPr lang="en-US" sz="1500" b="1" dirty="0">
+              <a:rPr lang="en-US" sz="1400" b="1" dirty="0">
                 <a:solidFill>
                   <a:srgbClr val="0F1B2D"/>
                 </a:solidFill>
@@ -4149,7 +7139,7 @@
               </a:rPr>
               <a:t>Problématique</a:t>
             </a:r>
-            <a:endParaRPr lang="en-US" sz="1500" dirty="0"/>
+            <a:endParaRPr lang="en-US" sz="1400" dirty="0"/>
           </a:p>
         </p:txBody>
       </p:sp>
@@ -4161,8 +7151,8 @@
         </p:nvSpPr>
         <p:spPr>
           <a:xfrm>
-            <a:off x="1188720" y="1874520"/>
-            <a:ext cx="4572000" cy="219456"/>
+            <a:off x="1143000" y="1645920"/>
+            <a:ext cx="4572000" cy="201168"/>
           </a:xfrm>
           <a:prstGeom prst="rect">
             <a:avLst/>
@@ -4178,7 +7168,7 @@
               <a:buNone/>
             </a:pPr>
             <a:r>
-              <a:rPr lang="en-US" sz="1100" dirty="0">
+              <a:rPr lang="en-US" sz="1000" dirty="0">
                 <a:solidFill>
                   <a:srgbClr val="334155"/>
                 </a:solidFill>
@@ -4188,7 +7178,7 @@
               </a:rPr>
               <a:t>Points de douleur et risques identifiés</a:t>
             </a:r>
-            <a:endParaRPr lang="en-US" sz="1100" dirty="0"/>
+            <a:endParaRPr lang="en-US" sz="1000" dirty="0"/>
           </a:p>
         </p:txBody>
       </p:sp>
@@ -4200,8 +7190,8 @@
         </p:nvSpPr>
         <p:spPr>
           <a:xfrm>
-            <a:off x="640080" y="2203704"/>
-            <a:ext cx="384048" cy="384048"/>
+            <a:off x="640080" y="1920240"/>
+            <a:ext cx="347472" cy="347472"/>
           </a:xfrm>
           <a:prstGeom prst="ellipse">
             <a:avLst/>
@@ -4227,8 +7217,8 @@
         </p:nvSpPr>
         <p:spPr>
           <a:xfrm>
-            <a:off x="640080" y="2203704"/>
-            <a:ext cx="384048" cy="384048"/>
+            <a:off x="640080" y="1920240"/>
+            <a:ext cx="347472" cy="347472"/>
           </a:xfrm>
           <a:prstGeom prst="rect">
             <a:avLst/>
@@ -4244,7 +7234,7 @@
               <a:buNone/>
             </a:pPr>
             <a:r>
-              <a:rPr lang="en-US" sz="1400" b="1" dirty="0">
+              <a:rPr lang="en-US" sz="1200" b="1" dirty="0">
                 <a:solidFill>
                   <a:srgbClr val="FFFFFF"/>
                 </a:solidFill>
@@ -4254,7 +7244,7 @@
               </a:rPr>
               <a:t>3</a:t>
             </a:r>
-            <a:endParaRPr lang="en-US" sz="1400" dirty="0"/>
+            <a:endParaRPr lang="en-US" sz="1200" dirty="0"/>
           </a:p>
         </p:txBody>
       </p:sp>
@@ -4266,8 +7256,8 @@
         </p:nvSpPr>
         <p:spPr>
           <a:xfrm>
-            <a:off x="1188720" y="2185416"/>
-            <a:ext cx="3200400" cy="237744"/>
+            <a:off x="1143000" y="1901952"/>
+            <a:ext cx="3200400" cy="219456"/>
           </a:xfrm>
           <a:prstGeom prst="rect">
             <a:avLst/>
@@ -4283,7 +7273,7 @@
               <a:buNone/>
             </a:pPr>
             <a:r>
-              <a:rPr lang="en-US" sz="1500" b="1" dirty="0">
+              <a:rPr lang="en-US" sz="1400" b="1" dirty="0">
                 <a:solidFill>
                   <a:srgbClr val="0F1B2D"/>
                 </a:solidFill>
@@ -4293,7 +7283,7 @@
               </a:rPr>
               <a:t>Architecture cible</a:t>
             </a:r>
-            <a:endParaRPr lang="en-US" sz="1500" dirty="0"/>
+            <a:endParaRPr lang="en-US" sz="1400" dirty="0"/>
           </a:p>
         </p:txBody>
       </p:sp>
@@ -4305,8 +7295,8 @@
         </p:nvSpPr>
         <p:spPr>
           <a:xfrm>
-            <a:off x="1188720" y="2404872"/>
-            <a:ext cx="4572000" cy="219456"/>
+            <a:off x="1143000" y="2103120"/>
+            <a:ext cx="4572000" cy="201168"/>
           </a:xfrm>
           <a:prstGeom prst="rect">
             <a:avLst/>
@@ -4322,7 +7312,7 @@
               <a:buNone/>
             </a:pPr>
             <a:r>
-              <a:rPr lang="en-US" sz="1100" dirty="0">
+              <a:rPr lang="en-US" sz="1000" dirty="0">
                 <a:solidFill>
                   <a:srgbClr val="334155"/>
                 </a:solidFill>
@@ -4332,7 +7322,7 @@
               </a:rPr>
               <a:t>Solution technique proposée</a:t>
             </a:r>
-            <a:endParaRPr lang="en-US" sz="1100" dirty="0"/>
+            <a:endParaRPr lang="en-US" sz="1000" dirty="0"/>
           </a:p>
         </p:txBody>
       </p:sp>
@@ -4344,8 +7334,8 @@
         </p:nvSpPr>
         <p:spPr>
           <a:xfrm>
-            <a:off x="640080" y="2734056"/>
-            <a:ext cx="384048" cy="384048"/>
+            <a:off x="640080" y="2377440"/>
+            <a:ext cx="347472" cy="347472"/>
           </a:xfrm>
           <a:prstGeom prst="ellipse">
             <a:avLst/>
@@ -4371,8 +7361,8 @@
         </p:nvSpPr>
         <p:spPr>
           <a:xfrm>
-            <a:off x="640080" y="2734056"/>
-            <a:ext cx="384048" cy="384048"/>
+            <a:off x="640080" y="2377440"/>
+            <a:ext cx="347472" cy="347472"/>
           </a:xfrm>
           <a:prstGeom prst="rect">
             <a:avLst/>
@@ -4388,7 +7378,7 @@
               <a:buNone/>
             </a:pPr>
             <a:r>
-              <a:rPr lang="en-US" sz="1400" b="1" dirty="0">
+              <a:rPr lang="en-US" sz="1200" b="1" dirty="0">
                 <a:solidFill>
                   <a:srgbClr val="FFFFFF"/>
                 </a:solidFill>
@@ -4398,7 +7388,7 @@
               </a:rPr>
               <a:t>4</a:t>
             </a:r>
-            <a:endParaRPr lang="en-US" sz="1400" dirty="0"/>
+            <a:endParaRPr lang="en-US" sz="1200" dirty="0"/>
           </a:p>
         </p:txBody>
       </p:sp>
@@ -4410,8 +7400,8 @@
         </p:nvSpPr>
         <p:spPr>
           <a:xfrm>
-            <a:off x="1188720" y="2715768"/>
-            <a:ext cx="3200400" cy="237744"/>
+            <a:off x="1143000" y="2359152"/>
+            <a:ext cx="3200400" cy="219456"/>
           </a:xfrm>
           <a:prstGeom prst="rect">
             <a:avLst/>
@@ -4427,7 +7417,7 @@
               <a:buNone/>
             </a:pPr>
             <a:r>
-              <a:rPr lang="en-US" sz="1500" b="1" dirty="0">
+              <a:rPr lang="en-US" sz="1400" b="1" dirty="0">
                 <a:solidFill>
                   <a:srgbClr val="0F1B2D"/>
                 </a:solidFill>
@@ -4437,7 +7427,7 @@
               </a:rPr>
               <a:t>Sécurité &amp; réseau</a:t>
             </a:r>
-            <a:endParaRPr lang="en-US" sz="1500" dirty="0"/>
+            <a:endParaRPr lang="en-US" sz="1400" dirty="0"/>
           </a:p>
         </p:txBody>
       </p:sp>
@@ -4449,8 +7439,8 @@
         </p:nvSpPr>
         <p:spPr>
           <a:xfrm>
-            <a:off x="1188720" y="2935224"/>
-            <a:ext cx="4572000" cy="219456"/>
+            <a:off x="1143000" y="2560320"/>
+            <a:ext cx="4572000" cy="201168"/>
           </a:xfrm>
           <a:prstGeom prst="rect">
             <a:avLst/>
@@ -4466,7 +7456,7 @@
               <a:buNone/>
             </a:pPr>
             <a:r>
-              <a:rPr lang="en-US" sz="1100" dirty="0">
+              <a:rPr lang="en-US" sz="1000" dirty="0">
                 <a:solidFill>
                   <a:srgbClr val="334155"/>
                 </a:solidFill>
@@ -4476,7 +7466,7 @@
               </a:rPr>
               <a:t>FortiGate, VPN IKEv2, VLAN, QoS</a:t>
             </a:r>
-            <a:endParaRPr lang="en-US" sz="1100" dirty="0"/>
+            <a:endParaRPr lang="en-US" sz="1000" dirty="0"/>
           </a:p>
         </p:txBody>
       </p:sp>
@@ -4488,8 +7478,8 @@
         </p:nvSpPr>
         <p:spPr>
           <a:xfrm>
-            <a:off x="640080" y="3264408"/>
-            <a:ext cx="384048" cy="384048"/>
+            <a:off x="640080" y="2834640"/>
+            <a:ext cx="347472" cy="347472"/>
           </a:xfrm>
           <a:prstGeom prst="ellipse">
             <a:avLst/>
@@ -4515,8 +7505,8 @@
         </p:nvSpPr>
         <p:spPr>
           <a:xfrm>
-            <a:off x="640080" y="3264408"/>
-            <a:ext cx="384048" cy="384048"/>
+            <a:off x="640080" y="2834640"/>
+            <a:ext cx="347472" cy="347472"/>
           </a:xfrm>
           <a:prstGeom prst="rect">
             <a:avLst/>
@@ -4532,7 +7522,7 @@
               <a:buNone/>
             </a:pPr>
             <a:r>
-              <a:rPr lang="en-US" sz="1400" b="1" dirty="0">
+              <a:rPr lang="en-US" sz="1200" b="1" dirty="0">
                 <a:solidFill>
                   <a:srgbClr val="FFFFFF"/>
                 </a:solidFill>
@@ -4542,7 +7532,7 @@
               </a:rPr>
               <a:t>5</a:t>
             </a:r>
-            <a:endParaRPr lang="en-US" sz="1400" dirty="0"/>
+            <a:endParaRPr lang="en-US" sz="1200" dirty="0"/>
           </a:p>
         </p:txBody>
       </p:sp>
@@ -4554,8 +7544,8 @@
         </p:nvSpPr>
         <p:spPr>
           <a:xfrm>
-            <a:off x="1188720" y="3246120"/>
-            <a:ext cx="3200400" cy="237744"/>
+            <a:off x="1143000" y="2816352"/>
+            <a:ext cx="3200400" cy="219456"/>
           </a:xfrm>
           <a:prstGeom prst="rect">
             <a:avLst/>
@@ -4571,7 +7561,7 @@
               <a:buNone/>
             </a:pPr>
             <a:r>
-              <a:rPr lang="en-US" sz="1500" b="1" dirty="0">
+              <a:rPr lang="en-US" sz="1400" b="1" dirty="0">
                 <a:solidFill>
                   <a:srgbClr val="0F1B2D"/>
                 </a:solidFill>
@@ -4581,7 +7571,7 @@
               </a:rPr>
               <a:t>Haute disponibilité &amp; PRA</a:t>
             </a:r>
-            <a:endParaRPr lang="en-US" sz="1500" dirty="0"/>
+            <a:endParaRPr lang="en-US" sz="1400" dirty="0"/>
           </a:p>
         </p:txBody>
       </p:sp>
@@ -4593,8 +7583,8 @@
         </p:nvSpPr>
         <p:spPr>
           <a:xfrm>
-            <a:off x="1188720" y="3465576"/>
-            <a:ext cx="4572000" cy="219456"/>
+            <a:off x="1143000" y="3017520"/>
+            <a:ext cx="4572000" cy="201168"/>
           </a:xfrm>
           <a:prstGeom prst="rect">
             <a:avLst/>
@@ -4610,7 +7600,7 @@
               <a:buNone/>
             </a:pPr>
             <a:r>
-              <a:rPr lang="en-US" sz="1100" dirty="0">
+              <a:rPr lang="en-US" sz="1000" dirty="0">
                 <a:solidFill>
                   <a:srgbClr val="334155"/>
                 </a:solidFill>
@@ -4620,7 +7610,7 @@
               </a:rPr>
               <a:t>Cluster HA, Azure Site Recovery</a:t>
             </a:r>
-            <a:endParaRPr lang="en-US" sz="1100" dirty="0"/>
+            <a:endParaRPr lang="en-US" sz="1000" dirty="0"/>
           </a:p>
         </p:txBody>
       </p:sp>
@@ -4632,8 +7622,8 @@
         </p:nvSpPr>
         <p:spPr>
           <a:xfrm>
-            <a:off x="640080" y="3794760"/>
-            <a:ext cx="384048" cy="384048"/>
+            <a:off x="640080" y="3291840"/>
+            <a:ext cx="347472" cy="347472"/>
           </a:xfrm>
           <a:prstGeom prst="ellipse">
             <a:avLst/>
@@ -4659,8 +7649,8 @@
         </p:nvSpPr>
         <p:spPr>
           <a:xfrm>
-            <a:off x="640080" y="3794760"/>
-            <a:ext cx="384048" cy="384048"/>
+            <a:off x="640080" y="3291840"/>
+            <a:ext cx="347472" cy="347472"/>
           </a:xfrm>
           <a:prstGeom prst="rect">
             <a:avLst/>
@@ -4676,7 +7666,7 @@
               <a:buNone/>
             </a:pPr>
             <a:r>
-              <a:rPr lang="en-US" sz="1400" b="1" dirty="0">
+              <a:rPr lang="en-US" sz="1200" b="1" dirty="0">
                 <a:solidFill>
                   <a:srgbClr val="FFFFFF"/>
                 </a:solidFill>
@@ -4686,7 +7676,7 @@
               </a:rPr>
               <a:t>6</a:t>
             </a:r>
-            <a:endParaRPr lang="en-US" sz="1400" dirty="0"/>
+            <a:endParaRPr lang="en-US" sz="1200" dirty="0"/>
           </a:p>
         </p:txBody>
       </p:sp>
@@ -4698,8 +7688,8 @@
         </p:nvSpPr>
         <p:spPr>
           <a:xfrm>
-            <a:off x="1188720" y="3776472"/>
-            <a:ext cx="3200400" cy="237744"/>
+            <a:off x="1143000" y="3273552"/>
+            <a:ext cx="3200400" cy="219456"/>
           </a:xfrm>
           <a:prstGeom prst="rect">
             <a:avLst/>
@@ -4715,7 +7705,7 @@
               <a:buNone/>
             </a:pPr>
             <a:r>
-              <a:rPr lang="en-US" sz="1500" b="1" dirty="0">
+              <a:rPr lang="en-US" sz="1400" b="1" dirty="0">
                 <a:solidFill>
                   <a:srgbClr val="0F1B2D"/>
                 </a:solidFill>
@@ -4725,7 +7715,7 @@
               </a:rPr>
               <a:t>Lab POC &amp; résultats</a:t>
             </a:r>
-            <a:endParaRPr lang="en-US" sz="1500" dirty="0"/>
+            <a:endParaRPr lang="en-US" sz="1400" dirty="0"/>
           </a:p>
         </p:txBody>
       </p:sp>
@@ -4737,8 +7727,8 @@
         </p:nvSpPr>
         <p:spPr>
           <a:xfrm>
-            <a:off x="1188720" y="3995928"/>
-            <a:ext cx="4572000" cy="219456"/>
+            <a:off x="1143000" y="3474720"/>
+            <a:ext cx="4572000" cy="201168"/>
           </a:xfrm>
           <a:prstGeom prst="rect">
             <a:avLst/>
@@ -4754,7 +7744,7 @@
               <a:buNone/>
             </a:pPr>
             <a:r>
-              <a:rPr lang="en-US" sz="1100" dirty="0">
+              <a:rPr lang="en-US" sz="1000" dirty="0">
                 <a:solidFill>
                   <a:srgbClr val="334155"/>
                 </a:solidFill>
@@ -4764,7 +7754,7 @@
               </a:rPr>
               <a:t>7 VMs Proxmox, 4 tests validés</a:t>
             </a:r>
-            <a:endParaRPr lang="en-US" sz="1100" dirty="0"/>
+            <a:endParaRPr lang="en-US" sz="1000" dirty="0"/>
           </a:p>
         </p:txBody>
       </p:sp>
@@ -4776,8 +7766,8 @@
         </p:nvSpPr>
         <p:spPr>
           <a:xfrm>
-            <a:off x="640080" y="4325112"/>
-            <a:ext cx="384048" cy="384048"/>
+            <a:off x="640080" y="3749040"/>
+            <a:ext cx="347472" cy="347472"/>
           </a:xfrm>
           <a:prstGeom prst="ellipse">
             <a:avLst/>
@@ -4803,8 +7793,8 @@
         </p:nvSpPr>
         <p:spPr>
           <a:xfrm>
-            <a:off x="640080" y="4325112"/>
-            <a:ext cx="384048" cy="384048"/>
+            <a:off x="640080" y="3749040"/>
+            <a:ext cx="347472" cy="347472"/>
           </a:xfrm>
           <a:prstGeom prst="rect">
             <a:avLst/>
@@ -4820,7 +7810,7 @@
               <a:buNone/>
             </a:pPr>
             <a:r>
-              <a:rPr lang="en-US" sz="1400" b="1" dirty="0">
+              <a:rPr lang="en-US" sz="1200" b="1" dirty="0">
                 <a:solidFill>
                   <a:srgbClr val="FFFFFF"/>
                 </a:solidFill>
@@ -4830,7 +7820,7 @@
               </a:rPr>
               <a:t>7</a:t>
             </a:r>
-            <a:endParaRPr lang="en-US" sz="1400" dirty="0"/>
+            <a:endParaRPr lang="en-US" sz="1200" dirty="0"/>
           </a:p>
         </p:txBody>
       </p:sp>
@@ -4842,8 +7832,8 @@
         </p:nvSpPr>
         <p:spPr>
           <a:xfrm>
-            <a:off x="1188720" y="4306824"/>
-            <a:ext cx="3200400" cy="237744"/>
+            <a:off x="1143000" y="3730752"/>
+            <a:ext cx="3200400" cy="219456"/>
           </a:xfrm>
           <a:prstGeom prst="rect">
             <a:avLst/>
@@ -4859,7 +7849,7 @@
               <a:buNone/>
             </a:pPr>
             <a:r>
-              <a:rPr lang="en-US" sz="1500" b="1" dirty="0">
+              <a:rPr lang="en-US" sz="1400" b="1" dirty="0">
                 <a:solidFill>
                   <a:srgbClr val="0F1B2D"/>
                 </a:solidFill>
@@ -4867,9 +7857,9 @@
                 <a:ea typeface="Trebuchet MS" pitchFamily="34" charset="-122"/>
                 <a:cs typeface="Trebuchet MS" pitchFamily="34" charset="-120"/>
               </a:rPr>
-              <a:t>Budget</a:t>
-            </a:r>
-            <a:endParaRPr lang="en-US" sz="1500" dirty="0"/>
+              <a:t>Stratégie de migration</a:t>
+            </a:r>
+            <a:endParaRPr lang="en-US" sz="1400" dirty="0"/>
           </a:p>
         </p:txBody>
       </p:sp>
@@ -4881,8 +7871,8 @@
         </p:nvSpPr>
         <p:spPr>
           <a:xfrm>
-            <a:off x="1188720" y="4526280"/>
-            <a:ext cx="4572000" cy="219456"/>
+            <a:off x="1143000" y="3931920"/>
+            <a:ext cx="4572000" cy="201168"/>
           </a:xfrm>
           <a:prstGeom prst="rect">
             <a:avLst/>
@@ -4898,7 +7888,7 @@
               <a:buNone/>
             </a:pPr>
             <a:r>
-              <a:rPr lang="en-US" sz="1100" dirty="0">
+              <a:rPr lang="en-US" sz="1000" dirty="0">
                 <a:solidFill>
                   <a:srgbClr val="334155"/>
                 </a:solidFill>
@@ -4906,15 +7896,159 @@
                 <a:ea typeface="Calibri" pitchFamily="34" charset="-122"/>
                 <a:cs typeface="Calibri" pitchFamily="34" charset="-120"/>
               </a:rPr>
-              <a:t>137k EUR sur 150k max</a:t>
-            </a:r>
-            <a:endParaRPr lang="en-US" sz="1100" dirty="0"/>
+              <a:t>6 phases, planning 6 semaines, rollback</a:t>
+            </a:r>
+            <a:endParaRPr lang="en-US" sz="1000" dirty="0"/>
           </a:p>
         </p:txBody>
       </p:sp>
       <p:sp>
         <p:nvSpPr>
           <p:cNvPr id="32" name="Shape 30"/>
+          <p:cNvSpPr/>
+          <p:nvPr/>
+        </p:nvSpPr>
+        <p:spPr>
+          <a:xfrm>
+            <a:off x="640080" y="4206240"/>
+            <a:ext cx="347472" cy="347472"/>
+          </a:xfrm>
+          <a:prstGeom prst="ellipse">
+            <a:avLst/>
+          </a:prstGeom>
+          <a:solidFill>
+            <a:srgbClr val="0891B2"/>
+          </a:solidFill>
+          <a:ln/>
+        </p:spPr>
+        <p:txBody>
+          <a:bodyPr/>
+          <a:lstStyle/>
+          <a:p>
+            <a:endParaRPr lang="fr-FR"/>
+          </a:p>
+        </p:txBody>
+      </p:sp>
+      <p:sp>
+        <p:nvSpPr>
+          <p:cNvPr id="33" name="Text 31"/>
+          <p:cNvSpPr/>
+          <p:nvPr/>
+        </p:nvSpPr>
+        <p:spPr>
+          <a:xfrm>
+            <a:off x="640080" y="4206240"/>
+            <a:ext cx="347472" cy="347472"/>
+          </a:xfrm>
+          <a:prstGeom prst="rect">
+            <a:avLst/>
+          </a:prstGeom>
+          <a:noFill/>
+          <a:ln/>
+        </p:spPr>
+        <p:txBody>
+          <a:bodyPr wrap="square" rtlCol="0" anchor="ctr"/>
+          <a:lstStyle/>
+          <a:p>
+            <a:pPr marL="0" indent="0" algn="ctr">
+              <a:buNone/>
+            </a:pPr>
+            <a:r>
+              <a:rPr lang="en-US" sz="1200" b="1" dirty="0">
+                <a:solidFill>
+                  <a:srgbClr val="FFFFFF"/>
+                </a:solidFill>
+                <a:latin typeface="Calibri" pitchFamily="34" charset="0"/>
+                <a:ea typeface="Calibri" pitchFamily="34" charset="-122"/>
+                <a:cs typeface="Calibri" pitchFamily="34" charset="-120"/>
+              </a:rPr>
+              <a:t>8</a:t>
+            </a:r>
+            <a:endParaRPr lang="en-US" sz="1200" dirty="0"/>
+          </a:p>
+        </p:txBody>
+      </p:sp>
+      <p:sp>
+        <p:nvSpPr>
+          <p:cNvPr id="34" name="Text 32"/>
+          <p:cNvSpPr/>
+          <p:nvPr/>
+        </p:nvSpPr>
+        <p:spPr>
+          <a:xfrm>
+            <a:off x="1143000" y="4187952"/>
+            <a:ext cx="3200400" cy="219456"/>
+          </a:xfrm>
+          <a:prstGeom prst="rect">
+            <a:avLst/>
+          </a:prstGeom>
+          <a:noFill/>
+          <a:ln/>
+        </p:spPr>
+        <p:txBody>
+          <a:bodyPr wrap="square" lIns="0" tIns="0" rIns="0" bIns="0" rtlCol="0" anchor="ctr"/>
+          <a:lstStyle/>
+          <a:p>
+            <a:pPr marL="0" indent="0">
+              <a:buNone/>
+            </a:pPr>
+            <a:r>
+              <a:rPr lang="en-US" sz="1400" b="1" dirty="0">
+                <a:solidFill>
+                  <a:srgbClr val="0F1B2D"/>
+                </a:solidFill>
+                <a:latin typeface="Trebuchet MS" pitchFamily="34" charset="0"/>
+                <a:ea typeface="Trebuchet MS" pitchFamily="34" charset="-122"/>
+                <a:cs typeface="Trebuchet MS" pitchFamily="34" charset="-120"/>
+              </a:rPr>
+              <a:t>Budget</a:t>
+            </a:r>
+            <a:endParaRPr lang="en-US" sz="1400" dirty="0"/>
+          </a:p>
+        </p:txBody>
+      </p:sp>
+      <p:sp>
+        <p:nvSpPr>
+          <p:cNvPr id="35" name="Text 33"/>
+          <p:cNvSpPr/>
+          <p:nvPr/>
+        </p:nvSpPr>
+        <p:spPr>
+          <a:xfrm>
+            <a:off x="1143000" y="4389120"/>
+            <a:ext cx="4572000" cy="201168"/>
+          </a:xfrm>
+          <a:prstGeom prst="rect">
+            <a:avLst/>
+          </a:prstGeom>
+          <a:noFill/>
+          <a:ln/>
+        </p:spPr>
+        <p:txBody>
+          <a:bodyPr wrap="square" lIns="0" tIns="0" rIns="0" bIns="0" rtlCol="0" anchor="ctr"/>
+          <a:lstStyle/>
+          <a:p>
+            <a:pPr marL="0" indent="0">
+              <a:buNone/>
+            </a:pPr>
+            <a:r>
+              <a:rPr lang="en-US" sz="1000" dirty="0">
+                <a:solidFill>
+                  <a:srgbClr val="334155"/>
+                </a:solidFill>
+                <a:latin typeface="Calibri" pitchFamily="34" charset="0"/>
+                <a:ea typeface="Calibri" pitchFamily="34" charset="-122"/>
+                <a:cs typeface="Calibri" pitchFamily="34" charset="-120"/>
+              </a:rPr>
+              <a:t>137k € sur 150k max</a:t>
+            </a:r>
+            <a:endParaRPr lang="en-US" sz="1000" dirty="0"/>
+          </a:p>
+        </p:txBody>
+      </p:sp>
+      <p:sp>
+        <p:nvSpPr>
+          <p:cNvPr id="36" name="Shape 34"/>
           <p:cNvSpPr/>
           <p:nvPr/>
         </p:nvSpPr>
@@ -4943,7 +8077,7 @@
       </p:sp>
       <p:pic>
         <p:nvPicPr>
-          <p:cNvPr id="33" name="Image 0" descr="preencoded.png"/>
+          <p:cNvPr id="37" name="Image 0" descr="preencoded.png"/>
           <p:cNvPicPr>
             <a:picLocks noChangeAspect="1"/>
           </p:cNvPicPr>
@@ -7869,66 +11003,6 @@
         </p:nvSpPr>
         <p:spPr>
           <a:xfrm>
-            <a:off x="5074920" y="1709928"/>
-            <a:ext cx="137160" cy="91440"/>
-          </a:xfrm>
-          <a:prstGeom prst="line">
-            <a:avLst/>
-          </a:prstGeom>
-          <a:noFill/>
-          <a:ln w="25400">
-            <a:solidFill>
-              <a:srgbClr val="22D3EE"/>
-            </a:solidFill>
-            <a:prstDash val="solid"/>
-          </a:ln>
-        </p:spPr>
-        <p:txBody>
-          <a:bodyPr/>
-          <a:lstStyle/>
-          <a:p>
-            <a:endParaRPr lang="fr-FR"/>
-          </a:p>
-        </p:txBody>
-      </p:sp>
-      <p:sp>
-        <p:nvSpPr>
-          <p:cNvPr id="28" name="Shape 21"/>
-          <p:cNvSpPr/>
-          <p:nvPr/>
-        </p:nvSpPr>
-        <p:spPr>
-          <a:xfrm>
-            <a:off x="5074920" y="1892808"/>
-            <a:ext cx="137160" cy="0"/>
-          </a:xfrm>
-          <a:prstGeom prst="line">
-            <a:avLst/>
-          </a:prstGeom>
-          <a:noFill/>
-          <a:ln w="25400">
-            <a:solidFill>
-              <a:srgbClr val="22D3EE"/>
-            </a:solidFill>
-            <a:prstDash val="solid"/>
-          </a:ln>
-        </p:spPr>
-        <p:txBody>
-          <a:bodyPr/>
-          <a:lstStyle/>
-          <a:p>
-            <a:endParaRPr lang="fr-FR"/>
-          </a:p>
-        </p:txBody>
-      </p:sp>
-      <p:sp>
-        <p:nvSpPr>
-          <p:cNvPr id="29" name="Shape 22"/>
-          <p:cNvSpPr/>
-          <p:nvPr/>
-        </p:nvSpPr>
-        <p:spPr>
-          <a:xfrm>
             <a:off x="4160520" y="1920240"/>
             <a:ext cx="1005840" cy="457200"/>
           </a:xfrm>
@@ -7950,7 +11024,7 @@
       </p:sp>
       <p:sp>
         <p:nvSpPr>
-          <p:cNvPr id="30" name="Text 23"/>
+          <p:cNvPr id="28" name="Text 21"/>
           <p:cNvSpPr/>
           <p:nvPr/>
         </p:nvSpPr>
@@ -8006,7 +11080,7 @@
       </p:sp>
       <p:sp>
         <p:nvSpPr>
-          <p:cNvPr id="31" name="Shape 24"/>
+          <p:cNvPr id="29" name="Shape 22"/>
           <p:cNvSpPr/>
           <p:nvPr/>
         </p:nvSpPr>
@@ -8040,7 +11114,7 @@
       </p:sp>
       <p:sp>
         <p:nvSpPr>
-          <p:cNvPr id="32" name="Text 25"/>
+          <p:cNvPr id="30" name="Text 23"/>
           <p:cNvSpPr/>
           <p:nvPr/>
         </p:nvSpPr>
@@ -8079,7 +11153,7 @@
       </p:sp>
       <p:sp>
         <p:nvSpPr>
-          <p:cNvPr id="33" name="Shape 26"/>
+          <p:cNvPr id="31" name="Shape 24"/>
           <p:cNvSpPr/>
           <p:nvPr/>
         </p:nvSpPr>
@@ -8106,7 +11180,7 @@
       </p:sp>
       <p:pic>
         <p:nvPicPr>
-          <p:cNvPr id="34" name="Image 5" descr="preencoded.png"/>
+          <p:cNvPr id="32" name="Image 5" descr="preencoded.png"/>
           <p:cNvPicPr>
             <a:picLocks noChangeAspect="1"/>
           </p:cNvPicPr>
@@ -8130,7 +11204,7 @@
       </p:pic>
       <p:sp>
         <p:nvSpPr>
-          <p:cNvPr id="35" name="Text 27"/>
+          <p:cNvPr id="33" name="Text 25"/>
           <p:cNvSpPr/>
           <p:nvPr/>
         </p:nvSpPr>
@@ -8169,7 +11243,7 @@
       </p:sp>
       <p:sp>
         <p:nvSpPr>
-          <p:cNvPr id="36" name="Shape 28"/>
+          <p:cNvPr id="34" name="Shape 26"/>
           <p:cNvSpPr/>
           <p:nvPr/>
         </p:nvSpPr>
@@ -8196,7 +11270,7 @@
       </p:sp>
       <p:pic>
         <p:nvPicPr>
-          <p:cNvPr id="37" name="Image 6" descr="preencoded.png"/>
+          <p:cNvPr id="35" name="Image 6" descr="preencoded.png"/>
           <p:cNvPicPr>
             <a:picLocks noChangeAspect="1"/>
           </p:cNvPicPr>
@@ -8220,7 +11294,7 @@
       </p:pic>
       <p:sp>
         <p:nvSpPr>
-          <p:cNvPr id="38" name="Text 29"/>
+          <p:cNvPr id="36" name="Text 27"/>
           <p:cNvSpPr/>
           <p:nvPr/>
         </p:nvSpPr>
@@ -8259,7 +11333,7 @@
       </p:sp>
       <p:sp>
         <p:nvSpPr>
-          <p:cNvPr id="39" name="Shape 30"/>
+          <p:cNvPr id="37" name="Shape 28"/>
           <p:cNvSpPr/>
           <p:nvPr/>
         </p:nvSpPr>
@@ -8286,7 +11360,7 @@
       </p:sp>
       <p:pic>
         <p:nvPicPr>
-          <p:cNvPr id="40" name="Image 7" descr="preencoded.png"/>
+          <p:cNvPr id="38" name="Image 7" descr="preencoded.png"/>
           <p:cNvPicPr>
             <a:picLocks noChangeAspect="1"/>
           </p:cNvPicPr>
@@ -8310,7 +11384,7 @@
       </p:pic>
       <p:sp>
         <p:nvSpPr>
-          <p:cNvPr id="41" name="Text 31"/>
+          <p:cNvPr id="39" name="Text 29"/>
           <p:cNvSpPr/>
           <p:nvPr/>
         </p:nvSpPr>
@@ -8349,7 +11423,7 @@
       </p:sp>
       <p:sp>
         <p:nvSpPr>
-          <p:cNvPr id="42" name="Shape 32"/>
+          <p:cNvPr id="40" name="Shape 30"/>
           <p:cNvSpPr/>
           <p:nvPr/>
         </p:nvSpPr>
@@ -8379,7 +11453,7 @@
       </p:sp>
       <p:sp>
         <p:nvSpPr>
-          <p:cNvPr id="43" name="Shape 33"/>
+          <p:cNvPr id="41" name="Shape 31"/>
           <p:cNvSpPr/>
           <p:nvPr/>
         </p:nvSpPr>
@@ -8408,7 +11482,7 @@
       </p:sp>
       <p:sp>
         <p:nvSpPr>
-          <p:cNvPr id="44" name="Text 34"/>
+          <p:cNvPr id="42" name="Text 32"/>
           <p:cNvSpPr/>
           <p:nvPr/>
         </p:nvSpPr>
@@ -8464,7 +11538,7 @@
       </p:sp>
       <p:sp>
         <p:nvSpPr>
-          <p:cNvPr id="45" name="Shape 35"/>
+          <p:cNvPr id="43" name="Shape 33"/>
           <p:cNvSpPr/>
           <p:nvPr/>
         </p:nvSpPr>
@@ -8493,7 +11567,7 @@
       </p:sp>
       <p:sp>
         <p:nvSpPr>
-          <p:cNvPr id="46" name="Text 36"/>
+          <p:cNvPr id="44" name="Text 34"/>
           <p:cNvSpPr/>
           <p:nvPr/>
         </p:nvSpPr>
@@ -9171,7 +12245,7 @@
         </p:nvGraphicFramePr>
         <p:xfrm>
           <a:off x="640080" y="3749040"/>
-          <a:ext cx="7863840" cy="1231392"/>
+          <a:ext cx="7863840" cy="914400"/>
         </p:xfrm>
         <a:graphic>
           <a:graphicData uri="http://schemas.openxmlformats.org/drawingml/2006/table">
@@ -11241,7 +14315,7 @@
         </p:nvGraphicFramePr>
         <p:xfrm>
           <a:off x="640080" y="4023360"/>
-          <a:ext cx="7863840" cy="987552"/>
+          <a:ext cx="7863840" cy="914400"/>
         </p:xfrm>
         <a:graphic>
           <a:graphicData uri="http://schemas.openxmlformats.org/drawingml/2006/table">

</xml_diff>

<commit_message>
docs: add revision express + fiche reference jour J + navigation soutenance
- Create revision-express.md — single condensed study document (5 pages)
- Create fiche-reference-jourj.md — detailed reference for use during soutenance (Ctrl+F)
- Add nav headers linking all 10 soutenance docs together
- Add cross-references from 02-conception to 04-livrables
- Update README, STRUCTURE, QUICKSTART with new documents
- Export both documents to styled DOCX (build_corporate engine)
- Add carnet-soutenance.md and cheatsheet-demo.md

Co-Authored-By: Claude Opus 4.6 <noreply@anthropic.com>
</commit_message>
<xml_diff>
--- a/docs/05-soutenance/MSPR_NordTransit_Presentation.pptx
+++ b/docs/05-soutenance/MSPR_NordTransit_Presentation.pptx
@@ -7,6 +7,9 @@
   <p:notesMasterIdLst>
     <p:notesMasterId r:id="rId14"/>
   </p:notesMasterIdLst>
+  <p:handoutMasterIdLst>
+    <p:handoutMasterId r:id="rId15"/>
+  </p:handoutMasterIdLst>
   <p:sldIdLst>
     <p:sldId id="256" r:id="rId2"/>
     <p:sldId id="257" r:id="rId3"/>
@@ -519,6 +522,192 @@
 </c:chartSpace>
 </file>
 
+<file path=ppt/handoutMasters/handoutMaster1.xml><?xml version="1.0" encoding="utf-8"?>
+<p:handoutMaster xmlns:a="http://schemas.openxmlformats.org/drawingml/2006/main" xmlns:r="http://schemas.openxmlformats.org/officeDocument/2006/relationships" xmlns:p="http://schemas.openxmlformats.org/presentationml/2006/main">
+  <p:cSld>
+    <p:bg>
+      <p:bgRef idx="1001">
+        <a:schemeClr val="bg1"/>
+      </p:bgRef>
+    </p:bg>
+    <p:spTree>
+      <p:nvGrpSpPr>
+        <p:cNvPr id="1" name=""/>
+        <p:cNvGrpSpPr/>
+        <p:nvPr/>
+      </p:nvGrpSpPr>
+      <p:grpSpPr>
+        <a:xfrm>
+          <a:off x="0" y="0"/>
+          <a:ext cx="0" cy="0"/>
+          <a:chOff x="0" y="0"/>
+          <a:chExt cx="0" cy="0"/>
+        </a:xfrm>
+      </p:grpSpPr>
+      <p:sp>
+        <p:nvSpPr>
+          <p:cNvPr id="2" name="Header Placeholder 1">
+            <a:extLst>
+              <a:ext uri="{FF2B5EF4-FFF2-40B4-BE49-F238E27FC236}">
+                <a16:creationId xmlns:a16="http://schemas.microsoft.com/office/drawing/2014/main" id="{7D6CC03B-15F5-0152-F2B6-818ED0C6A988}"/>
+              </a:ext>
+            </a:extLst>
+          </p:cNvPr>
+          <p:cNvSpPr>
+            <a:spLocks noGrp="1"/>
+          </p:cNvSpPr>
+          <p:nvPr>
+            <p:ph type="hdr" sz="quarter"/>
+          </p:nvPr>
+        </p:nvSpPr>
+        <p:spPr>
+          <a:xfrm>
+            <a:off x="0" y="0"/>
+            <a:ext cx="2228850" cy="458788"/>
+          </a:xfrm>
+          <a:prstGeom prst="rect">
+            <a:avLst/>
+          </a:prstGeom>
+        </p:spPr>
+        <p:txBody>
+          <a:bodyPr vert="horz" lIns="91440" tIns="45720" rIns="91440" bIns="45720" rtlCol="0"/>
+          <a:lstStyle>
+            <a:lvl1pPr algn="l">
+              <a:defRPr sz="1200"/>
+            </a:lvl1pPr>
+          </a:lstStyle>
+          <a:p>
+            <a:endParaRPr lang="fr-FR"/>
+          </a:p>
+        </p:txBody>
+      </p:sp>
+      <p:sp>
+        <p:nvSpPr>
+          <p:cNvPr id="3" name="Date Placeholder 2">
+            <a:extLst>
+              <a:ext uri="{FF2B5EF4-FFF2-40B4-BE49-F238E27FC236}">
+                <a16:creationId xmlns:a16="http://schemas.microsoft.com/office/drawing/2014/main" id="{B154332A-14E8-F8B5-CC0A-E7C1B3773243}"/>
+              </a:ext>
+            </a:extLst>
+          </p:cNvPr>
+          <p:cNvSpPr>
+            <a:spLocks noGrp="1"/>
+          </p:cNvSpPr>
+          <p:nvPr>
+            <p:ph type="dt" sz="quarter" idx="1"/>
+          </p:nvPr>
+        </p:nvSpPr>
+        <p:spPr>
+          <a:xfrm>
+            <a:off x="2913063" y="0"/>
+            <a:ext cx="2228850" cy="458788"/>
+          </a:xfrm>
+          <a:prstGeom prst="rect">
+            <a:avLst/>
+          </a:prstGeom>
+        </p:spPr>
+        <p:txBody>
+          <a:bodyPr vert="horz" lIns="91440" tIns="45720" rIns="91440" bIns="45720" rtlCol="0"/>
+          <a:lstStyle>
+            <a:lvl1pPr algn="r">
+              <a:defRPr sz="1200"/>
+            </a:lvl1pPr>
+          </a:lstStyle>
+          <a:p>
+            <a:endParaRPr lang="fr-FR"/>
+          </a:p>
+        </p:txBody>
+      </p:sp>
+      <p:sp>
+        <p:nvSpPr>
+          <p:cNvPr id="4" name="Footer Placeholder 3">
+            <a:extLst>
+              <a:ext uri="{FF2B5EF4-FFF2-40B4-BE49-F238E27FC236}">
+                <a16:creationId xmlns:a16="http://schemas.microsoft.com/office/drawing/2014/main" id="{39C4C0E6-1A62-B0BD-8C26-C376CDEA8F47}"/>
+              </a:ext>
+            </a:extLst>
+          </p:cNvPr>
+          <p:cNvSpPr>
+            <a:spLocks noGrp="1"/>
+          </p:cNvSpPr>
+          <p:nvPr>
+            <p:ph type="ftr" sz="quarter" idx="2"/>
+          </p:nvPr>
+        </p:nvSpPr>
+        <p:spPr>
+          <a:xfrm>
+            <a:off x="0" y="8685213"/>
+            <a:ext cx="2228850" cy="458787"/>
+          </a:xfrm>
+          <a:prstGeom prst="rect">
+            <a:avLst/>
+          </a:prstGeom>
+        </p:spPr>
+        <p:txBody>
+          <a:bodyPr vert="horz" lIns="91440" tIns="45720" rIns="91440" bIns="45720" rtlCol="0" anchor="b"/>
+          <a:lstStyle>
+            <a:lvl1pPr algn="l">
+              <a:defRPr sz="1200"/>
+            </a:lvl1pPr>
+          </a:lstStyle>
+          <a:p>
+            <a:endParaRPr lang="fr-FR"/>
+          </a:p>
+        </p:txBody>
+      </p:sp>
+      <p:sp>
+        <p:nvSpPr>
+          <p:cNvPr id="5" name="Slide Number Placeholder 4">
+            <a:extLst>
+              <a:ext uri="{FF2B5EF4-FFF2-40B4-BE49-F238E27FC236}">
+                <a16:creationId xmlns:a16="http://schemas.microsoft.com/office/drawing/2014/main" id="{0E0FCD04-8815-B406-D702-EAD9EB4E6A50}"/>
+              </a:ext>
+            </a:extLst>
+          </p:cNvPr>
+          <p:cNvSpPr>
+            <a:spLocks noGrp="1"/>
+          </p:cNvSpPr>
+          <p:nvPr>
+            <p:ph type="sldNum" sz="quarter" idx="3"/>
+          </p:nvPr>
+        </p:nvSpPr>
+        <p:spPr>
+          <a:xfrm>
+            <a:off x="2913063" y="8685213"/>
+            <a:ext cx="2228850" cy="458787"/>
+          </a:xfrm>
+          <a:prstGeom prst="rect">
+            <a:avLst/>
+          </a:prstGeom>
+        </p:spPr>
+        <p:txBody>
+          <a:bodyPr vert="horz" lIns="91440" tIns="45720" rIns="91440" bIns="45720" rtlCol="0" anchor="b"/>
+          <a:lstStyle>
+            <a:lvl1pPr algn="r">
+              <a:defRPr sz="1200"/>
+            </a:lvl1pPr>
+          </a:lstStyle>
+          <a:p>
+            <a:fld id="{5B93C933-9933-4C31-BE6D-F5666E68E0FD}" type="slidenum">
+              <a:rPr lang="fr-FR" smtClean="0"/>
+              <a:t>‹#›</a:t>
+            </a:fld>
+            <a:endParaRPr lang="fr-FR"/>
+          </a:p>
+        </p:txBody>
+      </p:sp>
+    </p:spTree>
+    <p:extLst>
+      <p:ext uri="{BB962C8B-B14F-4D97-AF65-F5344CB8AC3E}">
+        <p14:creationId xmlns:p14="http://schemas.microsoft.com/office/powerpoint/2010/main" val="170269413"/>
+      </p:ext>
+    </p:extLst>
+  </p:cSld>
+  <p:clrMap bg1="lt1" tx1="dk1" bg2="lt2" tx2="dk2" accent1="accent1" accent2="accent2" accent3="accent3" accent4="accent4" accent5="accent5" accent6="accent6" hlink="hlink" folHlink="folHlink"/>
+  <p:hf sldNum="0" hdr="0" ftr="0" dt="0"/>
+</p:handoutMaster>
+</file>
+
 <file path=ppt/notesMasters/notesMaster1.xml><?xml version="1.0" encoding="utf-8"?>
 <p:notesMaster xmlns:a="http://schemas.openxmlformats.org/drawingml/2006/main" xmlns:r="http://schemas.openxmlformats.org/officeDocument/2006/relationships" xmlns:p="http://schemas.openxmlformats.org/presentationml/2006/main">
   <p:cSld>
@@ -549,6 +738,7 @@
     </p:extLst>
   </p:cSld>
   <p:clrMap bg1="lt1" tx1="dk1" bg2="lt2" tx2="dk2" accent1="accent1" accent2="accent2" accent3="accent3" accent4="accent4" accent5="accent5" accent6="accent6" hlink="hlink" folHlink="folHlink"/>
+  <p:hf sldNum="0" hdr="0" ftr="0" dt="0"/>
   <p:notesStyle>
     <a:lvl1pPr marL="0" algn="l" defTabSz="914400" rtl="0" eaLnBrk="1" latinLnBrk="0" hangingPunct="1">
       <a:defRPr sz="1200" kern="1200">
@@ -692,29 +882,6 @@
           </a:p>
         </p:txBody>
       </p:sp>
-      <p:sp>
-        <p:nvSpPr>
-          <p:cNvPr id="4" name="Slide Number Placeholder 3"/>
-          <p:cNvSpPr>
-            <a:spLocks noGrp="1"/>
-          </p:cNvSpPr>
-          <p:nvPr>
-            <p:ph type="sldNum" sz="quarter" idx="10"/>
-          </p:nvPr>
-        </p:nvSpPr>
-        <p:spPr/>
-        <p:txBody>
-          <a:bodyPr/>
-          <a:lstStyle/>
-          <a:p>
-            <a:fld id="{F7021451-1387-4CA6-816F-3879F97B5CBC}" type="slidenum">
-              <a:rPr lang="en-US"/>
-              <a:t>1</a:t>
-            </a:fld>
-            <a:endParaRPr lang="en-US"/>
-          </a:p>
-        </p:txBody>
-      </p:sp>
     </p:spTree>
     <p:extLst>
       <p:ext uri="{BB962C8B-B14F-4D97-AF65-F5344CB8AC3E}">
@@ -776,29 +943,6 @@
           </a:p>
         </p:txBody>
       </p:sp>
-      <p:sp>
-        <p:nvSpPr>
-          <p:cNvPr id="4" name="Slide Number Placeholder 3"/>
-          <p:cNvSpPr>
-            <a:spLocks noGrp="1"/>
-          </p:cNvSpPr>
-          <p:nvPr>
-            <p:ph type="sldNum" sz="quarter" idx="10"/>
-          </p:nvPr>
-        </p:nvSpPr>
-        <p:spPr/>
-        <p:txBody>
-          <a:bodyPr/>
-          <a:lstStyle/>
-          <a:p>
-            <a:fld id="{F7021451-1387-4CA6-816F-3879F97B5CBC}" type="slidenum">
-              <a:rPr lang="en-US"/>
-              <a:t>10</a:t>
-            </a:fld>
-            <a:endParaRPr lang="en-US"/>
-          </a:p>
-        </p:txBody>
-      </p:sp>
     </p:spTree>
     <p:extLst>
       <p:ext uri="{BB962C8B-B14F-4D97-AF65-F5344CB8AC3E}">
@@ -860,29 +1004,6 @@
           </a:p>
         </p:txBody>
       </p:sp>
-      <p:sp>
-        <p:nvSpPr>
-          <p:cNvPr id="4" name="Slide Number Placeholder 3"/>
-          <p:cNvSpPr>
-            <a:spLocks noGrp="1"/>
-          </p:cNvSpPr>
-          <p:nvPr>
-            <p:ph type="sldNum" sz="quarter" idx="10"/>
-          </p:nvPr>
-        </p:nvSpPr>
-        <p:spPr/>
-        <p:txBody>
-          <a:bodyPr/>
-          <a:lstStyle/>
-          <a:p>
-            <a:fld id="{F7021451-1387-4CA6-816F-3879F97B5CBC}" type="slidenum">
-              <a:rPr lang="en-US"/>
-              <a:t>11</a:t>
-            </a:fld>
-            <a:endParaRPr lang="en-US"/>
-          </a:p>
-        </p:txBody>
-      </p:sp>
     </p:spTree>
     <p:extLst>
       <p:ext uri="{BB962C8B-B14F-4D97-AF65-F5344CB8AC3E}">
@@ -944,29 +1065,6 @@
           </a:p>
         </p:txBody>
       </p:sp>
-      <p:sp>
-        <p:nvSpPr>
-          <p:cNvPr id="4" name="Slide Number Placeholder 3"/>
-          <p:cNvSpPr>
-            <a:spLocks noGrp="1"/>
-          </p:cNvSpPr>
-          <p:nvPr>
-            <p:ph type="sldNum" sz="quarter" idx="10"/>
-          </p:nvPr>
-        </p:nvSpPr>
-        <p:spPr/>
-        <p:txBody>
-          <a:bodyPr/>
-          <a:lstStyle/>
-          <a:p>
-            <a:fld id="{F7021451-1387-4CA6-816F-3879F97B5CBC}" type="slidenum">
-              <a:rPr lang="en-US"/>
-              <a:t>12</a:t>
-            </a:fld>
-            <a:endParaRPr lang="en-US"/>
-          </a:p>
-        </p:txBody>
-      </p:sp>
     </p:spTree>
     <p:extLst>
       <p:ext uri="{BB962C8B-B14F-4D97-AF65-F5344CB8AC3E}">
@@ -1028,29 +1126,6 @@
           </a:p>
         </p:txBody>
       </p:sp>
-      <p:sp>
-        <p:nvSpPr>
-          <p:cNvPr id="4" name="Slide Number Placeholder 3"/>
-          <p:cNvSpPr>
-            <a:spLocks noGrp="1"/>
-          </p:cNvSpPr>
-          <p:nvPr>
-            <p:ph type="sldNum" sz="quarter" idx="10"/>
-          </p:nvPr>
-        </p:nvSpPr>
-        <p:spPr/>
-        <p:txBody>
-          <a:bodyPr/>
-          <a:lstStyle/>
-          <a:p>
-            <a:fld id="{F7021451-1387-4CA6-816F-3879F97B5CBC}" type="slidenum">
-              <a:rPr lang="en-US"/>
-              <a:t>2</a:t>
-            </a:fld>
-            <a:endParaRPr lang="en-US"/>
-          </a:p>
-        </p:txBody>
-      </p:sp>
     </p:spTree>
     <p:extLst>
       <p:ext uri="{BB962C8B-B14F-4D97-AF65-F5344CB8AC3E}">
@@ -1112,29 +1187,6 @@
           </a:p>
         </p:txBody>
       </p:sp>
-      <p:sp>
-        <p:nvSpPr>
-          <p:cNvPr id="4" name="Slide Number Placeholder 3"/>
-          <p:cNvSpPr>
-            <a:spLocks noGrp="1"/>
-          </p:cNvSpPr>
-          <p:nvPr>
-            <p:ph type="sldNum" sz="quarter" idx="10"/>
-          </p:nvPr>
-        </p:nvSpPr>
-        <p:spPr/>
-        <p:txBody>
-          <a:bodyPr/>
-          <a:lstStyle/>
-          <a:p>
-            <a:fld id="{F7021451-1387-4CA6-816F-3879F97B5CBC}" type="slidenum">
-              <a:rPr lang="en-US"/>
-              <a:t>3</a:t>
-            </a:fld>
-            <a:endParaRPr lang="en-US"/>
-          </a:p>
-        </p:txBody>
-      </p:sp>
     </p:spTree>
     <p:extLst>
       <p:ext uri="{BB962C8B-B14F-4D97-AF65-F5344CB8AC3E}">
@@ -1196,29 +1248,6 @@
           </a:p>
         </p:txBody>
       </p:sp>
-      <p:sp>
-        <p:nvSpPr>
-          <p:cNvPr id="4" name="Slide Number Placeholder 3"/>
-          <p:cNvSpPr>
-            <a:spLocks noGrp="1"/>
-          </p:cNvSpPr>
-          <p:nvPr>
-            <p:ph type="sldNum" sz="quarter" idx="10"/>
-          </p:nvPr>
-        </p:nvSpPr>
-        <p:spPr/>
-        <p:txBody>
-          <a:bodyPr/>
-          <a:lstStyle/>
-          <a:p>
-            <a:fld id="{F7021451-1387-4CA6-816F-3879F97B5CBC}" type="slidenum">
-              <a:rPr lang="en-US"/>
-              <a:t>4</a:t>
-            </a:fld>
-            <a:endParaRPr lang="en-US"/>
-          </a:p>
-        </p:txBody>
-      </p:sp>
     </p:spTree>
     <p:extLst>
       <p:ext uri="{BB962C8B-B14F-4D97-AF65-F5344CB8AC3E}">
@@ -1280,29 +1309,6 @@
           </a:p>
         </p:txBody>
       </p:sp>
-      <p:sp>
-        <p:nvSpPr>
-          <p:cNvPr id="4" name="Slide Number Placeholder 3"/>
-          <p:cNvSpPr>
-            <a:spLocks noGrp="1"/>
-          </p:cNvSpPr>
-          <p:nvPr>
-            <p:ph type="sldNum" sz="quarter" idx="10"/>
-          </p:nvPr>
-        </p:nvSpPr>
-        <p:spPr/>
-        <p:txBody>
-          <a:bodyPr/>
-          <a:lstStyle/>
-          <a:p>
-            <a:fld id="{F7021451-1387-4CA6-816F-3879F97B5CBC}" type="slidenum">
-              <a:rPr lang="en-US"/>
-              <a:t>5</a:t>
-            </a:fld>
-            <a:endParaRPr lang="en-US"/>
-          </a:p>
-        </p:txBody>
-      </p:sp>
     </p:spTree>
     <p:extLst>
       <p:ext uri="{BB962C8B-B14F-4D97-AF65-F5344CB8AC3E}">
@@ -1364,29 +1370,6 @@
           </a:p>
         </p:txBody>
       </p:sp>
-      <p:sp>
-        <p:nvSpPr>
-          <p:cNvPr id="4" name="Slide Number Placeholder 3"/>
-          <p:cNvSpPr>
-            <a:spLocks noGrp="1"/>
-          </p:cNvSpPr>
-          <p:nvPr>
-            <p:ph type="sldNum" sz="quarter" idx="10"/>
-          </p:nvPr>
-        </p:nvSpPr>
-        <p:spPr/>
-        <p:txBody>
-          <a:bodyPr/>
-          <a:lstStyle/>
-          <a:p>
-            <a:fld id="{F7021451-1387-4CA6-816F-3879F97B5CBC}" type="slidenum">
-              <a:rPr lang="en-US"/>
-              <a:t>6</a:t>
-            </a:fld>
-            <a:endParaRPr lang="en-US"/>
-          </a:p>
-        </p:txBody>
-      </p:sp>
     </p:spTree>
     <p:extLst>
       <p:ext uri="{BB962C8B-B14F-4D97-AF65-F5344CB8AC3E}">
@@ -1448,29 +1431,6 @@
           </a:p>
         </p:txBody>
       </p:sp>
-      <p:sp>
-        <p:nvSpPr>
-          <p:cNvPr id="4" name="Slide Number Placeholder 3"/>
-          <p:cNvSpPr>
-            <a:spLocks noGrp="1"/>
-          </p:cNvSpPr>
-          <p:nvPr>
-            <p:ph type="sldNum" sz="quarter" idx="10"/>
-          </p:nvPr>
-        </p:nvSpPr>
-        <p:spPr/>
-        <p:txBody>
-          <a:bodyPr/>
-          <a:lstStyle/>
-          <a:p>
-            <a:fld id="{F7021451-1387-4CA6-816F-3879F97B5CBC}" type="slidenum">
-              <a:rPr lang="en-US"/>
-              <a:t>7</a:t>
-            </a:fld>
-            <a:endParaRPr lang="en-US"/>
-          </a:p>
-        </p:txBody>
-      </p:sp>
     </p:spTree>
     <p:extLst>
       <p:ext uri="{BB962C8B-B14F-4D97-AF65-F5344CB8AC3E}">
@@ -1532,29 +1492,6 @@
           </a:p>
         </p:txBody>
       </p:sp>
-      <p:sp>
-        <p:nvSpPr>
-          <p:cNvPr id="4" name="Slide Number Placeholder 3"/>
-          <p:cNvSpPr>
-            <a:spLocks noGrp="1"/>
-          </p:cNvSpPr>
-          <p:nvPr>
-            <p:ph type="sldNum" sz="quarter" idx="10"/>
-          </p:nvPr>
-        </p:nvSpPr>
-        <p:spPr/>
-        <p:txBody>
-          <a:bodyPr/>
-          <a:lstStyle/>
-          <a:p>
-            <a:fld id="{F7021451-1387-4CA6-816F-3879F97B5CBC}" type="slidenum">
-              <a:rPr lang="en-US"/>
-              <a:t>8</a:t>
-            </a:fld>
-            <a:endParaRPr lang="en-US"/>
-          </a:p>
-        </p:txBody>
-      </p:sp>
     </p:spTree>
     <p:extLst>
       <p:ext uri="{BB962C8B-B14F-4D97-AF65-F5344CB8AC3E}">
@@ -1613,29 +1550,6 @@
           <a:lstStyle/>
           <a:p>
             <a:endParaRPr lang="en-US" dirty="0"/>
-          </a:p>
-        </p:txBody>
-      </p:sp>
-      <p:sp>
-        <p:nvSpPr>
-          <p:cNvPr id="4" name="Slide Number Placeholder 3"/>
-          <p:cNvSpPr>
-            <a:spLocks noGrp="1"/>
-          </p:cNvSpPr>
-          <p:nvPr>
-            <p:ph type="sldNum" sz="quarter" idx="10"/>
-          </p:nvPr>
-        </p:nvSpPr>
-        <p:spPr/>
-        <p:txBody>
-          <a:bodyPr/>
-          <a:lstStyle/>
-          <a:p>
-            <a:fld id="{F7021451-1387-4CA6-816F-3879F97B5CBC}" type="slidenum">
-              <a:rPr lang="en-US"/>
-              <a:t>9</a:t>
-            </a:fld>
-            <a:endParaRPr lang="en-US"/>
           </a:p>
         </p:txBody>
       </p:sp>
@@ -1674,6 +1588,35 @@
           <a:chExt cx="0" cy="0"/>
         </a:xfrm>
       </p:grpSpPr>
+      <p:sp>
+        <p:nvSpPr>
+          <p:cNvPr id="2" name="Slide Number Placeholder 1">
+            <a:extLst>
+              <a:ext uri="{FF2B5EF4-FFF2-40B4-BE49-F238E27FC236}">
+                <a16:creationId xmlns:a16="http://schemas.microsoft.com/office/drawing/2014/main" id="{C47A6172-EF82-3779-3802-DDA232D0E7C3}"/>
+              </a:ext>
+            </a:extLst>
+          </p:cNvPr>
+          <p:cNvSpPr>
+            <a:spLocks noGrp="1"/>
+          </p:cNvSpPr>
+          <p:nvPr>
+            <p:ph type="sldNum" sz="quarter" idx="10"/>
+          </p:nvPr>
+        </p:nvSpPr>
+        <p:spPr/>
+        <p:txBody>
+          <a:bodyPr/>
+          <a:lstStyle/>
+          <a:p>
+            <a:fld id="{4945FB95-144E-49FD-B7E5-5AC832B9F648}" type="slidenum">
+              <a:rPr lang="fr-FR" smtClean="0"/>
+              <a:t>‹#›</a:t>
+            </a:fld>
+            <a:endParaRPr lang="fr-FR"/>
+          </a:p>
+        </p:txBody>
+      </p:sp>
     </p:spTree>
   </p:cSld>
   <p:clrMapOvr>
@@ -1704,13 +1647,60 @@
           <a:chExt cx="0" cy="0"/>
         </a:xfrm>
       </p:grpSpPr>
+      <p:sp>
+        <p:nvSpPr>
+          <p:cNvPr id="2" name="Slide Number Placeholder 1">
+            <a:extLst>
+              <a:ext uri="{FF2B5EF4-FFF2-40B4-BE49-F238E27FC236}">
+                <a16:creationId xmlns:a16="http://schemas.microsoft.com/office/drawing/2014/main" id="{FB5B4E7C-A112-C4EC-AA6C-7BB2C68C9ADD}"/>
+              </a:ext>
+            </a:extLst>
+          </p:cNvPr>
+          <p:cNvSpPr>
+            <a:spLocks noGrp="1"/>
+          </p:cNvSpPr>
+          <p:nvPr>
+            <p:ph type="sldNum" sz="quarter" idx="4"/>
+          </p:nvPr>
+        </p:nvSpPr>
+        <p:spPr>
+          <a:xfrm>
+            <a:off x="6937783" y="4767263"/>
+            <a:ext cx="2057400" cy="274637"/>
+          </a:xfrm>
+          <a:prstGeom prst="rect">
+            <a:avLst/>
+          </a:prstGeom>
+        </p:spPr>
+        <p:txBody>
+          <a:bodyPr vert="horz" lIns="91440" tIns="45720" rIns="91440" bIns="45720" rtlCol="0" anchor="ctr"/>
+          <a:lstStyle>
+            <a:lvl1pPr algn="r">
+              <a:defRPr sz="1200">
+                <a:solidFill>
+                  <a:schemeClr val="tx1">
+                    <a:tint val="82000"/>
+                  </a:schemeClr>
+                </a:solidFill>
+              </a:defRPr>
+            </a:lvl1pPr>
+          </a:lstStyle>
+          <a:p>
+            <a:fld id="{4945FB95-144E-49FD-B7E5-5AC832B9F648}" type="slidenum">
+              <a:rPr lang="fr-FR" smtClean="0"/>
+              <a:t>‹#›</a:t>
+            </a:fld>
+            <a:endParaRPr lang="fr-FR"/>
+          </a:p>
+        </p:txBody>
+      </p:sp>
     </p:spTree>
   </p:cSld>
   <p:clrMap bg1="lt1" tx1="dk1" bg2="lt2" tx2="dk2" accent1="accent1" accent2="accent2" accent3="accent3" accent4="accent4" accent5="accent5" accent6="accent6" hlink="hlink" folHlink="folHlink"/>
   <p:sldLayoutIdLst>
     <p:sldLayoutId id="2147483649" r:id="rId1"/>
   </p:sldLayoutIdLst>
-  <p:hf sldNum="0" hdr="0" ftr="0" dt="0"/>
+  <p:hf hdr="0" ftr="0" dt="0"/>
   <p:txStyles>
     <p:titleStyle>
       <a:lvl1pPr algn="ctr" defTabSz="914400" rtl="0" eaLnBrk="1" latinLnBrk="0" hangingPunct="1">
@@ -2053,7 +2043,7 @@
         </p:nvSpPr>
         <p:spPr>
           <a:xfrm>
-            <a:off x="731520" y="1097280"/>
+            <a:off x="731520" y="597033"/>
             <a:ext cx="7680960" cy="731520"/>
           </a:xfrm>
           <a:prstGeom prst="rect">
@@ -2092,7 +2082,7 @@
         </p:nvSpPr>
         <p:spPr>
           <a:xfrm>
-            <a:off x="731520" y="1691640"/>
+            <a:off x="731520" y="1191393"/>
             <a:ext cx="7680960" cy="914400"/>
           </a:xfrm>
           <a:prstGeom prst="rect">
@@ -2131,7 +2121,7 @@
         </p:nvSpPr>
         <p:spPr>
           <a:xfrm>
-            <a:off x="731520" y="2606040"/>
+            <a:off x="731520" y="2105793"/>
             <a:ext cx="7680960" cy="548640"/>
           </a:xfrm>
           <a:prstGeom prst="rect">
@@ -2170,7 +2160,7 @@
         </p:nvSpPr>
         <p:spPr>
           <a:xfrm>
-            <a:off x="731520" y="3337560"/>
+            <a:off x="731520" y="2837313"/>
             <a:ext cx="2286000" cy="0"/>
           </a:xfrm>
           <a:prstGeom prst="line">
@@ -2200,7 +2190,7 @@
         </p:nvSpPr>
         <p:spPr>
           <a:xfrm>
-            <a:off x="731520" y="3557517"/>
+            <a:off x="731520" y="3057270"/>
             <a:ext cx="7680960" cy="1059966"/>
           </a:xfrm>
           <a:prstGeom prst="rect">
@@ -2356,7 +2346,7 @@
         </p:nvSpPr>
         <p:spPr>
           <a:xfrm>
-            <a:off x="731520" y="4682774"/>
+            <a:off x="731520" y="4182527"/>
             <a:ext cx="7680960" cy="365760"/>
           </a:xfrm>
           <a:prstGeom prst="rect">
@@ -2384,6 +2374,103 @@
               <a:t>Février 2026</a:t>
             </a:r>
             <a:endParaRPr lang="en-US" sz="1300" dirty="0"/>
+          </a:p>
+        </p:txBody>
+      </p:sp>
+      <p:sp>
+        <p:nvSpPr>
+          <p:cNvPr id="10" name="Shape 0">
+            <a:extLst>
+              <a:ext uri="{FF2B5EF4-FFF2-40B4-BE49-F238E27FC236}">
+                <a16:creationId xmlns:a16="http://schemas.microsoft.com/office/drawing/2014/main" id="{6C498870-44BD-C17F-F7FC-10CCCEDDE0A3}"/>
+              </a:ext>
+            </a:extLst>
+          </p:cNvPr>
+          <p:cNvSpPr/>
+          <p:nvPr/>
+        </p:nvSpPr>
+        <p:spPr>
+          <a:xfrm>
+            <a:off x="0" y="5088636"/>
+            <a:ext cx="9144000" cy="54864"/>
+          </a:xfrm>
+          <a:prstGeom prst="rect">
+            <a:avLst/>
+          </a:prstGeom>
+          <a:solidFill>
+            <a:srgbClr val="0891B2"/>
+          </a:solidFill>
+          <a:ln/>
+        </p:spPr>
+        <p:txBody>
+          <a:bodyPr/>
+          <a:lstStyle/>
+          <a:p>
+            <a:endParaRPr lang="fr-FR"/>
+          </a:p>
+        </p:txBody>
+      </p:sp>
+      <p:sp>
+        <p:nvSpPr>
+          <p:cNvPr id="11" name="Shape 1">
+            <a:extLst>
+              <a:ext uri="{FF2B5EF4-FFF2-40B4-BE49-F238E27FC236}">
+                <a16:creationId xmlns:a16="http://schemas.microsoft.com/office/drawing/2014/main" id="{D30BC3A2-0A5F-99AF-514B-9B513DAAA6DF}"/>
+              </a:ext>
+            </a:extLst>
+          </p:cNvPr>
+          <p:cNvSpPr/>
+          <p:nvPr/>
+        </p:nvSpPr>
+        <p:spPr>
+          <a:xfrm>
+            <a:off x="9107424" y="54864"/>
+            <a:ext cx="36576" cy="5088636"/>
+          </a:xfrm>
+          <a:prstGeom prst="rect">
+            <a:avLst/>
+          </a:prstGeom>
+          <a:solidFill>
+            <a:srgbClr val="0891B2">
+              <a:alpha val="70000"/>
+            </a:srgbClr>
+          </a:solidFill>
+          <a:ln/>
+        </p:spPr>
+        <p:txBody>
+          <a:bodyPr/>
+          <a:lstStyle/>
+          <a:p>
+            <a:endParaRPr lang="fr-FR"/>
+          </a:p>
+        </p:txBody>
+      </p:sp>
+      <p:sp>
+        <p:nvSpPr>
+          <p:cNvPr id="13" name="Slide Number Placeholder 12">
+            <a:extLst>
+              <a:ext uri="{FF2B5EF4-FFF2-40B4-BE49-F238E27FC236}">
+                <a16:creationId xmlns:a16="http://schemas.microsoft.com/office/drawing/2014/main" id="{EF01E84D-3B85-EE0E-39BB-536A85C16ADD}"/>
+              </a:ext>
+            </a:extLst>
+          </p:cNvPr>
+          <p:cNvSpPr>
+            <a:spLocks noGrp="1"/>
+          </p:cNvSpPr>
+          <p:nvPr>
+            <p:ph type="sldNum" sz="quarter" idx="10"/>
+          </p:nvPr>
+        </p:nvSpPr>
+        <p:spPr/>
+        <p:txBody>
+          <a:bodyPr/>
+          <a:lstStyle/>
+          <a:p>
+            <a:fld id="{4945FB95-144E-49FD-B7E5-5AC832B9F648}" type="slidenum">
+              <a:rPr lang="fr-FR" smtClean="0"/>
+              <a:t>1</a:t>
+            </a:fld>
+            <a:endParaRPr lang="fr-FR"/>
           </a:p>
         </p:txBody>
       </p:sp>
@@ -2443,7 +2530,7 @@
           <a:bodyPr/>
           <a:lstStyle/>
           <a:p>
-            <a:endParaRPr lang="fr-FR"/>
+            <a:endParaRPr lang="fr-FR" noProof="1"/>
           </a:p>
         </p:txBody>
       </p:sp>
@@ -2472,7 +2559,7 @@
               <a:buNone/>
             </a:pPr>
             <a:r>
-              <a:rPr lang="en-US" sz="3000" b="1" dirty="0">
+              <a:rPr lang="fr-FR" sz="3000" b="1" noProof="1">
                 <a:solidFill>
                   <a:srgbClr val="0F1B2D"/>
                 </a:solidFill>
@@ -2482,7 +2569,7 @@
               </a:rPr>
               <a:t>Stratégie de migration</a:t>
             </a:r>
-            <a:endParaRPr lang="en-US" sz="3000" dirty="0"/>
+            <a:endParaRPr lang="fr-FR" sz="3000" noProof="1"/>
           </a:p>
         </p:txBody>
       </p:sp>
@@ -2511,7 +2598,7 @@
               <a:buNone/>
             </a:pPr>
             <a:r>
-              <a:rPr lang="en-US" sz="1200" i="1" dirty="0">
+              <a:rPr lang="fr-FR" sz="1200" i="1" noProof="1">
                 <a:solidFill>
                   <a:srgbClr val="334155"/>
                 </a:solidFill>
@@ -2519,9 +2606,9 @@
                 <a:ea typeface="Calibri" pitchFamily="34" charset="-122"/>
                 <a:cs typeface="Calibri" pitchFamily="34" charset="-120"/>
               </a:rPr>
-              <a:t>6 phases sur 6 semaines — migrations nocturnes — rollback à chaque étape</a:t>
-            </a:r>
-            <a:endParaRPr lang="en-US" sz="1200" dirty="0"/>
+              <a:t>6 phases sur 6 semaines - migrations nocturnes - rollback à chaque étape</a:t>
+            </a:r>
+            <a:endParaRPr lang="fr-FR" sz="1200" noProof="1"/>
           </a:p>
         </p:txBody>
       </p:sp>
@@ -2555,7 +2642,7 @@
           <a:bodyPr/>
           <a:lstStyle/>
           <a:p>
-            <a:endParaRPr lang="fr-FR"/>
+            <a:endParaRPr lang="fr-FR" noProof="1"/>
           </a:p>
         </p:txBody>
       </p:sp>
@@ -2582,7 +2669,7 @@
           <a:bodyPr/>
           <a:lstStyle/>
           <a:p>
-            <a:endParaRPr lang="fr-FR"/>
+            <a:endParaRPr lang="fr-FR" noProof="1"/>
           </a:p>
         </p:txBody>
       </p:sp>
@@ -2609,7 +2696,7 @@
           <a:bodyPr/>
           <a:lstStyle/>
           <a:p>
-            <a:endParaRPr lang="fr-FR"/>
+            <a:endParaRPr lang="fr-FR" noProof="1"/>
           </a:p>
         </p:txBody>
       </p:sp>
@@ -2638,7 +2725,7 @@
               <a:buNone/>
             </a:pPr>
             <a:r>
-              <a:rPr lang="en-US" sz="1200" b="1" dirty="0">
+              <a:rPr lang="fr-FR" sz="1200" b="1" noProof="1">
                 <a:solidFill>
                   <a:srgbClr val="FFFFFF"/>
                 </a:solidFill>
@@ -2648,7 +2735,7 @@
               </a:rPr>
               <a:t>M1</a:t>
             </a:r>
-            <a:endParaRPr lang="en-US" sz="1200" dirty="0"/>
+            <a:endParaRPr lang="fr-FR" sz="1200" noProof="1"/>
           </a:p>
         </p:txBody>
       </p:sp>
@@ -2677,7 +2764,7 @@
               <a:buNone/>
             </a:pPr>
             <a:r>
-              <a:rPr lang="en-US" sz="1300" b="1" dirty="0">
+              <a:rPr lang="fr-FR" sz="1300" b="1" noProof="1">
                 <a:solidFill>
                   <a:srgbClr val="0F1B2D"/>
                 </a:solidFill>
@@ -2687,7 +2774,7 @@
               </a:rPr>
               <a:t>Pare-feu</a:t>
             </a:r>
-            <a:endParaRPr lang="en-US" sz="1300" dirty="0"/>
+            <a:endParaRPr lang="fr-FR" sz="1300" noProof="1"/>
           </a:p>
         </p:txBody>
       </p:sp>
@@ -2716,7 +2803,7 @@
               <a:buNone/>
             </a:pPr>
             <a:r>
-              <a:rPr lang="en-US" sz="900" dirty="0">
+              <a:rPr lang="fr-FR" sz="900" noProof="1">
                 <a:solidFill>
                   <a:srgbClr val="334155"/>
                 </a:solidFill>
@@ -2726,7 +2813,7 @@
               </a:rPr>
               <a:t>Remplacement DrayTek/80D → FortiGate</a:t>
             </a:r>
-            <a:endParaRPr lang="en-US" sz="900" dirty="0"/>
+            <a:endParaRPr lang="fr-FR" sz="900" noProof="1"/>
           </a:p>
         </p:txBody>
       </p:sp>
@@ -2753,7 +2840,7 @@
           <a:bodyPr/>
           <a:lstStyle/>
           <a:p>
-            <a:endParaRPr lang="fr-FR"/>
+            <a:endParaRPr lang="fr-FR" noProof="1"/>
           </a:p>
         </p:txBody>
       </p:sp>
@@ -2782,7 +2869,7 @@
               <a:buNone/>
             </a:pPr>
             <a:r>
-              <a:rPr lang="en-US" sz="750" dirty="0">
+              <a:rPr lang="fr-FR" sz="750" noProof="1">
                 <a:solidFill>
                   <a:srgbClr val="0F1B2D"/>
                 </a:solidFill>
@@ -2792,7 +2879,7 @@
               </a:rPr>
               <a:t>5 nuits (S1-S2)</a:t>
             </a:r>
-            <a:endParaRPr lang="en-US" sz="750" dirty="0"/>
+            <a:endParaRPr lang="fr-FR" sz="750" noProof="1"/>
           </a:p>
         </p:txBody>
       </p:sp>
@@ -2821,7 +2908,7 @@
               <a:buNone/>
             </a:pPr>
             <a:r>
-              <a:rPr lang="en-US" sz="800" i="1" dirty="0">
+              <a:rPr lang="fr-FR" sz="800" i="1" noProof="1">
                 <a:solidFill>
                   <a:srgbClr val="94A3B8"/>
                 </a:solidFill>
@@ -2831,7 +2918,7 @@
               </a:rPr>
               <a:t>↩ Rebrancher ancien équipement (~15 min)</a:t>
             </a:r>
-            <a:endParaRPr lang="en-US" sz="800" dirty="0"/>
+            <a:endParaRPr lang="fr-FR" sz="800" noProof="1"/>
           </a:p>
         </p:txBody>
       </p:sp>
@@ -2865,7 +2952,7 @@
           <a:bodyPr/>
           <a:lstStyle/>
           <a:p>
-            <a:endParaRPr lang="fr-FR"/>
+            <a:endParaRPr lang="fr-FR" noProof="1"/>
           </a:p>
         </p:txBody>
       </p:sp>
@@ -2892,7 +2979,7 @@
           <a:bodyPr/>
           <a:lstStyle/>
           <a:p>
-            <a:endParaRPr lang="fr-FR"/>
+            <a:endParaRPr lang="fr-FR" noProof="1"/>
           </a:p>
         </p:txBody>
       </p:sp>
@@ -2919,7 +3006,7 @@
           <a:bodyPr/>
           <a:lstStyle/>
           <a:p>
-            <a:endParaRPr lang="fr-FR"/>
+            <a:endParaRPr lang="fr-FR" noProof="1"/>
           </a:p>
         </p:txBody>
       </p:sp>
@@ -2948,7 +3035,7 @@
               <a:buNone/>
             </a:pPr>
             <a:r>
-              <a:rPr lang="en-US" sz="1200" b="1" dirty="0">
+              <a:rPr lang="fr-FR" sz="1200" b="1" noProof="1">
                 <a:solidFill>
                   <a:srgbClr val="FFFFFF"/>
                 </a:solidFill>
@@ -2958,7 +3045,7 @@
               </a:rPr>
               <a:t>M2</a:t>
             </a:r>
-            <a:endParaRPr lang="en-US" sz="1200" dirty="0"/>
+            <a:endParaRPr lang="fr-FR" sz="1200" noProof="1"/>
           </a:p>
         </p:txBody>
       </p:sp>
@@ -2987,7 +3074,7 @@
               <a:buNone/>
             </a:pPr>
             <a:r>
-              <a:rPr lang="en-US" sz="1300" b="1" dirty="0">
+              <a:rPr lang="fr-FR" sz="1300" b="1" noProof="1">
                 <a:solidFill>
                   <a:srgbClr val="0F1B2D"/>
                 </a:solidFill>
@@ -2997,7 +3084,7 @@
               </a:rPr>
               <a:t>Cluster</a:t>
             </a:r>
-            <a:endParaRPr lang="en-US" sz="1300" dirty="0"/>
+            <a:endParaRPr lang="fr-FR" sz="1300" noProof="1"/>
           </a:p>
         </p:txBody>
       </p:sp>
@@ -3026,7 +3113,7 @@
               <a:buNone/>
             </a:pPr>
             <a:r>
-              <a:rPr lang="en-US" sz="900" dirty="0">
+              <a:rPr lang="fr-FR" sz="900" noProof="1">
                 <a:solidFill>
                   <a:srgbClr val="334155"/>
                 </a:solidFill>
@@ -3036,7 +3123,7 @@
               </a:rPr>
               <a:t>Installation 2x R650xs + SAN ME5012</a:t>
             </a:r>
-            <a:endParaRPr lang="en-US" sz="900" dirty="0"/>
+            <a:endParaRPr lang="fr-FR" sz="900" noProof="1"/>
           </a:p>
         </p:txBody>
       </p:sp>
@@ -3063,7 +3150,7 @@
           <a:bodyPr/>
           <a:lstStyle/>
           <a:p>
-            <a:endParaRPr lang="fr-FR"/>
+            <a:endParaRPr lang="fr-FR" noProof="1"/>
           </a:p>
         </p:txBody>
       </p:sp>
@@ -3092,7 +3179,7 @@
               <a:buNone/>
             </a:pPr>
             <a:r>
-              <a:rPr lang="en-US" sz="750" dirty="0">
+              <a:rPr lang="fr-FR" sz="750" noProof="1">
                 <a:solidFill>
                   <a:srgbClr val="0F1B2D"/>
                 </a:solidFill>
@@ -3102,7 +3189,7 @@
               </a:rPr>
               <a:t>1 WE + 2j (S2-S3)</a:t>
             </a:r>
-            <a:endParaRPr lang="en-US" sz="750" dirty="0"/>
+            <a:endParaRPr lang="fr-FR" sz="750" noProof="1"/>
           </a:p>
         </p:txBody>
       </p:sp>
@@ -3131,7 +3218,7 @@
               <a:buNone/>
             </a:pPr>
             <a:r>
-              <a:rPr lang="en-US" sz="800" i="1" dirty="0">
+              <a:rPr lang="fr-FR" sz="800" i="1" noProof="1">
                 <a:solidFill>
                   <a:srgbClr val="94A3B8"/>
                 </a:solidFill>
@@ -3141,7 +3228,7 @@
               </a:rPr>
               <a:t>↩ R630 reste actif en parallèle</a:t>
             </a:r>
-            <a:endParaRPr lang="en-US" sz="800" dirty="0"/>
+            <a:endParaRPr lang="fr-FR" sz="800" noProof="1"/>
           </a:p>
         </p:txBody>
       </p:sp>
@@ -3175,7 +3262,7 @@
           <a:bodyPr/>
           <a:lstStyle/>
           <a:p>
-            <a:endParaRPr lang="fr-FR"/>
+            <a:endParaRPr lang="fr-FR" noProof="1"/>
           </a:p>
         </p:txBody>
       </p:sp>
@@ -3202,7 +3289,7 @@
           <a:bodyPr/>
           <a:lstStyle/>
           <a:p>
-            <a:endParaRPr lang="fr-FR"/>
+            <a:endParaRPr lang="fr-FR" noProof="1"/>
           </a:p>
         </p:txBody>
       </p:sp>
@@ -3229,7 +3316,7 @@
           <a:bodyPr/>
           <a:lstStyle/>
           <a:p>
-            <a:endParaRPr lang="fr-FR"/>
+            <a:endParaRPr lang="fr-FR" noProof="1"/>
           </a:p>
         </p:txBody>
       </p:sp>
@@ -3258,7 +3345,7 @@
               <a:buNone/>
             </a:pPr>
             <a:r>
-              <a:rPr lang="en-US" sz="1200" b="1" dirty="0">
+              <a:rPr lang="fr-FR" sz="1200" b="1" noProof="1">
                 <a:solidFill>
                   <a:srgbClr val="FFFFFF"/>
                 </a:solidFill>
@@ -3268,7 +3355,7 @@
               </a:rPr>
               <a:t>M3</a:t>
             </a:r>
-            <a:endParaRPr lang="en-US" sz="1200" dirty="0"/>
+            <a:endParaRPr lang="fr-FR" sz="1200" noProof="1"/>
           </a:p>
         </p:txBody>
       </p:sp>
@@ -3297,7 +3384,7 @@
               <a:buNone/>
             </a:pPr>
             <a:r>
-              <a:rPr lang="en-US" sz="1300" b="1" dirty="0">
+              <a:rPr lang="fr-FR" sz="1300" b="1" noProof="1">
                 <a:solidFill>
                   <a:srgbClr val="0F1B2D"/>
                 </a:solidFill>
@@ -3307,7 +3394,7 @@
               </a:rPr>
               <a:t>VMs</a:t>
             </a:r>
-            <a:endParaRPr lang="en-US" sz="1300" dirty="0"/>
+            <a:endParaRPr lang="fr-FR" sz="1300" noProof="1"/>
           </a:p>
         </p:txBody>
       </p:sp>
@@ -3336,7 +3423,7 @@
               <a:buNone/>
             </a:pPr>
             <a:r>
-              <a:rPr lang="en-US" sz="900" dirty="0">
+              <a:rPr lang="fr-FR" sz="900" noProof="1">
                 <a:solidFill>
                   <a:srgbClr val="334155"/>
                 </a:solidFill>
@@ -3346,7 +3433,7 @@
               </a:rPr>
               <a:t>Migration ~20 VMs du R630 → cluster</a:t>
             </a:r>
-            <a:endParaRPr lang="en-US" sz="900" dirty="0"/>
+            <a:endParaRPr lang="fr-FR" sz="900" noProof="1"/>
           </a:p>
         </p:txBody>
       </p:sp>
@@ -3373,7 +3460,7 @@
           <a:bodyPr/>
           <a:lstStyle/>
           <a:p>
-            <a:endParaRPr lang="fr-FR"/>
+            <a:endParaRPr lang="fr-FR" noProof="1"/>
           </a:p>
         </p:txBody>
       </p:sp>
@@ -3402,7 +3489,7 @@
               <a:buNone/>
             </a:pPr>
             <a:r>
-              <a:rPr lang="en-US" sz="750" dirty="0">
+              <a:rPr lang="fr-FR" sz="750" noProof="1">
                 <a:solidFill>
                   <a:srgbClr val="0F1B2D"/>
                 </a:solidFill>
@@ -3412,7 +3499,7 @@
               </a:rPr>
               <a:t>2 nuits WE (S3)</a:t>
             </a:r>
-            <a:endParaRPr lang="en-US" sz="750" dirty="0"/>
+            <a:endParaRPr lang="fr-FR" sz="750" noProof="1"/>
           </a:p>
         </p:txBody>
       </p:sp>
@@ -3441,7 +3528,7 @@
               <a:buNone/>
             </a:pPr>
             <a:r>
-              <a:rPr lang="en-US" sz="800" i="1" dirty="0">
+              <a:rPr lang="fr-FR" sz="800" i="1" noProof="1">
                 <a:solidFill>
                   <a:srgbClr val="94A3B8"/>
                 </a:solidFill>
@@ -3451,7 +3538,7 @@
               </a:rPr>
               <a:t>↩ Restaurer snapshots sur R630 (~30 min)</a:t>
             </a:r>
-            <a:endParaRPr lang="en-US" sz="800" dirty="0"/>
+            <a:endParaRPr lang="fr-FR" sz="800" noProof="1"/>
           </a:p>
         </p:txBody>
       </p:sp>
@@ -3485,7 +3572,7 @@
           <a:bodyPr/>
           <a:lstStyle/>
           <a:p>
-            <a:endParaRPr lang="fr-FR"/>
+            <a:endParaRPr lang="fr-FR" noProof="1"/>
           </a:p>
         </p:txBody>
       </p:sp>
@@ -3512,7 +3599,7 @@
           <a:bodyPr/>
           <a:lstStyle/>
           <a:p>
-            <a:endParaRPr lang="fr-FR"/>
+            <a:endParaRPr lang="fr-FR" noProof="1"/>
           </a:p>
         </p:txBody>
       </p:sp>
@@ -3539,7 +3626,7 @@
           <a:bodyPr/>
           <a:lstStyle/>
           <a:p>
-            <a:endParaRPr lang="fr-FR"/>
+            <a:endParaRPr lang="fr-FR" noProof="1"/>
           </a:p>
         </p:txBody>
       </p:sp>
@@ -3568,7 +3655,7 @@
               <a:buNone/>
             </a:pPr>
             <a:r>
-              <a:rPr lang="en-US" sz="1200" b="1" dirty="0">
+              <a:rPr lang="fr-FR" sz="1200" b="1" noProof="1">
                 <a:solidFill>
                   <a:srgbClr val="FFFFFF"/>
                 </a:solidFill>
@@ -3578,7 +3665,7 @@
               </a:rPr>
               <a:t>M4</a:t>
             </a:r>
-            <a:endParaRPr lang="en-US" sz="1200" dirty="0"/>
+            <a:endParaRPr lang="fr-FR" sz="1200" noProof="1"/>
           </a:p>
         </p:txBody>
       </p:sp>
@@ -3607,7 +3694,7 @@
               <a:buNone/>
             </a:pPr>
             <a:r>
-              <a:rPr lang="en-US" sz="1300" b="1" dirty="0">
+              <a:rPr lang="fr-FR" sz="1300" b="1" noProof="1">
                 <a:solidFill>
                   <a:srgbClr val="0F1B2D"/>
                 </a:solidFill>
@@ -3617,7 +3704,7 @@
               </a:rPr>
               <a:t>Azure</a:t>
             </a:r>
-            <a:endParaRPr lang="en-US" sz="1300" dirty="0"/>
+            <a:endParaRPr lang="fr-FR" sz="1300" noProof="1"/>
           </a:p>
         </p:txBody>
       </p:sp>
@@ -3646,7 +3733,7 @@
               <a:buNone/>
             </a:pPr>
             <a:r>
-              <a:rPr lang="en-US" sz="900" dirty="0">
+              <a:rPr lang="fr-FR" sz="900" noProof="1">
                 <a:solidFill>
                   <a:srgbClr val="334155"/>
                 </a:solidFill>
@@ -3656,7 +3743,7 @@
               </a:rPr>
               <a:t>VPN site-à-site + DC répliqué + ASR</a:t>
             </a:r>
-            <a:endParaRPr lang="en-US" sz="900" dirty="0"/>
+            <a:endParaRPr lang="fr-FR" sz="900" noProof="1"/>
           </a:p>
         </p:txBody>
       </p:sp>
@@ -3683,7 +3770,7 @@
           <a:bodyPr/>
           <a:lstStyle/>
           <a:p>
-            <a:endParaRPr lang="fr-FR"/>
+            <a:endParaRPr lang="fr-FR" noProof="1"/>
           </a:p>
         </p:txBody>
       </p:sp>
@@ -3712,7 +3799,7 @@
               <a:buNone/>
             </a:pPr>
             <a:r>
-              <a:rPr lang="en-US" sz="750" dirty="0">
+              <a:rPr lang="fr-FR" sz="750" noProof="1">
                 <a:solidFill>
                   <a:srgbClr val="0F1B2D"/>
                 </a:solidFill>
@@ -3722,7 +3809,7 @@
               </a:rPr>
               <a:t>3 jours (S4)</a:t>
             </a:r>
-            <a:endParaRPr lang="en-US" sz="750" dirty="0"/>
+            <a:endParaRPr lang="fr-FR" sz="750" noProof="1"/>
           </a:p>
         </p:txBody>
       </p:sp>
@@ -3751,7 +3838,7 @@
               <a:buNone/>
             </a:pPr>
             <a:r>
-              <a:rPr lang="en-US" sz="800" i="1" dirty="0">
+              <a:rPr lang="fr-FR" sz="800" i="1" noProof="1">
                 <a:solidFill>
                   <a:srgbClr val="94A3B8"/>
                 </a:solidFill>
@@ -3761,7 +3848,7 @@
               </a:rPr>
               <a:t>↩ Couper tunnel, supprimer ressources (~5 min)</a:t>
             </a:r>
-            <a:endParaRPr lang="en-US" sz="800" dirty="0"/>
+            <a:endParaRPr lang="fr-FR" sz="800" noProof="1"/>
           </a:p>
         </p:txBody>
       </p:sp>
@@ -3795,7 +3882,7 @@
           <a:bodyPr/>
           <a:lstStyle/>
           <a:p>
-            <a:endParaRPr lang="fr-FR"/>
+            <a:endParaRPr lang="fr-FR" noProof="1"/>
           </a:p>
         </p:txBody>
       </p:sp>
@@ -3822,7 +3909,7 @@
           <a:bodyPr/>
           <a:lstStyle/>
           <a:p>
-            <a:endParaRPr lang="fr-FR"/>
+            <a:endParaRPr lang="fr-FR" noProof="1"/>
           </a:p>
         </p:txBody>
       </p:sp>
@@ -3849,7 +3936,7 @@
           <a:bodyPr/>
           <a:lstStyle/>
           <a:p>
-            <a:endParaRPr lang="fr-FR"/>
+            <a:endParaRPr lang="fr-FR" noProof="1"/>
           </a:p>
         </p:txBody>
       </p:sp>
@@ -3878,7 +3965,7 @@
               <a:buNone/>
             </a:pPr>
             <a:r>
-              <a:rPr lang="en-US" sz="1200" b="1" dirty="0">
+              <a:rPr lang="fr-FR" sz="1200" b="1" noProof="1">
                 <a:solidFill>
                   <a:srgbClr val="FFFFFF"/>
                 </a:solidFill>
@@ -3888,7 +3975,7 @@
               </a:rPr>
               <a:t>M5</a:t>
             </a:r>
-            <a:endParaRPr lang="en-US" sz="1200" dirty="0"/>
+            <a:endParaRPr lang="fr-FR" sz="1200" noProof="1"/>
           </a:p>
         </p:txBody>
       </p:sp>
@@ -3917,7 +4004,7 @@
               <a:buNone/>
             </a:pPr>
             <a:r>
-              <a:rPr lang="en-US" sz="1300" b="1" dirty="0">
+              <a:rPr lang="fr-FR" sz="1300" b="1" noProof="1">
                 <a:solidFill>
                   <a:srgbClr val="0F1B2D"/>
                 </a:solidFill>
@@ -3927,7 +4014,7 @@
               </a:rPr>
               <a:t>QoS/VLAN</a:t>
             </a:r>
-            <a:endParaRPr lang="en-US" sz="1300" dirty="0"/>
+            <a:endParaRPr lang="fr-FR" sz="1300" noProof="1"/>
           </a:p>
         </p:txBody>
       </p:sp>
@@ -3956,7 +4043,7 @@
               <a:buNone/>
             </a:pPr>
             <a:r>
-              <a:rPr lang="en-US" sz="900" dirty="0">
+              <a:rPr lang="fr-FR" sz="900" noProof="1">
                 <a:solidFill>
                   <a:srgbClr val="334155"/>
                 </a:solidFill>
@@ -3966,7 +4053,7 @@
               </a:rPr>
               <a:t>Segmentation 4 VLAN + DSCP + QoS VoIP</a:t>
             </a:r>
-            <a:endParaRPr lang="en-US" sz="900" dirty="0"/>
+            <a:endParaRPr lang="fr-FR" sz="900" noProof="1"/>
           </a:p>
         </p:txBody>
       </p:sp>
@@ -3993,7 +4080,7 @@
           <a:bodyPr/>
           <a:lstStyle/>
           <a:p>
-            <a:endParaRPr lang="fr-FR"/>
+            <a:endParaRPr lang="fr-FR" noProof="1"/>
           </a:p>
         </p:txBody>
       </p:sp>
@@ -4022,7 +4109,7 @@
               <a:buNone/>
             </a:pPr>
             <a:r>
-              <a:rPr lang="en-US" sz="750" dirty="0">
+              <a:rPr lang="fr-FR" sz="750" noProof="1">
                 <a:solidFill>
                   <a:srgbClr val="0F1B2D"/>
                 </a:solidFill>
@@ -4032,7 +4119,7 @@
               </a:rPr>
               <a:t>3 nuits (S5)</a:t>
             </a:r>
-            <a:endParaRPr lang="en-US" sz="750" dirty="0"/>
+            <a:endParaRPr lang="fr-FR" sz="750" noProof="1"/>
           </a:p>
         </p:txBody>
       </p:sp>
@@ -4061,7 +4148,7 @@
               <a:buNone/>
             </a:pPr>
             <a:r>
-              <a:rPr lang="en-US" sz="800" i="1" dirty="0">
+              <a:rPr lang="fr-FR" sz="800" i="1" noProof="1">
                 <a:solidFill>
                   <a:srgbClr val="94A3B8"/>
                 </a:solidFill>
@@ -4071,7 +4158,7 @@
               </a:rPr>
               <a:t>↩ Désactiver VLAN, retour flat (~20 min)</a:t>
             </a:r>
-            <a:endParaRPr lang="en-US" sz="800" dirty="0"/>
+            <a:endParaRPr lang="fr-FR" sz="800" noProof="1"/>
           </a:p>
         </p:txBody>
       </p:sp>
@@ -4105,7 +4192,7 @@
           <a:bodyPr/>
           <a:lstStyle/>
           <a:p>
-            <a:endParaRPr lang="fr-FR"/>
+            <a:endParaRPr lang="fr-FR" noProof="1"/>
           </a:p>
         </p:txBody>
       </p:sp>
@@ -4132,7 +4219,7 @@
           <a:bodyPr/>
           <a:lstStyle/>
           <a:p>
-            <a:endParaRPr lang="fr-FR"/>
+            <a:endParaRPr lang="fr-FR" noProof="1"/>
           </a:p>
         </p:txBody>
       </p:sp>
@@ -4159,7 +4246,7 @@
           <a:bodyPr/>
           <a:lstStyle/>
           <a:p>
-            <a:endParaRPr lang="fr-FR"/>
+            <a:endParaRPr lang="fr-FR" noProof="1"/>
           </a:p>
         </p:txBody>
       </p:sp>
@@ -4188,7 +4275,7 @@
               <a:buNone/>
             </a:pPr>
             <a:r>
-              <a:rPr lang="en-US" sz="1200" b="1" dirty="0">
+              <a:rPr lang="fr-FR" sz="1200" b="1" noProof="1">
                 <a:solidFill>
                   <a:srgbClr val="FFFFFF"/>
                 </a:solidFill>
@@ -4198,7 +4285,7 @@
               </a:rPr>
               <a:t>M6</a:t>
             </a:r>
-            <a:endParaRPr lang="en-US" sz="1200" dirty="0"/>
+            <a:endParaRPr lang="fr-FR" sz="1200" noProof="1"/>
           </a:p>
         </p:txBody>
       </p:sp>
@@ -4227,7 +4314,7 @@
               <a:buNone/>
             </a:pPr>
             <a:r>
-              <a:rPr lang="en-US" sz="1300" b="1" dirty="0">
+              <a:rPr lang="fr-FR" sz="1300" b="1" noProof="1">
                 <a:solidFill>
                   <a:srgbClr val="0F1B2D"/>
                 </a:solidFill>
@@ -4237,7 +4324,7 @@
               </a:rPr>
               <a:t>Validation</a:t>
             </a:r>
-            <a:endParaRPr lang="en-US" sz="1300" dirty="0"/>
+            <a:endParaRPr lang="fr-FR" sz="1300" noProof="1"/>
           </a:p>
         </p:txBody>
       </p:sp>
@@ -4266,7 +4353,7 @@
               <a:buNone/>
             </a:pPr>
             <a:r>
-              <a:rPr lang="en-US" sz="900" dirty="0">
+              <a:rPr lang="fr-FR" sz="900" noProof="1">
                 <a:solidFill>
                   <a:srgbClr val="334155"/>
                 </a:solidFill>
@@ -4276,7 +4363,7 @@
               </a:rPr>
               <a:t>Tests bout en bout + test PRA complet</a:t>
             </a:r>
-            <a:endParaRPr lang="en-US" sz="900" dirty="0"/>
+            <a:endParaRPr lang="fr-FR" sz="900" noProof="1"/>
           </a:p>
         </p:txBody>
       </p:sp>
@@ -4303,7 +4390,7 @@
           <a:bodyPr/>
           <a:lstStyle/>
           <a:p>
-            <a:endParaRPr lang="fr-FR"/>
+            <a:endParaRPr lang="fr-FR" noProof="1"/>
           </a:p>
         </p:txBody>
       </p:sp>
@@ -4332,7 +4419,7 @@
               <a:buNone/>
             </a:pPr>
             <a:r>
-              <a:rPr lang="en-US" sz="750" dirty="0">
+              <a:rPr lang="fr-FR" sz="750" noProof="1">
                 <a:solidFill>
                   <a:srgbClr val="0F1B2D"/>
                 </a:solidFill>
@@ -4342,7 +4429,7 @@
               </a:rPr>
               <a:t>1 WE (S6)</a:t>
             </a:r>
-            <a:endParaRPr lang="en-US" sz="750" dirty="0"/>
+            <a:endParaRPr lang="fr-FR" sz="750" noProof="1"/>
           </a:p>
         </p:txBody>
       </p:sp>
@@ -4371,7 +4458,7 @@
               <a:buNone/>
             </a:pPr>
             <a:r>
-              <a:rPr lang="en-US" sz="800" i="1" dirty="0">
+              <a:rPr lang="fr-FR" sz="800" i="1" noProof="1">
                 <a:solidFill>
                   <a:srgbClr val="94A3B8"/>
                 </a:solidFill>
@@ -4381,7 +4468,7 @@
               </a:rPr>
               <a:t>↩ Non applicable (tests uniquement)</a:t>
             </a:r>
-            <a:endParaRPr lang="en-US" sz="800" dirty="0"/>
+            <a:endParaRPr lang="fr-FR" sz="800" noProof="1"/>
           </a:p>
         </p:txBody>
       </p:sp>
@@ -4408,7 +4495,7 @@
           <a:bodyPr/>
           <a:lstStyle/>
           <a:p>
-            <a:endParaRPr lang="fr-FR"/>
+            <a:endParaRPr lang="fr-FR" noProof="1"/>
           </a:p>
         </p:txBody>
       </p:sp>
@@ -4437,7 +4524,7 @@
               <a:buNone/>
             </a:pPr>
             <a:r>
-              <a:rPr lang="en-US" sz="1000" b="1" dirty="0">
+              <a:rPr lang="fr-FR" sz="1000" b="1" noProof="1">
                 <a:solidFill>
                   <a:srgbClr val="FFFFFF"/>
                 </a:solidFill>
@@ -4447,7 +4534,7 @@
               </a:rPr>
               <a:t>Planning : 6 semaines — interventions nocturnes et week-ends uniquement</a:t>
             </a:r>
-            <a:endParaRPr lang="en-US" sz="1000" dirty="0"/>
+            <a:endParaRPr lang="fr-FR" sz="1000" noProof="1"/>
           </a:p>
         </p:txBody>
       </p:sp>
@@ -4460,7 +4547,7 @@
         <p:spPr>
           <a:xfrm>
             <a:off x="914400" y="4206240"/>
-            <a:ext cx="1280160" cy="201168"/>
+            <a:ext cx="1280160" cy="173464"/>
           </a:xfrm>
           <a:prstGeom prst="rect">
             <a:avLst/>
@@ -4470,7 +4557,7 @@
           </a:solidFill>
           <a:ln w="6350">
             <a:solidFill>
-              <a:srgbClr val="E2E8F0"/>
+              <a:schemeClr val="tx1"/>
             </a:solidFill>
             <a:prstDash val="solid"/>
           </a:ln>
@@ -4479,7 +4566,7 @@
           <a:bodyPr/>
           <a:lstStyle/>
           <a:p>
-            <a:endParaRPr lang="fr-FR"/>
+            <a:endParaRPr lang="fr-FR" noProof="1"/>
           </a:p>
         </p:txBody>
       </p:sp>
@@ -4492,7 +4579,7 @@
         <p:spPr>
           <a:xfrm>
             <a:off x="914400" y="4206240"/>
-            <a:ext cx="1280160" cy="201168"/>
+            <a:ext cx="1280160" cy="173464"/>
           </a:xfrm>
           <a:prstGeom prst="rect">
             <a:avLst/>
@@ -4508,7 +4595,7 @@
               <a:buNone/>
             </a:pPr>
             <a:r>
-              <a:rPr lang="en-US" sz="800" b="1" dirty="0">
+              <a:rPr lang="fr-FR" sz="800" b="1" noProof="1">
                 <a:solidFill>
                   <a:srgbClr val="0F1B2D"/>
                 </a:solidFill>
@@ -4518,7 +4605,7 @@
               </a:rPr>
               <a:t>S1</a:t>
             </a:r>
-            <a:endParaRPr lang="en-US" sz="800" dirty="0"/>
+            <a:endParaRPr lang="fr-FR" sz="800" noProof="1"/>
           </a:p>
         </p:txBody>
       </p:sp>
@@ -4531,7 +4618,7 @@
         <p:spPr>
           <a:xfrm>
             <a:off x="2194560" y="4206240"/>
-            <a:ext cx="1280160" cy="201168"/>
+            <a:ext cx="1280160" cy="173464"/>
           </a:xfrm>
           <a:prstGeom prst="rect">
             <a:avLst/>
@@ -4541,7 +4628,7 @@
           </a:solidFill>
           <a:ln w="6350">
             <a:solidFill>
-              <a:srgbClr val="E2E8F0"/>
+              <a:schemeClr val="tx1"/>
             </a:solidFill>
             <a:prstDash val="solid"/>
           </a:ln>
@@ -4550,7 +4637,7 @@
           <a:bodyPr/>
           <a:lstStyle/>
           <a:p>
-            <a:endParaRPr lang="fr-FR"/>
+            <a:endParaRPr lang="fr-FR" noProof="1"/>
           </a:p>
         </p:txBody>
       </p:sp>
@@ -4563,7 +4650,7 @@
         <p:spPr>
           <a:xfrm>
             <a:off x="2194560" y="4206240"/>
-            <a:ext cx="1280160" cy="201168"/>
+            <a:ext cx="1280160" cy="173464"/>
           </a:xfrm>
           <a:prstGeom prst="rect">
             <a:avLst/>
@@ -4579,7 +4666,7 @@
               <a:buNone/>
             </a:pPr>
             <a:r>
-              <a:rPr lang="en-US" sz="800" b="1" dirty="0">
+              <a:rPr lang="fr-FR" sz="800" b="1" noProof="1">
                 <a:solidFill>
                   <a:srgbClr val="0F1B2D"/>
                 </a:solidFill>
@@ -4589,7 +4676,7 @@
               </a:rPr>
               <a:t>S2</a:t>
             </a:r>
-            <a:endParaRPr lang="en-US" sz="800" dirty="0"/>
+            <a:endParaRPr lang="fr-FR" sz="800" noProof="1"/>
           </a:p>
         </p:txBody>
       </p:sp>
@@ -4602,7 +4689,7 @@
         <p:spPr>
           <a:xfrm>
             <a:off x="3474720" y="4206240"/>
-            <a:ext cx="1280160" cy="201168"/>
+            <a:ext cx="1280160" cy="173464"/>
           </a:xfrm>
           <a:prstGeom prst="rect">
             <a:avLst/>
@@ -4612,7 +4699,7 @@
           </a:solidFill>
           <a:ln w="6350">
             <a:solidFill>
-              <a:srgbClr val="E2E8F0"/>
+              <a:schemeClr val="tx1"/>
             </a:solidFill>
             <a:prstDash val="solid"/>
           </a:ln>
@@ -4621,7 +4708,7 @@
           <a:bodyPr/>
           <a:lstStyle/>
           <a:p>
-            <a:endParaRPr lang="fr-FR"/>
+            <a:endParaRPr lang="fr-FR" noProof="1"/>
           </a:p>
         </p:txBody>
       </p:sp>
@@ -4634,7 +4721,7 @@
         <p:spPr>
           <a:xfrm>
             <a:off x="3474720" y="4206240"/>
-            <a:ext cx="1280160" cy="201168"/>
+            <a:ext cx="1280160" cy="173464"/>
           </a:xfrm>
           <a:prstGeom prst="rect">
             <a:avLst/>
@@ -4650,7 +4737,7 @@
               <a:buNone/>
             </a:pPr>
             <a:r>
-              <a:rPr lang="en-US" sz="800" b="1" dirty="0">
+              <a:rPr lang="fr-FR" sz="800" b="1" noProof="1">
                 <a:solidFill>
                   <a:srgbClr val="0F1B2D"/>
                 </a:solidFill>
@@ -4660,7 +4747,7 @@
               </a:rPr>
               <a:t>S3</a:t>
             </a:r>
-            <a:endParaRPr lang="en-US" sz="800" dirty="0"/>
+            <a:endParaRPr lang="fr-FR" sz="800" noProof="1"/>
           </a:p>
         </p:txBody>
       </p:sp>
@@ -4673,7 +4760,7 @@
         <p:spPr>
           <a:xfrm>
             <a:off x="4754880" y="4206240"/>
-            <a:ext cx="1280160" cy="201168"/>
+            <a:ext cx="1280160" cy="173464"/>
           </a:xfrm>
           <a:prstGeom prst="rect">
             <a:avLst/>
@@ -4683,7 +4770,7 @@
           </a:solidFill>
           <a:ln w="6350">
             <a:solidFill>
-              <a:srgbClr val="E2E8F0"/>
+              <a:schemeClr val="tx1"/>
             </a:solidFill>
             <a:prstDash val="solid"/>
           </a:ln>
@@ -4692,7 +4779,7 @@
           <a:bodyPr/>
           <a:lstStyle/>
           <a:p>
-            <a:endParaRPr lang="fr-FR"/>
+            <a:endParaRPr lang="fr-FR" noProof="1"/>
           </a:p>
         </p:txBody>
       </p:sp>
@@ -4705,7 +4792,7 @@
         <p:spPr>
           <a:xfrm>
             <a:off x="4754880" y="4206240"/>
-            <a:ext cx="1280160" cy="201168"/>
+            <a:ext cx="1280160" cy="173464"/>
           </a:xfrm>
           <a:prstGeom prst="rect">
             <a:avLst/>
@@ -4721,7 +4808,7 @@
               <a:buNone/>
             </a:pPr>
             <a:r>
-              <a:rPr lang="en-US" sz="800" b="1" dirty="0">
+              <a:rPr lang="fr-FR" sz="800" b="1" noProof="1">
                 <a:solidFill>
                   <a:srgbClr val="0F1B2D"/>
                 </a:solidFill>
@@ -4731,7 +4818,7 @@
               </a:rPr>
               <a:t>S4</a:t>
             </a:r>
-            <a:endParaRPr lang="en-US" sz="800" dirty="0"/>
+            <a:endParaRPr lang="fr-FR" sz="800" noProof="1"/>
           </a:p>
         </p:txBody>
       </p:sp>
@@ -4744,7 +4831,7 @@
         <p:spPr>
           <a:xfrm>
             <a:off x="6035040" y="4206240"/>
-            <a:ext cx="1280160" cy="201168"/>
+            <a:ext cx="1280160" cy="173464"/>
           </a:xfrm>
           <a:prstGeom prst="rect">
             <a:avLst/>
@@ -4754,7 +4841,7 @@
           </a:solidFill>
           <a:ln w="6350">
             <a:solidFill>
-              <a:srgbClr val="E2E8F0"/>
+              <a:schemeClr val="tx1"/>
             </a:solidFill>
             <a:prstDash val="solid"/>
           </a:ln>
@@ -4763,7 +4850,7 @@
           <a:bodyPr/>
           <a:lstStyle/>
           <a:p>
-            <a:endParaRPr lang="fr-FR"/>
+            <a:endParaRPr lang="fr-FR" noProof="1"/>
           </a:p>
         </p:txBody>
       </p:sp>
@@ -4776,7 +4863,7 @@
         <p:spPr>
           <a:xfrm>
             <a:off x="6035040" y="4206240"/>
-            <a:ext cx="1280160" cy="201168"/>
+            <a:ext cx="1280160" cy="173464"/>
           </a:xfrm>
           <a:prstGeom prst="rect">
             <a:avLst/>
@@ -4792,7 +4879,7 @@
               <a:buNone/>
             </a:pPr>
             <a:r>
-              <a:rPr lang="en-US" sz="800" b="1" dirty="0">
+              <a:rPr lang="fr-FR" sz="800" b="1" noProof="1">
                 <a:solidFill>
                   <a:srgbClr val="0F1B2D"/>
                 </a:solidFill>
@@ -4802,7 +4889,7 @@
               </a:rPr>
               <a:t>S5</a:t>
             </a:r>
-            <a:endParaRPr lang="en-US" sz="800" dirty="0"/>
+            <a:endParaRPr lang="fr-FR" sz="800" noProof="1"/>
           </a:p>
         </p:txBody>
       </p:sp>
@@ -4815,7 +4902,7 @@
         <p:spPr>
           <a:xfrm>
             <a:off x="7315200" y="4206240"/>
-            <a:ext cx="1280160" cy="201168"/>
+            <a:ext cx="1280160" cy="173464"/>
           </a:xfrm>
           <a:prstGeom prst="rect">
             <a:avLst/>
@@ -4825,7 +4912,7 @@
           </a:solidFill>
           <a:ln w="6350">
             <a:solidFill>
-              <a:srgbClr val="E2E8F0"/>
+              <a:schemeClr val="tx1"/>
             </a:solidFill>
             <a:prstDash val="solid"/>
           </a:ln>
@@ -4834,7 +4921,7 @@
           <a:bodyPr/>
           <a:lstStyle/>
           <a:p>
-            <a:endParaRPr lang="fr-FR"/>
+            <a:endParaRPr lang="fr-FR" noProof="1"/>
           </a:p>
         </p:txBody>
       </p:sp>
@@ -4847,7 +4934,7 @@
         <p:spPr>
           <a:xfrm>
             <a:off x="7315200" y="4206240"/>
-            <a:ext cx="1280160" cy="201168"/>
+            <a:ext cx="1280160" cy="173464"/>
           </a:xfrm>
           <a:prstGeom prst="rect">
             <a:avLst/>
@@ -4863,7 +4950,7 @@
               <a:buNone/>
             </a:pPr>
             <a:r>
-              <a:rPr lang="en-US" sz="800" b="1" dirty="0">
+              <a:rPr lang="fr-FR" sz="800" b="1" noProof="1">
                 <a:solidFill>
                   <a:srgbClr val="0F1B2D"/>
                 </a:solidFill>
@@ -4873,7 +4960,7 @@
               </a:rPr>
               <a:t>S6</a:t>
             </a:r>
-            <a:endParaRPr lang="en-US" sz="800" dirty="0"/>
+            <a:endParaRPr lang="fr-FR" sz="800" noProof="1"/>
           </a:p>
         </p:txBody>
       </p:sp>
@@ -4885,7 +4972,7 @@
         </p:nvSpPr>
         <p:spPr>
           <a:xfrm>
-            <a:off x="914400" y="4443984"/>
+            <a:off x="914400" y="4393556"/>
             <a:ext cx="2560320" cy="100584"/>
           </a:xfrm>
           <a:prstGeom prst="rect">
@@ -4900,7 +4987,7 @@
           <a:bodyPr/>
           <a:lstStyle/>
           <a:p>
-            <a:endParaRPr lang="fr-FR"/>
+            <a:endParaRPr lang="fr-FR" noProof="1"/>
           </a:p>
         </p:txBody>
       </p:sp>
@@ -4912,7 +4999,7 @@
         </p:nvSpPr>
         <p:spPr>
           <a:xfrm>
-            <a:off x="914400" y="4443984"/>
+            <a:off x="914400" y="4400482"/>
             <a:ext cx="2560320" cy="100584"/>
           </a:xfrm>
           <a:prstGeom prst="rect">
@@ -4929,7 +5016,7 @@
               <a:buNone/>
             </a:pPr>
             <a:r>
-              <a:rPr lang="en-US" sz="600" b="1" dirty="0">
+              <a:rPr lang="fr-FR" sz="600" b="1" noProof="1">
                 <a:solidFill>
                   <a:srgbClr val="FFFFFF"/>
                 </a:solidFill>
@@ -4939,7 +5026,7 @@
               </a:rPr>
               <a:t>M1</a:t>
             </a:r>
-            <a:endParaRPr lang="en-US" sz="600" dirty="0"/>
+            <a:endParaRPr lang="fr-FR" sz="600" noProof="1"/>
           </a:p>
         </p:txBody>
       </p:sp>
@@ -4951,7 +5038,7 @@
         </p:nvSpPr>
         <p:spPr>
           <a:xfrm>
-            <a:off x="2834640" y="4572000"/>
+            <a:off x="2834640" y="4507992"/>
             <a:ext cx="1920240" cy="100584"/>
           </a:xfrm>
           <a:prstGeom prst="rect">
@@ -4966,7 +5053,7 @@
           <a:bodyPr/>
           <a:lstStyle/>
           <a:p>
-            <a:endParaRPr lang="fr-FR"/>
+            <a:endParaRPr lang="fr-FR" noProof="1"/>
           </a:p>
         </p:txBody>
       </p:sp>
@@ -4978,7 +5065,7 @@
         </p:nvSpPr>
         <p:spPr>
           <a:xfrm>
-            <a:off x="2834640" y="4572000"/>
+            <a:off x="2834640" y="4507992"/>
             <a:ext cx="1920240" cy="100584"/>
           </a:xfrm>
           <a:prstGeom prst="rect">
@@ -4995,7 +5082,7 @@
               <a:buNone/>
             </a:pPr>
             <a:r>
-              <a:rPr lang="en-US" sz="600" b="1" dirty="0">
+              <a:rPr lang="fr-FR" sz="600" b="1" noProof="1">
                 <a:solidFill>
                   <a:srgbClr val="FFFFFF"/>
                 </a:solidFill>
@@ -5005,7 +5092,7 @@
               </a:rPr>
               <a:t>M2</a:t>
             </a:r>
-            <a:endParaRPr lang="en-US" sz="600" dirty="0"/>
+            <a:endParaRPr lang="fr-FR" sz="600" noProof="1"/>
           </a:p>
         </p:txBody>
       </p:sp>
@@ -5017,7 +5104,7 @@
         </p:nvSpPr>
         <p:spPr>
           <a:xfrm>
-            <a:off x="4114800" y="4700016"/>
+            <a:off x="4114800" y="4636008"/>
             <a:ext cx="640080" cy="100584"/>
           </a:xfrm>
           <a:prstGeom prst="rect">
@@ -5032,7 +5119,7 @@
           <a:bodyPr/>
           <a:lstStyle/>
           <a:p>
-            <a:endParaRPr lang="fr-FR"/>
+            <a:endParaRPr lang="fr-FR" noProof="1"/>
           </a:p>
         </p:txBody>
       </p:sp>
@@ -5044,7 +5131,7 @@
         </p:nvSpPr>
         <p:spPr>
           <a:xfrm>
-            <a:off x="4114800" y="4700016"/>
+            <a:off x="4114800" y="4636008"/>
             <a:ext cx="640080" cy="100584"/>
           </a:xfrm>
           <a:prstGeom prst="rect">
@@ -5061,7 +5148,7 @@
               <a:buNone/>
             </a:pPr>
             <a:r>
-              <a:rPr lang="en-US" sz="600" b="1" dirty="0">
+              <a:rPr lang="fr-FR" sz="600" b="1" noProof="1">
                 <a:solidFill>
                   <a:srgbClr val="FFFFFF"/>
                 </a:solidFill>
@@ -5071,7 +5158,7 @@
               </a:rPr>
               <a:t>M3</a:t>
             </a:r>
-            <a:endParaRPr lang="en-US" sz="600" dirty="0"/>
+            <a:endParaRPr lang="fr-FR" sz="600" noProof="1"/>
           </a:p>
         </p:txBody>
       </p:sp>
@@ -5083,7 +5170,7 @@
         </p:nvSpPr>
         <p:spPr>
           <a:xfrm>
-            <a:off x="4754880" y="4828032"/>
+            <a:off x="4754880" y="4764024"/>
             <a:ext cx="1280160" cy="100584"/>
           </a:xfrm>
           <a:prstGeom prst="rect">
@@ -5098,7 +5185,7 @@
           <a:bodyPr/>
           <a:lstStyle/>
           <a:p>
-            <a:endParaRPr lang="fr-FR"/>
+            <a:endParaRPr lang="fr-FR" noProof="1"/>
           </a:p>
         </p:txBody>
       </p:sp>
@@ -5110,7 +5197,7 @@
         </p:nvSpPr>
         <p:spPr>
           <a:xfrm>
-            <a:off x="4754880" y="4828032"/>
+            <a:off x="4754880" y="4764024"/>
             <a:ext cx="1280160" cy="100584"/>
           </a:xfrm>
           <a:prstGeom prst="rect">
@@ -5127,7 +5214,7 @@
               <a:buNone/>
             </a:pPr>
             <a:r>
-              <a:rPr lang="en-US" sz="600" b="1" dirty="0">
+              <a:rPr lang="fr-FR" sz="600" b="1" noProof="1">
                 <a:solidFill>
                   <a:srgbClr val="FFFFFF"/>
                 </a:solidFill>
@@ -5137,7 +5224,7 @@
               </a:rPr>
               <a:t>M4</a:t>
             </a:r>
-            <a:endParaRPr lang="en-US" sz="600" dirty="0"/>
+            <a:endParaRPr lang="fr-FR" sz="600" noProof="1"/>
           </a:p>
         </p:txBody>
       </p:sp>
@@ -5149,7 +5236,7 @@
         </p:nvSpPr>
         <p:spPr>
           <a:xfrm>
-            <a:off x="6035040" y="4956048"/>
+            <a:off x="6035040" y="4892040"/>
             <a:ext cx="1280160" cy="100584"/>
           </a:xfrm>
           <a:prstGeom prst="rect">
@@ -5164,7 +5251,7 @@
           <a:bodyPr/>
           <a:lstStyle/>
           <a:p>
-            <a:endParaRPr lang="fr-FR"/>
+            <a:endParaRPr lang="fr-FR" noProof="1"/>
           </a:p>
         </p:txBody>
       </p:sp>
@@ -5176,7 +5263,7 @@
         </p:nvSpPr>
         <p:spPr>
           <a:xfrm>
-            <a:off x="6035040" y="4956048"/>
+            <a:off x="6035040" y="4892040"/>
             <a:ext cx="1280160" cy="100584"/>
           </a:xfrm>
           <a:prstGeom prst="rect">
@@ -5193,7 +5280,7 @@
               <a:buNone/>
             </a:pPr>
             <a:r>
-              <a:rPr lang="en-US" sz="600" b="1" dirty="0">
+              <a:rPr lang="fr-FR" sz="600" b="1" noProof="1">
                 <a:solidFill>
                   <a:srgbClr val="FFFFFF"/>
                 </a:solidFill>
@@ -5203,7 +5290,7 @@
               </a:rPr>
               <a:t>M5</a:t>
             </a:r>
-            <a:endParaRPr lang="en-US" sz="600" dirty="0"/>
+            <a:endParaRPr lang="fr-FR" sz="600" noProof="1"/>
           </a:p>
         </p:txBody>
       </p:sp>
@@ -5215,7 +5302,7 @@
         </p:nvSpPr>
         <p:spPr>
           <a:xfrm>
-            <a:off x="7315200" y="5084064"/>
+            <a:off x="7315200" y="5020056"/>
             <a:ext cx="1280160" cy="100584"/>
           </a:xfrm>
           <a:prstGeom prst="rect">
@@ -5230,7 +5317,7 @@
           <a:bodyPr/>
           <a:lstStyle/>
           <a:p>
-            <a:endParaRPr lang="fr-FR"/>
+            <a:endParaRPr lang="fr-FR" noProof="1"/>
           </a:p>
         </p:txBody>
       </p:sp>
@@ -5242,7 +5329,7 @@
         </p:nvSpPr>
         <p:spPr>
           <a:xfrm>
-            <a:off x="7315200" y="5084064"/>
+            <a:off x="7315200" y="5020056"/>
             <a:ext cx="1280160" cy="100584"/>
           </a:xfrm>
           <a:prstGeom prst="rect">
@@ -5259,7 +5346,7 @@
               <a:buNone/>
             </a:pPr>
             <a:r>
-              <a:rPr lang="en-US" sz="600" b="1" dirty="0">
+              <a:rPr lang="fr-FR" sz="600" b="1" noProof="1">
                 <a:solidFill>
                   <a:srgbClr val="FFFFFF"/>
                 </a:solidFill>
@@ -5269,7 +5356,36 @@
               </a:rPr>
               <a:t>M6</a:t>
             </a:r>
-            <a:endParaRPr lang="en-US" sz="600" dirty="0"/>
+            <a:endParaRPr lang="fr-FR" sz="600" noProof="1"/>
+          </a:p>
+        </p:txBody>
+      </p:sp>
+      <p:sp>
+        <p:nvSpPr>
+          <p:cNvPr id="85" name="Slide Number Placeholder 84">
+            <a:extLst>
+              <a:ext uri="{FF2B5EF4-FFF2-40B4-BE49-F238E27FC236}">
+                <a16:creationId xmlns:a16="http://schemas.microsoft.com/office/drawing/2014/main" id="{73D57D2A-0D78-705A-ECC6-8DD9DFA6CE00}"/>
+              </a:ext>
+            </a:extLst>
+          </p:cNvPr>
+          <p:cNvSpPr>
+            <a:spLocks noGrp="1"/>
+          </p:cNvSpPr>
+          <p:nvPr>
+            <p:ph type="sldNum" sz="quarter" idx="10"/>
+          </p:nvPr>
+        </p:nvSpPr>
+        <p:spPr/>
+        <p:txBody>
+          <a:bodyPr/>
+          <a:lstStyle/>
+          <a:p>
+            <a:fld id="{4945FB95-144E-49FD-B7E5-5AC832B9F648}" type="slidenum">
+              <a:rPr lang="fr-FR" noProof="1" smtClean="0"/>
+              <a:t>10</a:t>
+            </a:fld>
+            <a:endParaRPr lang="fr-FR" noProof="1"/>
           </a:p>
         </p:txBody>
       </p:sp>
@@ -5419,8 +5535,8 @@
         </p:nvSpPr>
         <p:spPr>
           <a:xfrm>
-            <a:off x="5029200" y="594360"/>
-            <a:ext cx="3657600" cy="228600"/>
+            <a:off x="6544916" y="594360"/>
+            <a:ext cx="2141883" cy="228600"/>
           </a:xfrm>
           <a:prstGeom prst="rect">
             <a:avLst/>
@@ -5437,14 +5553,11 @@
             </a:pPr>
             <a:r>
               <a:rPr lang="en-US" sz="1000" dirty="0">
-                <a:solidFill>
-                  <a:srgbClr val="94A3B8"/>
-                </a:solidFill>
                 <a:latin typeface="Calibri" pitchFamily="34" charset="0"/>
                 <a:ea typeface="Calibri" pitchFamily="34" charset="-122"/>
                 <a:cs typeface="Calibri" pitchFamily="34" charset="-120"/>
               </a:rPr>
-              <a:t>sur 150 000 € max — marge de 12 699 €</a:t>
+              <a:t>sur 150 000 € max - marge de 12 699 €</a:t>
             </a:r>
             <a:endParaRPr lang="en-US" sz="1000" dirty="0"/>
           </a:p>
@@ -5613,8 +5726,8 @@
         </p:nvSpPr>
         <p:spPr>
           <a:xfrm>
-            <a:off x="5943600" y="2011680"/>
-            <a:ext cx="2560320" cy="640080"/>
+            <a:off x="5760721" y="2011680"/>
+            <a:ext cx="2926078" cy="640080"/>
           </a:xfrm>
           <a:prstGeom prst="rect">
             <a:avLst/>
@@ -5630,7 +5743,7 @@
               <a:buNone/>
             </a:pPr>
             <a:r>
-              <a:rPr lang="en-US" sz="1000" dirty="0">
+              <a:rPr lang="en-US" sz="1000" noProof="1">
                 <a:solidFill>
                   <a:srgbClr val="334155"/>
                 </a:solidFill>
@@ -5638,16 +5751,16 @@
                 <a:ea typeface="Calibri" pitchFamily="34" charset="-122"/>
                 <a:cs typeface="Calibri" pitchFamily="34" charset="-120"/>
               </a:rPr>
-              <a:t>CAPEX : ~137k €</a:t>
-            </a:r>
-            <a:endParaRPr lang="en-US" sz="1000" dirty="0"/>
+              <a:t>CAPEX – dépenses d’investissement : ~137k €</a:t>
+            </a:r>
+            <a:endParaRPr lang="en-US" sz="1000" noProof="1"/>
           </a:p>
           <a:p>
             <a:pPr marL="0" indent="0" algn="ctr">
               <a:buNone/>
             </a:pPr>
             <a:r>
-              <a:rPr lang="en-US" sz="1000" dirty="0">
+              <a:rPr lang="en-US" sz="1000" noProof="1">
                 <a:solidFill>
                   <a:srgbClr val="334155"/>
                 </a:solidFill>
@@ -5655,9 +5768,9 @@
                 <a:ea typeface="Calibri" pitchFamily="34" charset="-122"/>
                 <a:cs typeface="Calibri" pitchFamily="34" charset="-120"/>
               </a:rPr>
-              <a:t>OPEX : ~19.3k €/an</a:t>
-            </a:r>
-            <a:endParaRPr lang="en-US" sz="1000" dirty="0"/>
+              <a:t>OPEX – dépenses de fonctionnement: ~19.3k €/an</a:t>
+            </a:r>
+            <a:endParaRPr lang="en-US" sz="1000" noProof="1"/>
           </a:p>
         </p:txBody>
       </p:sp>
@@ -5864,6 +5977,35 @@
               <a:t>2 nœuds vs 3 : -15k €</a:t>
             </a:r>
             <a:endParaRPr lang="en-US" sz="950" dirty="0"/>
+          </a:p>
+        </p:txBody>
+      </p:sp>
+      <p:sp>
+        <p:nvSpPr>
+          <p:cNvPr id="16" name="Slide Number Placeholder 15">
+            <a:extLst>
+              <a:ext uri="{FF2B5EF4-FFF2-40B4-BE49-F238E27FC236}">
+                <a16:creationId xmlns:a16="http://schemas.microsoft.com/office/drawing/2014/main" id="{ACF9C863-FD7B-C8C7-7DB6-32458F494984}"/>
+              </a:ext>
+            </a:extLst>
+          </p:cNvPr>
+          <p:cNvSpPr>
+            <a:spLocks noGrp="1"/>
+          </p:cNvSpPr>
+          <p:nvPr>
+            <p:ph type="sldNum" sz="quarter" idx="10"/>
+          </p:nvPr>
+        </p:nvSpPr>
+        <p:spPr/>
+        <p:txBody>
+          <a:bodyPr/>
+          <a:lstStyle/>
+          <a:p>
+            <a:fld id="{4945FB95-144E-49FD-B7E5-5AC832B9F648}" type="slidenum">
+              <a:rPr lang="fr-FR" smtClean="0"/>
+              <a:t>11</a:t>
+            </a:fld>
+            <a:endParaRPr lang="fr-FR"/>
           </a:p>
         </p:txBody>
       </p:sp>
@@ -6795,6 +6937,35 @@
           </a:p>
         </p:txBody>
       </p:sp>
+      <p:sp>
+        <p:nvSpPr>
+          <p:cNvPr id="26" name="Slide Number Placeholder 25">
+            <a:extLst>
+              <a:ext uri="{FF2B5EF4-FFF2-40B4-BE49-F238E27FC236}">
+                <a16:creationId xmlns:a16="http://schemas.microsoft.com/office/drawing/2014/main" id="{42058E6C-CEA0-7FDC-DB52-9D720FC60D51}"/>
+              </a:ext>
+            </a:extLst>
+          </p:cNvPr>
+          <p:cNvSpPr>
+            <a:spLocks noGrp="1"/>
+          </p:cNvSpPr>
+          <p:nvPr>
+            <p:ph type="sldNum" sz="quarter" idx="10"/>
+          </p:nvPr>
+        </p:nvSpPr>
+        <p:spPr/>
+        <p:txBody>
+          <a:bodyPr/>
+          <a:lstStyle/>
+          <a:p>
+            <a:fld id="{4945FB95-144E-49FD-B7E5-5AC832B9F648}" type="slidenum">
+              <a:rPr lang="fr-FR" smtClean="0"/>
+              <a:t>12</a:t>
+            </a:fld>
+            <a:endParaRPr lang="fr-FR"/>
+          </a:p>
+        </p:txBody>
+      </p:sp>
     </p:spTree>
   </p:cSld>
   <p:clrMapOvr>
@@ -8099,6 +8270,35 @@
           </a:prstGeom>
         </p:spPr>
       </p:pic>
+      <p:sp>
+        <p:nvSpPr>
+          <p:cNvPr id="38" name="Slide Number Placeholder 37">
+            <a:extLst>
+              <a:ext uri="{FF2B5EF4-FFF2-40B4-BE49-F238E27FC236}">
+                <a16:creationId xmlns:a16="http://schemas.microsoft.com/office/drawing/2014/main" id="{6E1AA80D-5AA2-B9AF-E18F-86BD280C9314}"/>
+              </a:ext>
+            </a:extLst>
+          </p:cNvPr>
+          <p:cNvSpPr>
+            <a:spLocks noGrp="1"/>
+          </p:cNvSpPr>
+          <p:nvPr>
+            <p:ph type="sldNum" sz="quarter" idx="10"/>
+          </p:nvPr>
+        </p:nvSpPr>
+        <p:spPr/>
+        <p:txBody>
+          <a:bodyPr/>
+          <a:lstStyle/>
+          <a:p>
+            <a:fld id="{4945FB95-144E-49FD-B7E5-5AC832B9F648}" type="slidenum">
+              <a:rPr lang="fr-FR" smtClean="0"/>
+              <a:t>2</a:t>
+            </a:fld>
+            <a:endParaRPr lang="fr-FR"/>
+          </a:p>
+        </p:txBody>
+      </p:sp>
     </p:spTree>
   </p:cSld>
   <p:clrMapOvr>
@@ -8231,7 +8431,7 @@
                 <a:ea typeface="Calibri" pitchFamily="34" charset="-122"/>
                 <a:cs typeface="Calibri" pitchFamily="34" charset="-120"/>
               </a:rPr>
-              <a:t>NordTransit Logistics — PME logistique, Hauts-de-France</a:t>
+              <a:t>NordTransit Logistics - PME logistique, Hauts-de-France</a:t>
             </a:r>
             <a:endParaRPr lang="en-US" sz="1300" dirty="0"/>
           </a:p>
@@ -8427,7 +8627,10 @@
             <a:r>
               <a:rPr lang="en-US" sz="900" dirty="0">
                 <a:solidFill>
-                  <a:srgbClr val="94A3B8"/>
+                  <a:schemeClr val="tx1">
+                    <a:lumMod val="75000"/>
+                    <a:lumOff val="25000"/>
+                  </a:schemeClr>
                 </a:solidFill>
                 <a:latin typeface="Calibri" pitchFamily="34" charset="0"/>
                 <a:ea typeface="Calibri" pitchFamily="34" charset="-122"/>
@@ -8435,7 +8638,14 @@
               </a:rPr>
               <a:t>Lille, Lens, Valenciennes, Arras</a:t>
             </a:r>
-            <a:endParaRPr lang="en-US" sz="900" dirty="0"/>
+            <a:endParaRPr lang="en-US" sz="900" dirty="0">
+              <a:solidFill>
+                <a:schemeClr val="tx1">
+                  <a:lumMod val="75000"/>
+                  <a:lumOff val="25000"/>
+                </a:schemeClr>
+              </a:solidFill>
+            </a:endParaRPr>
           </a:p>
         </p:txBody>
       </p:sp>
@@ -8629,7 +8839,10 @@
             <a:r>
               <a:rPr lang="en-US" sz="900" dirty="0">
                 <a:solidFill>
-                  <a:srgbClr val="94A3B8"/>
+                  <a:schemeClr val="tx1">
+                    <a:lumMod val="75000"/>
+                    <a:lumOff val="25000"/>
+                  </a:schemeClr>
                 </a:solidFill>
                 <a:latin typeface="Calibri" pitchFamily="34" charset="0"/>
                 <a:ea typeface="Calibri" pitchFamily="34" charset="-122"/>
@@ -8637,7 +8850,14 @@
               </a:rPr>
               <a:t>Jusqu'à 300 en haute saison</a:t>
             </a:r>
-            <a:endParaRPr lang="en-US" sz="900" dirty="0"/>
+            <a:endParaRPr lang="en-US" sz="900" dirty="0">
+              <a:solidFill>
+                <a:schemeClr val="tx1">
+                  <a:lumMod val="75000"/>
+                  <a:lumOff val="25000"/>
+                </a:schemeClr>
+              </a:solidFill>
+            </a:endParaRPr>
           </a:p>
         </p:txBody>
       </p:sp>
@@ -8831,7 +9051,10 @@
             <a:r>
               <a:rPr lang="en-US" sz="900" dirty="0">
                 <a:solidFill>
-                  <a:srgbClr val="94A3B8"/>
+                  <a:schemeClr val="tx1">
+                    <a:lumMod val="75000"/>
+                    <a:lumOff val="25000"/>
+                  </a:schemeClr>
                 </a:solidFill>
                 <a:latin typeface="Calibri" pitchFamily="34" charset="0"/>
                 <a:ea typeface="Calibri" pitchFamily="34" charset="-122"/>
@@ -8839,7 +9062,14 @@
               </a:rPr>
               <a:t>Sur un serveur unique (SPOF)</a:t>
             </a:r>
-            <a:endParaRPr lang="en-US" sz="900" dirty="0"/>
+            <a:endParaRPr lang="en-US" sz="900" dirty="0">
+              <a:solidFill>
+                <a:schemeClr val="tx1">
+                  <a:lumMod val="75000"/>
+                  <a:lumOff val="25000"/>
+                </a:schemeClr>
+              </a:solidFill>
+            </a:endParaRPr>
           </a:p>
         </p:txBody>
       </p:sp>
@@ -9033,7 +9263,10 @@
             <a:r>
               <a:rPr lang="en-US" sz="900" dirty="0">
                 <a:solidFill>
-                  <a:srgbClr val="94A3B8"/>
+                  <a:schemeClr val="tx1">
+                    <a:lumMod val="75000"/>
+                    <a:lumOff val="25000"/>
+                  </a:schemeClr>
                 </a:solidFill>
                 <a:latin typeface="Calibri" pitchFamily="34" charset="0"/>
                 <a:ea typeface="Calibri" pitchFamily="34" charset="-122"/>
@@ -9041,7 +9274,14 @@
               </a:rPr>
               <a:t>1 resp. + 3 techniciens</a:t>
             </a:r>
-            <a:endParaRPr lang="en-US" sz="900" dirty="0"/>
+            <a:endParaRPr lang="en-US" sz="900" dirty="0">
+              <a:solidFill>
+                <a:schemeClr val="tx1">
+                  <a:lumMod val="75000"/>
+                  <a:lumOff val="25000"/>
+                </a:schemeClr>
+              </a:solidFill>
+            </a:endParaRPr>
           </a:p>
         </p:txBody>
       </p:sp>
@@ -9078,7 +9318,7 @@
                 <a:ea typeface="Calibri" pitchFamily="34" charset="-122"/>
                 <a:cs typeface="Calibri" pitchFamily="34" charset="-120"/>
               </a:rPr>
-              <a:t>Système critique : WMS (gestion d'entrepôt) — indisponibilité = arrêt des 4 sites</a:t>
+              <a:t>Système critique : WMS (gestion d'entrepôt) - indisponibilité = arrêt des 4 sites</a:t>
             </a:r>
             <a:endParaRPr lang="en-US" sz="1200" dirty="0"/>
           </a:p>
@@ -9144,9 +9384,38 @@
                 <a:ea typeface="Calibri" pitchFamily="34" charset="-122"/>
                 <a:cs typeface="Calibri" pitchFamily="34" charset="-120"/>
               </a:rPr>
-              <a:t>Horaires critiques WMS : 5h30 — 18h30  |  Active Directory : 24/7  |  VoIP : 7h00 — 18h30</a:t>
+              <a:t>Horaires critiques WMS : 5h30 - 18h30  |  Active Directory : 24/7  |  VoIP : 7h00 - 18h30</a:t>
             </a:r>
             <a:endParaRPr lang="en-US" sz="1100" dirty="0"/>
+          </a:p>
+        </p:txBody>
+      </p:sp>
+      <p:sp>
+        <p:nvSpPr>
+          <p:cNvPr id="32" name="Slide Number Placeholder 31">
+            <a:extLst>
+              <a:ext uri="{FF2B5EF4-FFF2-40B4-BE49-F238E27FC236}">
+                <a16:creationId xmlns:a16="http://schemas.microsoft.com/office/drawing/2014/main" id="{1D0E5894-8811-3D6A-F893-DC5C204E6EB5}"/>
+              </a:ext>
+            </a:extLst>
+          </p:cNvPr>
+          <p:cNvSpPr>
+            <a:spLocks noGrp="1"/>
+          </p:cNvSpPr>
+          <p:nvPr>
+            <p:ph type="sldNum" sz="quarter" idx="10"/>
+          </p:nvPr>
+        </p:nvSpPr>
+        <p:spPr/>
+        <p:txBody>
+          <a:bodyPr/>
+          <a:lstStyle/>
+          <a:p>
+            <a:fld id="{4945FB95-144E-49FD-B7E5-5AC832B9F648}" type="slidenum">
+              <a:rPr lang="fr-FR" smtClean="0"/>
+              <a:t>3</a:t>
+            </a:fld>
+            <a:endParaRPr lang="fr-FR"/>
           </a:p>
         </p:txBody>
       </p:sp>
@@ -9472,7 +9741,7 @@
                 <a:ea typeface="Calibri" pitchFamily="34" charset="-122"/>
                 <a:cs typeface="Calibri" pitchFamily="34" charset="-120"/>
               </a:rPr>
-              <a:t>Serveur unique Dell R630 — panne = arrêt total de tous les services (AD, WMS, VoIP, supervision)</a:t>
+              <a:t>Serveur unique Dell R630 - panne = arrêt total de tous les services (AD, WMS, VoIP, supervision)</a:t>
             </a:r>
             <a:endParaRPr lang="en-US" sz="1100" dirty="0"/>
           </a:p>
@@ -10159,9 +10428,60 @@
                 <a:ea typeface="Calibri" pitchFamily="34" charset="-122"/>
                 <a:cs typeface="Calibri" pitchFamily="34" charset="-120"/>
               </a:rPr>
-              <a:t>Aucune QoS configurée — la voix se coupe quand le réseau est chargé</a:t>
+              <a:t>Aucune QoS </a:t>
+            </a:r>
+            <a:r>
+              <a:rPr lang="en-US" sz="1100" dirty="0" err="1">
+                <a:solidFill>
+                  <a:srgbClr val="334155"/>
+                </a:solidFill>
+                <a:latin typeface="Calibri" pitchFamily="34" charset="0"/>
+                <a:ea typeface="Calibri" pitchFamily="34" charset="-122"/>
+                <a:cs typeface="Calibri" pitchFamily="34" charset="-120"/>
+              </a:rPr>
+              <a:t>configurée</a:t>
+            </a:r>
+            <a:r>
+              <a:rPr lang="en-US" sz="1100" dirty="0">
+                <a:solidFill>
+                  <a:srgbClr val="334155"/>
+                </a:solidFill>
+                <a:latin typeface="Calibri" pitchFamily="34" charset="0"/>
+                <a:ea typeface="Calibri" pitchFamily="34" charset="-122"/>
+                <a:cs typeface="Calibri" pitchFamily="34" charset="-120"/>
+              </a:rPr>
+              <a:t> - la voix se coupe quand le réseau est chargé</a:t>
             </a:r>
             <a:endParaRPr lang="en-US" sz="1100" dirty="0"/>
+          </a:p>
+        </p:txBody>
+      </p:sp>
+      <p:sp>
+        <p:nvSpPr>
+          <p:cNvPr id="32" name="Slide Number Placeholder 31">
+            <a:extLst>
+              <a:ext uri="{FF2B5EF4-FFF2-40B4-BE49-F238E27FC236}">
+                <a16:creationId xmlns:a16="http://schemas.microsoft.com/office/drawing/2014/main" id="{9D4620E7-AE71-B1E4-B937-8A22C1FA8EA5}"/>
+              </a:ext>
+            </a:extLst>
+          </p:cNvPr>
+          <p:cNvSpPr>
+            <a:spLocks noGrp="1"/>
+          </p:cNvSpPr>
+          <p:nvPr>
+            <p:ph type="sldNum" sz="quarter" idx="10"/>
+          </p:nvPr>
+        </p:nvSpPr>
+        <p:spPr/>
+        <p:txBody>
+          <a:bodyPr/>
+          <a:lstStyle/>
+          <a:p>
+            <a:fld id="{4945FB95-144E-49FD-B7E5-5AC832B9F648}" type="slidenum">
+              <a:rPr lang="fr-FR" smtClean="0"/>
+              <a:t>4</a:t>
+            </a:fld>
+            <a:endParaRPr lang="fr-FR"/>
           </a:p>
         </p:txBody>
       </p:sp>
@@ -10391,7 +10711,9 @@
             <a:avLst/>
           </a:prstGeom>
           <a:solidFill>
-            <a:srgbClr val="1A2744"/>
+            <a:schemeClr val="accent5">
+              <a:lumMod val="50000"/>
+            </a:schemeClr>
           </a:solidFill>
           <a:ln/>
         </p:spPr>
@@ -10399,7 +10721,11 @@
           <a:bodyPr/>
           <a:lstStyle/>
           <a:p>
-            <a:endParaRPr lang="fr-FR"/>
+            <a:endParaRPr lang="fr-FR">
+              <a:solidFill>
+                <a:schemeClr val="bg2"/>
+              </a:solidFill>
+            </a:endParaRPr>
           </a:p>
         </p:txBody>
       </p:sp>
@@ -10481,7 +10807,9 @@
             <a:avLst/>
           </a:prstGeom>
           <a:solidFill>
-            <a:srgbClr val="1A2744"/>
+            <a:schemeClr val="accent5">
+              <a:lumMod val="50000"/>
+            </a:schemeClr>
           </a:solidFill>
           <a:ln/>
         </p:spPr>
@@ -10489,7 +10817,11 @@
           <a:bodyPr/>
           <a:lstStyle/>
           <a:p>
-            <a:endParaRPr lang="fr-FR"/>
+            <a:endParaRPr lang="fr-FR">
+              <a:solidFill>
+                <a:schemeClr val="bg2"/>
+              </a:solidFill>
+            </a:endParaRPr>
           </a:p>
         </p:txBody>
       </p:sp>
@@ -10571,7 +10903,9 @@
             <a:avLst/>
           </a:prstGeom>
           <a:solidFill>
-            <a:srgbClr val="1A2744"/>
+            <a:schemeClr val="accent5">
+              <a:lumMod val="50000"/>
+            </a:schemeClr>
           </a:solidFill>
           <a:ln/>
         </p:spPr>
@@ -10579,7 +10913,11 @@
           <a:bodyPr/>
           <a:lstStyle/>
           <a:p>
-            <a:endParaRPr lang="fr-FR"/>
+            <a:endParaRPr lang="fr-FR">
+              <a:solidFill>
+                <a:schemeClr val="bg2"/>
+              </a:solidFill>
+            </a:endParaRPr>
           </a:p>
         </p:txBody>
       </p:sp>
@@ -10661,7 +10999,9 @@
             <a:avLst/>
           </a:prstGeom>
           <a:solidFill>
-            <a:srgbClr val="1A2744"/>
+            <a:schemeClr val="accent5">
+              <a:lumMod val="50000"/>
+            </a:schemeClr>
           </a:solidFill>
           <a:ln/>
         </p:spPr>
@@ -10669,7 +11009,11 @@
           <a:bodyPr/>
           <a:lstStyle/>
           <a:p>
-            <a:endParaRPr lang="fr-FR"/>
+            <a:endParaRPr lang="fr-FR">
+              <a:solidFill>
+                <a:schemeClr val="bg2"/>
+              </a:solidFill>
+            </a:endParaRPr>
           </a:p>
         </p:txBody>
       </p:sp>
@@ -10824,7 +11168,9 @@
             <a:avLst/>
           </a:prstGeom>
           <a:solidFill>
-            <a:srgbClr val="1A2744"/>
+            <a:schemeClr val="accent5">
+              <a:lumMod val="50000"/>
+            </a:schemeClr>
           </a:solidFill>
           <a:ln/>
         </p:spPr>
@@ -10832,7 +11178,11 @@
           <a:bodyPr/>
           <a:lstStyle/>
           <a:p>
-            <a:endParaRPr lang="fr-FR"/>
+            <a:endParaRPr lang="fr-FR">
+              <a:solidFill>
+                <a:schemeClr val="bg2"/>
+              </a:solidFill>
+            </a:endParaRPr>
           </a:p>
         </p:txBody>
       </p:sp>
@@ -10914,7 +11264,9 @@
             <a:avLst/>
           </a:prstGeom>
           <a:solidFill>
-            <a:srgbClr val="1A2744"/>
+            <a:schemeClr val="accent5">
+              <a:lumMod val="50000"/>
+            </a:schemeClr>
           </a:solidFill>
           <a:ln/>
         </p:spPr>
@@ -10922,7 +11274,11 @@
           <a:bodyPr/>
           <a:lstStyle/>
           <a:p>
-            <a:endParaRPr lang="fr-FR"/>
+            <a:endParaRPr lang="fr-FR">
+              <a:solidFill>
+                <a:schemeClr val="bg2"/>
+              </a:solidFill>
+            </a:endParaRPr>
           </a:p>
         </p:txBody>
       </p:sp>
@@ -11166,7 +11522,9 @@
             <a:avLst/>
           </a:prstGeom>
           <a:solidFill>
-            <a:srgbClr val="1A2744"/>
+            <a:schemeClr val="accent4">
+              <a:lumMod val="50000"/>
+            </a:schemeClr>
           </a:solidFill>
           <a:ln/>
         </p:spPr>
@@ -11174,7 +11532,11 @@
           <a:bodyPr/>
           <a:lstStyle/>
           <a:p>
-            <a:endParaRPr lang="fr-FR"/>
+            <a:endParaRPr lang="fr-FR">
+              <a:solidFill>
+                <a:schemeClr val="bg2"/>
+              </a:solidFill>
+            </a:endParaRPr>
           </a:p>
         </p:txBody>
       </p:sp>
@@ -11256,7 +11618,9 @@
             <a:avLst/>
           </a:prstGeom>
           <a:solidFill>
-            <a:srgbClr val="1A2744"/>
+            <a:schemeClr val="accent4">
+              <a:lumMod val="50000"/>
+            </a:schemeClr>
           </a:solidFill>
           <a:ln/>
         </p:spPr>
@@ -11264,7 +11628,11 @@
           <a:bodyPr/>
           <a:lstStyle/>
           <a:p>
-            <a:endParaRPr lang="fr-FR"/>
+            <a:endParaRPr lang="fr-FR">
+              <a:solidFill>
+                <a:schemeClr val="bg2"/>
+              </a:solidFill>
+            </a:endParaRPr>
           </a:p>
         </p:txBody>
       </p:sp>
@@ -11346,7 +11714,9 @@
             <a:avLst/>
           </a:prstGeom>
           <a:solidFill>
-            <a:srgbClr val="1A2744"/>
+            <a:schemeClr val="accent4">
+              <a:lumMod val="50000"/>
+            </a:schemeClr>
           </a:solidFill>
           <a:ln/>
         </p:spPr>
@@ -11354,7 +11724,11 @@
           <a:bodyPr/>
           <a:lstStyle/>
           <a:p>
-            <a:endParaRPr lang="fr-FR"/>
+            <a:endParaRPr lang="fr-FR">
+              <a:solidFill>
+                <a:schemeClr val="bg2"/>
+              </a:solidFill>
+            </a:endParaRPr>
           </a:p>
         </p:txBody>
       </p:sp>
@@ -11429,8 +11803,8 @@
         </p:nvSpPr>
         <p:spPr>
           <a:xfrm>
-            <a:off x="4663440" y="3291840"/>
-            <a:ext cx="548640" cy="0"/>
+            <a:off x="4114800" y="3291840"/>
+            <a:ext cx="1097280" cy="0"/>
           </a:xfrm>
           <a:prstGeom prst="line">
             <a:avLst/>
@@ -11459,7 +11833,7 @@
         </p:nvSpPr>
         <p:spPr>
           <a:xfrm>
-            <a:off x="4114800" y="3063240"/>
+            <a:off x="4389120" y="3406139"/>
             <a:ext cx="594360" cy="457200"/>
           </a:xfrm>
           <a:prstGeom prst="rect">
@@ -11476,7 +11850,7 @@
           <a:bodyPr/>
           <a:lstStyle/>
           <a:p>
-            <a:endParaRPr lang="fr-FR"/>
+            <a:endParaRPr lang="fr-FR" dirty="0"/>
           </a:p>
         </p:txBody>
       </p:sp>
@@ -11488,7 +11862,7 @@
         </p:nvSpPr>
         <p:spPr>
           <a:xfrm>
-            <a:off x="4114800" y="3063240"/>
+            <a:off x="4389120" y="3410712"/>
             <a:ext cx="594360" cy="457200"/>
           </a:xfrm>
           <a:prstGeom prst="rect">
@@ -11601,6 +11975,35 @@
               <a:t>Budget : 137k € / 150k max  —  FortiGate homogènes  —  Cluster HA  —  PRA Azure  —  QoS VoIP</a:t>
             </a:r>
             <a:endParaRPr lang="en-US" sz="1100" dirty="0"/>
+          </a:p>
+        </p:txBody>
+      </p:sp>
+      <p:sp>
+        <p:nvSpPr>
+          <p:cNvPr id="45" name="Slide Number Placeholder 44">
+            <a:extLst>
+              <a:ext uri="{FF2B5EF4-FFF2-40B4-BE49-F238E27FC236}">
+                <a16:creationId xmlns:a16="http://schemas.microsoft.com/office/drawing/2014/main" id="{7981E068-B07D-9551-2F81-AB9B27D31623}"/>
+              </a:ext>
+            </a:extLst>
+          </p:cNvPr>
+          <p:cNvSpPr>
+            <a:spLocks noGrp="1"/>
+          </p:cNvSpPr>
+          <p:nvPr>
+            <p:ph type="sldNum" sz="quarter" idx="10"/>
+          </p:nvPr>
+        </p:nvSpPr>
+        <p:spPr/>
+        <p:txBody>
+          <a:bodyPr/>
+          <a:lstStyle/>
+          <a:p>
+            <a:fld id="{4945FB95-144E-49FD-B7E5-5AC832B9F648}" type="slidenum">
+              <a:rPr lang="fr-FR" smtClean="0"/>
+              <a:t>5</a:t>
+            </a:fld>
+            <a:endParaRPr lang="fr-FR"/>
           </a:p>
         </p:txBody>
       </p:sp>
@@ -12245,7 +12648,7 @@
         </p:nvGraphicFramePr>
         <p:xfrm>
           <a:off x="640080" y="3749040"/>
-          <a:ext cx="7863840" cy="914400"/>
+          <a:ext cx="7863840" cy="1231392"/>
         </p:xfrm>
         <a:graphic>
           <a:graphicData uri="http://schemas.openxmlformats.org/drawingml/2006/table">
@@ -13632,6 +14035,35 @@
           </a:graphicData>
         </a:graphic>
       </p:graphicFrame>
+      <p:sp>
+        <p:nvSpPr>
+          <p:cNvPr id="17" name="Slide Number Placeholder 16">
+            <a:extLst>
+              <a:ext uri="{FF2B5EF4-FFF2-40B4-BE49-F238E27FC236}">
+                <a16:creationId xmlns:a16="http://schemas.microsoft.com/office/drawing/2014/main" id="{800C71C8-35F7-E2D6-8047-50993EEF50B2}"/>
+              </a:ext>
+            </a:extLst>
+          </p:cNvPr>
+          <p:cNvSpPr>
+            <a:spLocks noGrp="1"/>
+          </p:cNvSpPr>
+          <p:nvPr>
+            <p:ph type="sldNum" sz="quarter" idx="10"/>
+          </p:nvPr>
+        </p:nvSpPr>
+        <p:spPr/>
+        <p:txBody>
+          <a:bodyPr/>
+          <a:lstStyle/>
+          <a:p>
+            <a:fld id="{4945FB95-144E-49FD-B7E5-5AC832B9F648}" type="slidenum">
+              <a:rPr lang="fr-FR" smtClean="0"/>
+              <a:t>6</a:t>
+            </a:fld>
+            <a:endParaRPr lang="fr-FR"/>
+          </a:p>
+        </p:txBody>
+      </p:sp>
     </p:spTree>
   </p:cSld>
   <p:clrMapOvr>
@@ -14315,7 +14747,7 @@
         </p:nvGraphicFramePr>
         <p:xfrm>
           <a:off x="640080" y="4023360"/>
-          <a:ext cx="7863840" cy="914400"/>
+          <a:ext cx="7863840" cy="987552"/>
         </p:xfrm>
         <a:graphic>
           <a:graphicData uri="http://schemas.openxmlformats.org/drawingml/2006/table">
@@ -15435,6 +15867,35 @@
           </a:graphicData>
         </a:graphic>
       </p:graphicFrame>
+      <p:sp>
+        <p:nvSpPr>
+          <p:cNvPr id="17" name="Slide Number Placeholder 16">
+            <a:extLst>
+              <a:ext uri="{FF2B5EF4-FFF2-40B4-BE49-F238E27FC236}">
+                <a16:creationId xmlns:a16="http://schemas.microsoft.com/office/drawing/2014/main" id="{B8E0191A-7FA7-021C-3C0F-19978C0EE0B2}"/>
+              </a:ext>
+            </a:extLst>
+          </p:cNvPr>
+          <p:cNvSpPr>
+            <a:spLocks noGrp="1"/>
+          </p:cNvSpPr>
+          <p:nvPr>
+            <p:ph type="sldNum" sz="quarter" idx="10"/>
+          </p:nvPr>
+        </p:nvSpPr>
+        <p:spPr/>
+        <p:txBody>
+          <a:bodyPr/>
+          <a:lstStyle/>
+          <a:p>
+            <a:fld id="{4945FB95-144E-49FD-B7E5-5AC832B9F648}" type="slidenum">
+              <a:rPr lang="fr-FR" smtClean="0"/>
+              <a:t>7</a:t>
+            </a:fld>
+            <a:endParaRPr lang="fr-FR"/>
+          </a:p>
+        </p:txBody>
+      </p:sp>
     </p:spTree>
   </p:cSld>
   <p:clrMapOvr>
@@ -15688,7 +16149,9 @@
             <a:avLst/>
           </a:prstGeom>
           <a:solidFill>
-            <a:srgbClr val="1A2744"/>
+            <a:schemeClr val="accent5">
+              <a:lumMod val="50000"/>
+            </a:schemeClr>
           </a:solidFill>
           <a:ln/>
         </p:spPr>
@@ -15754,7 +16217,9 @@
             <a:avLst/>
           </a:prstGeom>
           <a:solidFill>
-            <a:srgbClr val="1E3A5F"/>
+            <a:schemeClr val="accent5">
+              <a:lumMod val="75000"/>
+            </a:schemeClr>
           </a:solidFill>
           <a:ln/>
         </p:spPr>
@@ -15820,7 +16285,9 @@
             <a:avLst/>
           </a:prstGeom>
           <a:solidFill>
-            <a:srgbClr val="1E3A5F"/>
+            <a:schemeClr val="accent5">
+              <a:lumMod val="75000"/>
+            </a:schemeClr>
           </a:solidFill>
           <a:ln/>
         </p:spPr>
@@ -15886,7 +16353,9 @@
             <a:avLst/>
           </a:prstGeom>
           <a:solidFill>
-            <a:srgbClr val="1E3A5F"/>
+            <a:schemeClr val="accent5">
+              <a:lumMod val="75000"/>
+            </a:schemeClr>
           </a:solidFill>
           <a:ln/>
         </p:spPr>
@@ -15894,7 +16363,7 @@
           <a:bodyPr/>
           <a:lstStyle/>
           <a:p>
-            <a:endParaRPr lang="fr-FR"/>
+            <a:endParaRPr lang="fr-FR" dirty="0"/>
           </a:p>
         </p:txBody>
       </p:sp>
@@ -15952,7 +16421,9 @@
             <a:avLst/>
           </a:prstGeom>
           <a:solidFill>
-            <a:srgbClr val="1E3A5F"/>
+            <a:schemeClr val="accent5">
+              <a:lumMod val="75000"/>
+            </a:schemeClr>
           </a:solidFill>
           <a:ln/>
         </p:spPr>
@@ -16068,9 +16539,6 @@
             </a:pPr>
             <a:r>
               <a:rPr lang="en-US" sz="900" dirty="0">
-                <a:solidFill>
-                  <a:srgbClr val="94A3B8"/>
-                </a:solidFill>
                 <a:latin typeface="Calibri" pitchFamily="34" charset="0"/>
                 <a:ea typeface="Calibri" pitchFamily="34" charset="-122"/>
                 <a:cs typeface="Calibri" pitchFamily="34" charset="-120"/>
@@ -16107,9 +16575,6 @@
             </a:pPr>
             <a:r>
               <a:rPr lang="en-US" sz="800" i="1" dirty="0">
-                <a:solidFill>
-                  <a:srgbClr val="94A3B8"/>
-                </a:solidFill>
                 <a:latin typeface="Calibri" pitchFamily="34" charset="0"/>
                 <a:ea typeface="Calibri" pitchFamily="34" charset="-122"/>
                 <a:cs typeface="Calibri" pitchFamily="34" charset="-120"/>
@@ -16129,7 +16594,7 @@
         <p:spPr>
           <a:xfrm>
             <a:off x="4937760" y="2286000"/>
-            <a:ext cx="594360" cy="0"/>
+            <a:ext cx="731520" cy="0"/>
           </a:xfrm>
           <a:prstGeom prst="line">
             <a:avLst/>
@@ -16137,7 +16602,9 @@
           <a:noFill/>
           <a:ln w="25400">
             <a:solidFill>
-              <a:srgbClr val="0891B2"/>
+              <a:schemeClr val="accent4">
+                <a:lumMod val="75000"/>
+              </a:schemeClr>
             </a:solidFill>
             <a:prstDash val="dash"/>
           </a:ln>
@@ -16158,14 +16625,16 @@
         </p:nvSpPr>
         <p:spPr>
           <a:xfrm>
-            <a:off x="4956048" y="2377440"/>
+            <a:off x="5029200" y="2377440"/>
             <a:ext cx="548640" cy="320040"/>
           </a:xfrm>
           <a:prstGeom prst="rect">
             <a:avLst/>
           </a:prstGeom>
           <a:solidFill>
-            <a:srgbClr val="0891B2"/>
+            <a:schemeClr val="accent4">
+              <a:lumMod val="75000"/>
+            </a:schemeClr>
           </a:solidFill>
           <a:ln/>
         </p:spPr>
@@ -16185,7 +16654,7 @@
         </p:nvSpPr>
         <p:spPr>
           <a:xfrm>
-            <a:off x="4956048" y="2377440"/>
+            <a:off x="5031111" y="2377440"/>
             <a:ext cx="548640" cy="320040"/>
           </a:xfrm>
           <a:prstGeom prst="rect">
@@ -16225,7 +16694,7 @@
         <p:spPr>
           <a:xfrm>
             <a:off x="5669280" y="1325880"/>
-            <a:ext cx="3108960" cy="2103120"/>
+            <a:ext cx="3108960" cy="1691640"/>
           </a:xfrm>
           <a:prstGeom prst="rect">
             <a:avLst/>
@@ -16331,7 +16800,9 @@
             <a:avLst/>
           </a:prstGeom>
           <a:solidFill>
-            <a:srgbClr val="1A2744"/>
+            <a:schemeClr val="accent4">
+              <a:lumMod val="50000"/>
+            </a:schemeClr>
           </a:solidFill>
           <a:ln/>
         </p:spPr>
@@ -16397,7 +16868,9 @@
             <a:avLst/>
           </a:prstGeom>
           <a:solidFill>
-            <a:srgbClr val="1E3A5F"/>
+            <a:schemeClr val="accent4">
+              <a:lumMod val="75000"/>
+            </a:schemeClr>
           </a:solidFill>
           <a:ln/>
         </p:spPr>
@@ -16456,14 +16929,16 @@
         </p:nvSpPr>
         <p:spPr>
           <a:xfrm>
-            <a:off x="5669280" y="3611880"/>
+            <a:off x="5669280" y="3246121"/>
             <a:ext cx="3108960" cy="457200"/>
           </a:xfrm>
           <a:prstGeom prst="rect">
             <a:avLst/>
           </a:prstGeom>
           <a:solidFill>
-            <a:srgbClr val="1A2744"/>
+            <a:schemeClr val="accent5">
+              <a:lumMod val="75000"/>
+            </a:schemeClr>
           </a:solidFill>
           <a:ln/>
         </p:spPr>
@@ -16483,7 +16958,7 @@
         </p:nvSpPr>
         <p:spPr>
           <a:xfrm>
-            <a:off x="5669280" y="3611880"/>
+            <a:off x="5669280" y="3246121"/>
             <a:ext cx="3108960" cy="457200"/>
           </a:xfrm>
           <a:prstGeom prst="rect">
@@ -16502,7 +16977,7 @@
             <a:r>
               <a:rPr lang="en-US" sz="900" dirty="0">
                 <a:solidFill>
-                  <a:srgbClr val="94A3B8"/>
+                  <a:schemeClr val="bg1"/>
                 </a:solidFill>
                 <a:latin typeface="Calibri" pitchFamily="34" charset="0"/>
                 <a:ea typeface="Calibri" pitchFamily="34" charset="-122"/>
@@ -16510,7 +16985,11 @@
               </a:rPr>
               <a:t>Proxmox VE 9.1</a:t>
             </a:r>
-            <a:endParaRPr lang="en-US" sz="900" dirty="0"/>
+            <a:endParaRPr lang="en-US" sz="900" dirty="0">
+              <a:solidFill>
+                <a:schemeClr val="bg1"/>
+              </a:solidFill>
+            </a:endParaRPr>
           </a:p>
           <a:p>
             <a:pPr marL="0" indent="0" algn="ctr">
@@ -16519,7 +16998,7 @@
             <a:r>
               <a:rPr lang="en-US" sz="900" dirty="0">
                 <a:solidFill>
-                  <a:srgbClr val="94A3B8"/>
+                  <a:schemeClr val="bg1"/>
                 </a:solidFill>
                 <a:latin typeface="Calibri" pitchFamily="34" charset="0"/>
                 <a:ea typeface="Calibri" pitchFamily="34" charset="-122"/>
@@ -16527,7 +17006,40 @@
               </a:rPr>
               <a:t>60 Go RAM | 720 Go SSD</a:t>
             </a:r>
-            <a:endParaRPr lang="en-US" sz="900" dirty="0"/>
+            <a:endParaRPr lang="en-US" sz="900" dirty="0">
+              <a:solidFill>
+                <a:schemeClr val="bg1"/>
+              </a:solidFill>
+            </a:endParaRPr>
+          </a:p>
+        </p:txBody>
+      </p:sp>
+      <p:sp>
+        <p:nvSpPr>
+          <p:cNvPr id="33" name="Slide Number Placeholder 32">
+            <a:extLst>
+              <a:ext uri="{FF2B5EF4-FFF2-40B4-BE49-F238E27FC236}">
+                <a16:creationId xmlns:a16="http://schemas.microsoft.com/office/drawing/2014/main" id="{3FFC7F07-F500-B085-F971-6D9B86710CD4}"/>
+              </a:ext>
+            </a:extLst>
+          </p:cNvPr>
+          <p:cNvSpPr>
+            <a:spLocks noGrp="1"/>
+          </p:cNvSpPr>
+          <p:nvPr>
+            <p:ph type="sldNum" sz="quarter" idx="10"/>
+          </p:nvPr>
+        </p:nvSpPr>
+        <p:spPr/>
+        <p:txBody>
+          <a:bodyPr/>
+          <a:lstStyle/>
+          <a:p>
+            <a:fld id="{4945FB95-144E-49FD-B7E5-5AC832B9F648}" type="slidenum">
+              <a:rPr lang="fr-FR" smtClean="0"/>
+              <a:t>8</a:t>
+            </a:fld>
+            <a:endParaRPr lang="fr-FR"/>
           </a:p>
         </p:txBody>
       </p:sp>
@@ -16624,7 +17136,7 @@
                 <a:ea typeface="Trebuchet MS" pitchFamily="34" charset="-122"/>
                 <a:cs typeface="Trebuchet MS" pitchFamily="34" charset="-120"/>
               </a:rPr>
-              <a:t>Résultats POC — 4 tests, 4 PASS</a:t>
+              <a:t>Résultats POC - 4 tests, 4 PASS</a:t>
             </a:r>
             <a:endParaRPr lang="en-US" sz="3200" dirty="0"/>
           </a:p>
@@ -17807,6 +18319,35 @@
               <a:t>Ping &lt; 1ms  |  DNS cross-site  |  Réplication AD OK</a:t>
             </a:r>
             <a:endParaRPr lang="en-US" sz="1000" dirty="0"/>
+          </a:p>
+        </p:txBody>
+      </p:sp>
+      <p:sp>
+        <p:nvSpPr>
+          <p:cNvPr id="40" name="Slide Number Placeholder 39">
+            <a:extLst>
+              <a:ext uri="{FF2B5EF4-FFF2-40B4-BE49-F238E27FC236}">
+                <a16:creationId xmlns:a16="http://schemas.microsoft.com/office/drawing/2014/main" id="{D3B0EC6A-40D6-25A3-C723-481C8E4D5AB6}"/>
+              </a:ext>
+            </a:extLst>
+          </p:cNvPr>
+          <p:cNvSpPr>
+            <a:spLocks noGrp="1"/>
+          </p:cNvSpPr>
+          <p:nvPr>
+            <p:ph type="sldNum" sz="quarter" idx="10"/>
+          </p:nvPr>
+        </p:nvSpPr>
+        <p:spPr/>
+        <p:txBody>
+          <a:bodyPr/>
+          <a:lstStyle/>
+          <a:p>
+            <a:fld id="{4945FB95-144E-49FD-B7E5-5AC832B9F648}" type="slidenum">
+              <a:rPr lang="fr-FR" smtClean="0"/>
+              <a:t>9</a:t>
+            </a:fld>
+            <a:endParaRPr lang="fr-FR"/>
           </a:p>
         </p:txBody>
       </p:sp>
@@ -18426,4 +18967,319 @@
     </a:ext>
   </a:extLst>
 </a:theme>
+</file>
+
+<file path=ppt/theme/theme3.xml><?xml version="1.0" encoding="utf-8"?>
+<a:theme xmlns:a="http://schemas.openxmlformats.org/drawingml/2006/main" name="Office Theme">
+  <a:themeElements>
+    <a:clrScheme name="Office">
+      <a:dk1>
+        <a:sysClr val="windowText" lastClr="000000"/>
+      </a:dk1>
+      <a:lt1>
+        <a:sysClr val="window" lastClr="FFFFFF"/>
+      </a:lt1>
+      <a:dk2>
+        <a:srgbClr val="0E2841"/>
+      </a:dk2>
+      <a:lt2>
+        <a:srgbClr val="E8E8E8"/>
+      </a:lt2>
+      <a:accent1>
+        <a:srgbClr val="156082"/>
+      </a:accent1>
+      <a:accent2>
+        <a:srgbClr val="E97132"/>
+      </a:accent2>
+      <a:accent3>
+        <a:srgbClr val="196B24"/>
+      </a:accent3>
+      <a:accent4>
+        <a:srgbClr val="0F9ED5"/>
+      </a:accent4>
+      <a:accent5>
+        <a:srgbClr val="A02B93"/>
+      </a:accent5>
+      <a:accent6>
+        <a:srgbClr val="4EA72E"/>
+      </a:accent6>
+      <a:hlink>
+        <a:srgbClr val="467886"/>
+      </a:hlink>
+      <a:folHlink>
+        <a:srgbClr val="96607D"/>
+      </a:folHlink>
+    </a:clrScheme>
+    <a:fontScheme name="Office">
+      <a:majorFont>
+        <a:latin typeface="Aptos Display" panose="02110004020202020204"/>
+        <a:ea typeface=""/>
+        <a:cs typeface=""/>
+        <a:font script="Jpan" typeface="游ゴシック Light"/>
+        <a:font script="Hang" typeface="맑은 고딕"/>
+        <a:font script="Hans" typeface="等线 Light"/>
+        <a:font script="Hant" typeface="新細明體"/>
+        <a:font script="Arab" typeface="Times New Roman"/>
+        <a:font script="Hebr" typeface="Times New Roman"/>
+        <a:font script="Thai" typeface="Angsana New"/>
+        <a:font script="Ethi" typeface="Nyala"/>
+        <a:font script="Beng" typeface="Vrinda"/>
+        <a:font script="Gujr" typeface="Shruti"/>
+        <a:font script="Khmr" typeface="MoolBoran"/>
+        <a:font script="Knda" typeface="Tunga"/>
+        <a:font script="Guru" typeface="Raavi"/>
+        <a:font script="Cans" typeface="Euphemia"/>
+        <a:font script="Cher" typeface="Plantagenet Cherokee"/>
+        <a:font script="Yiii" typeface="Microsoft Yi Baiti"/>
+        <a:font script="Tibt" typeface="Microsoft Himalaya"/>
+        <a:font script="Thaa" typeface="MV Boli"/>
+        <a:font script="Deva" typeface="Mangal"/>
+        <a:font script="Telu" typeface="Gautami"/>
+        <a:font script="Taml" typeface="Latha"/>
+        <a:font script="Syrc" typeface="Estrangelo Edessa"/>
+        <a:font script="Orya" typeface="Kalinga"/>
+        <a:font script="Mlym" typeface="Kartika"/>
+        <a:font script="Laoo" typeface="DokChampa"/>
+        <a:font script="Sinh" typeface="Iskoola Pota"/>
+        <a:font script="Mong" typeface="Mongolian Baiti"/>
+        <a:font script="Viet" typeface="Times New Roman"/>
+        <a:font script="Uigh" typeface="Microsoft Uighur"/>
+        <a:font script="Geor" typeface="Sylfaen"/>
+        <a:font script="Armn" typeface="Arial"/>
+        <a:font script="Bugi" typeface="Leelawadee UI"/>
+        <a:font script="Bopo" typeface="Microsoft JhengHei"/>
+        <a:font script="Java" typeface="Javanese Text"/>
+        <a:font script="Lisu" typeface="Segoe UI"/>
+        <a:font script="Mymr" typeface="Myanmar Text"/>
+        <a:font script="Nkoo" typeface="Ebrima"/>
+        <a:font script="Olck" typeface="Nirmala UI"/>
+        <a:font script="Osma" typeface="Ebrima"/>
+        <a:font script="Phag" typeface="Phagspa"/>
+        <a:font script="Syrn" typeface="Estrangelo Edessa"/>
+        <a:font script="Syrj" typeface="Estrangelo Edessa"/>
+        <a:font script="Syre" typeface="Estrangelo Edessa"/>
+        <a:font script="Sora" typeface="Nirmala UI"/>
+        <a:font script="Tale" typeface="Microsoft Tai Le"/>
+        <a:font script="Talu" typeface="Microsoft New Tai Lue"/>
+        <a:font script="Tfng" typeface="Ebrima"/>
+      </a:majorFont>
+      <a:minorFont>
+        <a:latin typeface="Aptos" panose="02110004020202020204"/>
+        <a:ea typeface=""/>
+        <a:cs typeface=""/>
+        <a:font script="Jpan" typeface="游ゴシック"/>
+        <a:font script="Hang" typeface="맑은 고딕"/>
+        <a:font script="Hans" typeface="等线"/>
+        <a:font script="Hant" typeface="新細明體"/>
+        <a:font script="Arab" typeface="Arial"/>
+        <a:font script="Hebr" typeface="Arial"/>
+        <a:font script="Thai" typeface="Cordia New"/>
+        <a:font script="Ethi" typeface="Nyala"/>
+        <a:font script="Beng" typeface="Vrinda"/>
+        <a:font script="Gujr" typeface="Shruti"/>
+        <a:font script="Khmr" typeface="DaunPenh"/>
+        <a:font script="Knda" typeface="Tunga"/>
+        <a:font script="Guru" typeface="Raavi"/>
+        <a:font script="Cans" typeface="Euphemia"/>
+        <a:font script="Cher" typeface="Plantagenet Cherokee"/>
+        <a:font script="Yiii" typeface="Microsoft Yi Baiti"/>
+        <a:font script="Tibt" typeface="Microsoft Himalaya"/>
+        <a:font script="Thaa" typeface="MV Boli"/>
+        <a:font script="Deva" typeface="Mangal"/>
+        <a:font script="Telu" typeface="Gautami"/>
+        <a:font script="Taml" typeface="Latha"/>
+        <a:font script="Syrc" typeface="Estrangelo Edessa"/>
+        <a:font script="Orya" typeface="Kalinga"/>
+        <a:font script="Mlym" typeface="Kartika"/>
+        <a:font script="Laoo" typeface="DokChampa"/>
+        <a:font script="Sinh" typeface="Iskoola Pota"/>
+        <a:font script="Mong" typeface="Mongolian Baiti"/>
+        <a:font script="Viet" typeface="Arial"/>
+        <a:font script="Uigh" typeface="Microsoft Uighur"/>
+        <a:font script="Geor" typeface="Sylfaen"/>
+        <a:font script="Armn" typeface="Arial"/>
+        <a:font script="Bugi" typeface="Leelawadee UI"/>
+        <a:font script="Bopo" typeface="Microsoft JhengHei"/>
+        <a:font script="Java" typeface="Javanese Text"/>
+        <a:font script="Lisu" typeface="Segoe UI"/>
+        <a:font script="Mymr" typeface="Myanmar Text"/>
+        <a:font script="Nkoo" typeface="Ebrima"/>
+        <a:font script="Olck" typeface="Nirmala UI"/>
+        <a:font script="Osma" typeface="Ebrima"/>
+        <a:font script="Phag" typeface="Phagspa"/>
+        <a:font script="Syrn" typeface="Estrangelo Edessa"/>
+        <a:font script="Syrj" typeface="Estrangelo Edessa"/>
+        <a:font script="Syre" typeface="Estrangelo Edessa"/>
+        <a:font script="Sora" typeface="Nirmala UI"/>
+        <a:font script="Tale" typeface="Microsoft Tai Le"/>
+        <a:font script="Talu" typeface="Microsoft New Tai Lue"/>
+        <a:font script="Tfng" typeface="Ebrima"/>
+      </a:minorFont>
+    </a:fontScheme>
+    <a:fmtScheme name="Office">
+      <a:fillStyleLst>
+        <a:solidFill>
+          <a:schemeClr val="phClr"/>
+        </a:solidFill>
+        <a:gradFill rotWithShape="1">
+          <a:gsLst>
+            <a:gs pos="0">
+              <a:schemeClr val="phClr">
+                <a:lumMod val="110000"/>
+                <a:satMod val="105000"/>
+                <a:tint val="67000"/>
+              </a:schemeClr>
+            </a:gs>
+            <a:gs pos="50000">
+              <a:schemeClr val="phClr">
+                <a:lumMod val="105000"/>
+                <a:satMod val="103000"/>
+                <a:tint val="73000"/>
+              </a:schemeClr>
+            </a:gs>
+            <a:gs pos="100000">
+              <a:schemeClr val="phClr">
+                <a:lumMod val="105000"/>
+                <a:satMod val="109000"/>
+                <a:tint val="81000"/>
+              </a:schemeClr>
+            </a:gs>
+          </a:gsLst>
+          <a:lin ang="5400000" scaled="0"/>
+        </a:gradFill>
+        <a:gradFill rotWithShape="1">
+          <a:gsLst>
+            <a:gs pos="0">
+              <a:schemeClr val="phClr">
+                <a:satMod val="103000"/>
+                <a:lumMod val="102000"/>
+                <a:tint val="94000"/>
+              </a:schemeClr>
+            </a:gs>
+            <a:gs pos="50000">
+              <a:schemeClr val="phClr">
+                <a:satMod val="110000"/>
+                <a:lumMod val="100000"/>
+                <a:shade val="100000"/>
+              </a:schemeClr>
+            </a:gs>
+            <a:gs pos="100000">
+              <a:schemeClr val="phClr">
+                <a:lumMod val="99000"/>
+                <a:satMod val="120000"/>
+                <a:shade val="78000"/>
+              </a:schemeClr>
+            </a:gs>
+          </a:gsLst>
+          <a:lin ang="5400000" scaled="0"/>
+        </a:gradFill>
+      </a:fillStyleLst>
+      <a:lnStyleLst>
+        <a:ln w="12700" cap="flat" cmpd="sng" algn="ctr">
+          <a:solidFill>
+            <a:schemeClr val="phClr"/>
+          </a:solidFill>
+          <a:prstDash val="solid"/>
+          <a:miter lim="800000"/>
+        </a:ln>
+        <a:ln w="19050" cap="flat" cmpd="sng" algn="ctr">
+          <a:solidFill>
+            <a:schemeClr val="phClr"/>
+          </a:solidFill>
+          <a:prstDash val="solid"/>
+          <a:miter lim="800000"/>
+        </a:ln>
+        <a:ln w="25400" cap="flat" cmpd="sng" algn="ctr">
+          <a:solidFill>
+            <a:schemeClr val="phClr"/>
+          </a:solidFill>
+          <a:prstDash val="solid"/>
+          <a:miter lim="800000"/>
+        </a:ln>
+      </a:lnStyleLst>
+      <a:effectStyleLst>
+        <a:effectStyle>
+          <a:effectLst/>
+        </a:effectStyle>
+        <a:effectStyle>
+          <a:effectLst/>
+        </a:effectStyle>
+        <a:effectStyle>
+          <a:effectLst>
+            <a:outerShdw blurRad="57150" dist="19050" dir="5400000" algn="ctr" rotWithShape="0">
+              <a:srgbClr val="000000">
+                <a:alpha val="63000"/>
+              </a:srgbClr>
+            </a:outerShdw>
+          </a:effectLst>
+        </a:effectStyle>
+      </a:effectStyleLst>
+      <a:bgFillStyleLst>
+        <a:solidFill>
+          <a:schemeClr val="phClr"/>
+        </a:solidFill>
+        <a:solidFill>
+          <a:schemeClr val="phClr">
+            <a:tint val="95000"/>
+            <a:satMod val="170000"/>
+          </a:schemeClr>
+        </a:solidFill>
+        <a:gradFill rotWithShape="1">
+          <a:gsLst>
+            <a:gs pos="0">
+              <a:schemeClr val="phClr">
+                <a:tint val="93000"/>
+                <a:satMod val="150000"/>
+                <a:shade val="98000"/>
+                <a:lumMod val="102000"/>
+              </a:schemeClr>
+            </a:gs>
+            <a:gs pos="50000">
+              <a:schemeClr val="phClr">
+                <a:tint val="98000"/>
+                <a:satMod val="130000"/>
+                <a:shade val="90000"/>
+                <a:lumMod val="103000"/>
+              </a:schemeClr>
+            </a:gs>
+            <a:gs pos="100000">
+              <a:schemeClr val="phClr">
+                <a:shade val="63000"/>
+                <a:satMod val="120000"/>
+              </a:schemeClr>
+            </a:gs>
+          </a:gsLst>
+          <a:lin ang="5400000" scaled="0"/>
+        </a:gradFill>
+      </a:bgFillStyleLst>
+    </a:fmtScheme>
+  </a:themeElements>
+  <a:objectDefaults>
+    <a:lnDef>
+      <a:spPr/>
+      <a:bodyPr/>
+      <a:lstStyle/>
+      <a:style>
+        <a:lnRef idx="2">
+          <a:schemeClr val="accent1"/>
+        </a:lnRef>
+        <a:fillRef idx="0">
+          <a:schemeClr val="accent1"/>
+        </a:fillRef>
+        <a:effectRef idx="1">
+          <a:schemeClr val="accent1"/>
+        </a:effectRef>
+        <a:fontRef idx="minor">
+          <a:schemeClr val="tx1"/>
+        </a:fontRef>
+      </a:style>
+    </a:lnDef>
+  </a:objectDefaults>
+  <a:extraClrSchemeLst/>
+  <a:extLst>
+    <a:ext uri="{05A4C25C-085E-4340-85A3-A5531E510DB2}">
+      <thm15:themeFamily xmlns:thm15="http://schemas.microsoft.com/office/thememl/2012/main" name="Office Theme" id="{2E142A2C-CD16-42D6-873A-C26D2A0506FA}" vid="{1BDDFF52-6CD6-40A5-AB3C-68EB2F1E4D0A}"/>
+    </a:ext>
+  </a:extLst>
+</a:theme>
 </file>
</xml_diff>

<commit_message>
docs: update soutenance docs + add demo scripts and captures
Mise à jour des fiches soutenance (aide-mémoire, cheatsheet, briefing,
révision express, guide captures plan B) et ajout de la procédure démo
live, captures POC, et scripts de démonstration/tunnels RDP.

Co-Authored-By: Claude Opus 4.6 <noreply@anthropic.com>
</commit_message>
<xml_diff>
--- a/docs/05-soutenance/MSPR_NordTransit_Presentation.pptx
+++ b/docs/05-soutenance/MSPR_NordTransit_Presentation.pptx
@@ -129,7 +129,7 @@
 <file path=ppt/charts/chart1.xml><?xml version="1.0" encoding="utf-8"?>
 <c:chartSpace xmlns:c="http://schemas.openxmlformats.org/drawingml/2006/chart" xmlns:a="http://schemas.openxmlformats.org/drawingml/2006/main" xmlns:r="http://schemas.openxmlformats.org/officeDocument/2006/relationships" xmlns:c16r2="http://schemas.microsoft.com/office/drawing/2015/06/chart">
   <c:date1904 val="0"/>
-  <c:lang val="en-US"/>
+  <c:lang val="fr-FR"/>
   <c:roundedCorners val="1"/>
   <c:style val="2"/>
   <c:chart>
@@ -690,7 +690,7 @@
           <a:p>
             <a:fld id="{5B93C933-9933-4C31-BE6D-F5666E68E0FD}" type="slidenum">
               <a:rPr lang="fr-FR" smtClean="0"/>
-              <a:t>‹#›</a:t>
+              <a:t>‹N°›</a:t>
             </a:fld>
             <a:endParaRPr lang="fr-FR"/>
           </a:p>
@@ -1611,7 +1611,7 @@
           <a:p>
             <a:fld id="{4945FB95-144E-49FD-B7E5-5AC832B9F648}" type="slidenum">
               <a:rPr lang="fr-FR" smtClean="0"/>
-              <a:t>‹#›</a:t>
+              <a:t>‹N°›</a:t>
             </a:fld>
             <a:endParaRPr lang="fr-FR"/>
           </a:p>
@@ -1688,7 +1688,7 @@
           <a:p>
             <a:fld id="{4945FB95-144E-49FD-B7E5-5AC832B9F648}" type="slidenum">
               <a:rPr lang="fr-FR" smtClean="0"/>
-              <a:t>‹#›</a:t>
+              <a:t>‹N°›</a:t>
             </a:fld>
             <a:endParaRPr lang="fr-FR"/>
           </a:p>

</xml_diff>